<commit_message>
feat: integrate bootstrap + emergency sensitivity into manuscripts and PPTX
Japanese manuscript (manuscript_strobe.docx):
- Methods: added bootstrap methodology (stratified, BCa) + emergency sensitivity description
- Results: Table 5 (emergency sensitivity), Table 6 (bootstrap), Fig. 8 (bootstrap comparison)
- Discussion: emergency effect modifier + bootstrap robustness findings

English manuscript (manuscript_strobe_en.docx):
- Same additions in English

PPTX (figures_strobe.pptx):
- Slide 8: Bootstrap comparison table (editable shapes)

Total: 8 figures, 6 tables, STROBE checklist in both manuscripts
Co-Authored-By: Tatsuki Onishi <bougtoir@gmail.com>
</commit_message>
<xml_diff>
--- a/yago_ionv/figures_strobe.pptx
+++ b/yago_ionv/figures_strobe.pptx
@@ -12,6 +12,7 @@
     <p:sldId id="260" r:id="rId11"/>
     <p:sldId id="261" r:id="rId12"/>
     <p:sldId id="262" r:id="rId13"/>
+    <p:sldId id="263" r:id="rId14"/>
   </p:sldIdLst>
   <p:sldSz cx="12191695" cy="6858000" type="screen4x3"/>
   <p:notesSz cx="6858000" cy="9144000"/>
@@ -10814,6 +10815,2904 @@
 </p:sld>
 </file>
 
+<file path=ppt/slides/slide8.xml><?xml version="1.0" encoding="utf-8"?>
+<p:sld xmlns:a="http://schemas.openxmlformats.org/drawingml/2006/main" xmlns:p="http://schemas.openxmlformats.org/presentationml/2006/main" xmlns:r="http://schemas.openxmlformats.org/officeDocument/2006/relationships">
+  <p:cSld>
+    <p:spTree>
+      <p:nvGrpSpPr>
+        <p:cNvPr id="1" name=""/>
+        <p:cNvGrpSpPr/>
+        <p:nvPr/>
+      </p:nvGrpSpPr>
+      <p:grpSpPr/>
+      <p:sp>
+        <p:nvSpPr>
+          <p:cNvPr id="2" name="TextBox 1"/>
+          <p:cNvSpPr txBox="1"/>
+          <p:nvPr/>
+        </p:nvSpPr>
+        <p:spPr>
+          <a:xfrm>
+            <a:off x="274320" y="137160"/>
+            <a:ext cx="11612880" cy="457200"/>
+          </a:xfrm>
+          <a:prstGeom prst="rect">
+            <a:avLst/>
+          </a:prstGeom>
+          <a:noFill/>
+        </p:spPr>
+        <p:txBody>
+          <a:bodyPr wrap="square">
+            <a:spAutoFit/>
+          </a:bodyPr>
+          <a:lstStyle/>
+          <a:p>
+            <a:pPr algn="ctr">
+              <a:defRPr sz="2000" b="1">
+                <a:solidFill>
+                  <a:srgbClr val="1A237E"/>
+                </a:solidFill>
+              </a:defRPr>
+            </a:pPr>
+            <a:r>
+              <a:t>Figure 8. Wald vs Bootstrap Confidence Interval Comparison</a:t>
+            </a:r>
+          </a:p>
+        </p:txBody>
+      </p:sp>
+      <p:sp>
+        <p:nvSpPr>
+          <p:cNvPr id="3" name="TextBox 2"/>
+          <p:cNvSpPr txBox="1"/>
+          <p:nvPr/>
+        </p:nvSpPr>
+        <p:spPr>
+          <a:xfrm>
+            <a:off x="457200" y="6217920"/>
+            <a:ext cx="11277295" cy="548640"/>
+          </a:xfrm>
+          <a:prstGeom prst="rect">
+            <a:avLst/>
+          </a:prstGeom>
+          <a:noFill/>
+        </p:spPr>
+        <p:txBody>
+          <a:bodyPr wrap="square">
+            <a:spAutoFit/>
+          </a:bodyPr>
+          <a:lstStyle/>
+          <a:p>
+            <a:pPr algn="ctr">
+              <a:defRPr sz="1000" i="1"/>
+            </a:pPr>
+            <a:r>
+              <a:t>Stratified bootstrap (10,000 resamples) validation of Wald-based CIs. BCa CI for narrow primary (full cohort) excludes 1, confirming robust twin effect.</a:t>
+            </a:r>
+          </a:p>
+        </p:txBody>
+      </p:sp>
+      <p:sp>
+        <p:nvSpPr>
+          <p:cNvPr id="4" name="Rectangle 3"/>
+          <p:cNvSpPr/>
+          <p:nvPr/>
+        </p:nvSpPr>
+        <p:spPr>
+          <a:xfrm>
+            <a:off x="1371600" y="914400"/>
+            <a:ext cx="1371600" cy="411480"/>
+          </a:xfrm>
+          <a:prstGeom prst="rect">
+            <a:avLst/>
+          </a:prstGeom>
+          <a:solidFill>
+            <a:srgbClr val="1A237E"/>
+          </a:solidFill>
+          <a:ln>
+            <a:solidFill>
+              <a:srgbClr val="FFFFFF"/>
+            </a:solidFill>
+          </a:ln>
+        </p:spPr>
+        <p:style>
+          <a:lnRef idx="1">
+            <a:schemeClr val="accent1"/>
+          </a:lnRef>
+          <a:fillRef idx="3">
+            <a:schemeClr val="accent1"/>
+          </a:fillRef>
+          <a:effectRef idx="2">
+            <a:schemeClr val="accent1"/>
+          </a:effectRef>
+          <a:fontRef idx="minor">
+            <a:schemeClr val="lt1"/>
+          </a:fontRef>
+        </p:style>
+        <p:txBody>
+          <a:bodyPr rtlCol="0" anchor="ctr" wrap="square"/>
+          <a:lstStyle/>
+          <a:p>
+            <a:pPr algn="ctr"/>
+            <a:r>
+              <a:rPr sz="1000" b="1">
+                <a:solidFill>
+                  <a:srgbClr val="FFFFFF"/>
+                </a:solidFill>
+              </a:rPr>
+              <a:t>Cohort</a:t>
+            </a:r>
+          </a:p>
+        </p:txBody>
+      </p:sp>
+      <p:sp>
+        <p:nvSpPr>
+          <p:cNvPr id="5" name="Rectangle 4"/>
+          <p:cNvSpPr/>
+          <p:nvPr/>
+        </p:nvSpPr>
+        <p:spPr>
+          <a:xfrm>
+            <a:off x="2743200" y="914400"/>
+            <a:ext cx="1828800" cy="411480"/>
+          </a:xfrm>
+          <a:prstGeom prst="rect">
+            <a:avLst/>
+          </a:prstGeom>
+          <a:solidFill>
+            <a:srgbClr val="1A237E"/>
+          </a:solidFill>
+          <a:ln>
+            <a:solidFill>
+              <a:srgbClr val="FFFFFF"/>
+            </a:solidFill>
+          </a:ln>
+        </p:spPr>
+        <p:style>
+          <a:lnRef idx="1">
+            <a:schemeClr val="accent1"/>
+          </a:lnRef>
+          <a:fillRef idx="3">
+            <a:schemeClr val="accent1"/>
+          </a:fillRef>
+          <a:effectRef idx="2">
+            <a:schemeClr val="accent1"/>
+          </a:effectRef>
+          <a:fontRef idx="minor">
+            <a:schemeClr val="lt1"/>
+          </a:fontRef>
+        </p:style>
+        <p:txBody>
+          <a:bodyPr rtlCol="0" anchor="ctr" wrap="square"/>
+          <a:lstStyle/>
+          <a:p>
+            <a:pPr algn="ctr"/>
+            <a:r>
+              <a:rPr sz="1000" b="1">
+                <a:solidFill>
+                  <a:srgbClr val="FFFFFF"/>
+                </a:solidFill>
+              </a:rPr>
+              <a:t>Outcome</a:t>
+            </a:r>
+          </a:p>
+        </p:txBody>
+      </p:sp>
+      <p:sp>
+        <p:nvSpPr>
+          <p:cNvPr id="6" name="Rectangle 5"/>
+          <p:cNvSpPr/>
+          <p:nvPr/>
+        </p:nvSpPr>
+        <p:spPr>
+          <a:xfrm>
+            <a:off x="4572000" y="914400"/>
+            <a:ext cx="914400" cy="411480"/>
+          </a:xfrm>
+          <a:prstGeom prst="rect">
+            <a:avLst/>
+          </a:prstGeom>
+          <a:solidFill>
+            <a:srgbClr val="1A237E"/>
+          </a:solidFill>
+          <a:ln>
+            <a:solidFill>
+              <a:srgbClr val="FFFFFF"/>
+            </a:solidFill>
+          </a:ln>
+        </p:spPr>
+        <p:style>
+          <a:lnRef idx="1">
+            <a:schemeClr val="accent1"/>
+          </a:lnRef>
+          <a:fillRef idx="3">
+            <a:schemeClr val="accent1"/>
+          </a:fillRef>
+          <a:effectRef idx="2">
+            <a:schemeClr val="accent1"/>
+          </a:effectRef>
+          <a:fontRef idx="minor">
+            <a:schemeClr val="lt1"/>
+          </a:fontRef>
+        </p:style>
+        <p:txBody>
+          <a:bodyPr rtlCol="0" anchor="ctr" wrap="square"/>
+          <a:lstStyle/>
+          <a:p>
+            <a:pPr algn="ctr"/>
+            <a:r>
+              <a:rPr sz="1000" b="1">
+                <a:solidFill>
+                  <a:srgbClr val="FFFFFF"/>
+                </a:solidFill>
+              </a:rPr>
+              <a:t>aOR</a:t>
+            </a:r>
+          </a:p>
+        </p:txBody>
+      </p:sp>
+      <p:sp>
+        <p:nvSpPr>
+          <p:cNvPr id="7" name="Rectangle 6"/>
+          <p:cNvSpPr/>
+          <p:nvPr/>
+        </p:nvSpPr>
+        <p:spPr>
+          <a:xfrm>
+            <a:off x="5486400" y="914400"/>
+            <a:ext cx="2011680" cy="411480"/>
+          </a:xfrm>
+          <a:prstGeom prst="rect">
+            <a:avLst/>
+          </a:prstGeom>
+          <a:solidFill>
+            <a:srgbClr val="1A237E"/>
+          </a:solidFill>
+          <a:ln>
+            <a:solidFill>
+              <a:srgbClr val="FFFFFF"/>
+            </a:solidFill>
+          </a:ln>
+        </p:spPr>
+        <p:style>
+          <a:lnRef idx="1">
+            <a:schemeClr val="accent1"/>
+          </a:lnRef>
+          <a:fillRef idx="3">
+            <a:schemeClr val="accent1"/>
+          </a:fillRef>
+          <a:effectRef idx="2">
+            <a:schemeClr val="accent1"/>
+          </a:effectRef>
+          <a:fontRef idx="minor">
+            <a:schemeClr val="lt1"/>
+          </a:fontRef>
+        </p:style>
+        <p:txBody>
+          <a:bodyPr rtlCol="0" anchor="ctr" wrap="square"/>
+          <a:lstStyle/>
+          <a:p>
+            <a:pPr algn="ctr"/>
+            <a:r>
+              <a:rPr sz="1000" b="1">
+                <a:solidFill>
+                  <a:srgbClr val="FFFFFF"/>
+                </a:solidFill>
+              </a:rPr>
+              <a:t>Wald 95% CI</a:t>
+            </a:r>
+          </a:p>
+        </p:txBody>
+      </p:sp>
+      <p:sp>
+        <p:nvSpPr>
+          <p:cNvPr id="8" name="Rectangle 7"/>
+          <p:cNvSpPr/>
+          <p:nvPr/>
+        </p:nvSpPr>
+        <p:spPr>
+          <a:xfrm>
+            <a:off x="7498080" y="914400"/>
+            <a:ext cx="2011680" cy="411480"/>
+          </a:xfrm>
+          <a:prstGeom prst="rect">
+            <a:avLst/>
+          </a:prstGeom>
+          <a:solidFill>
+            <a:srgbClr val="1A237E"/>
+          </a:solidFill>
+          <a:ln>
+            <a:solidFill>
+              <a:srgbClr val="FFFFFF"/>
+            </a:solidFill>
+          </a:ln>
+        </p:spPr>
+        <p:style>
+          <a:lnRef idx="1">
+            <a:schemeClr val="accent1"/>
+          </a:lnRef>
+          <a:fillRef idx="3">
+            <a:schemeClr val="accent1"/>
+          </a:fillRef>
+          <a:effectRef idx="2">
+            <a:schemeClr val="accent1"/>
+          </a:effectRef>
+          <a:fontRef idx="minor">
+            <a:schemeClr val="lt1"/>
+          </a:fontRef>
+        </p:style>
+        <p:txBody>
+          <a:bodyPr rtlCol="0" anchor="ctr" wrap="square"/>
+          <a:lstStyle/>
+          <a:p>
+            <a:pPr algn="ctr"/>
+            <a:r>
+              <a:rPr sz="1000" b="1">
+                <a:solidFill>
+                  <a:srgbClr val="FFFFFF"/>
+                </a:solidFill>
+              </a:rPr>
+              <a:t>BCa 95% CI</a:t>
+            </a:r>
+          </a:p>
+        </p:txBody>
+      </p:sp>
+      <p:sp>
+        <p:nvSpPr>
+          <p:cNvPr id="9" name="Rectangle 8"/>
+          <p:cNvSpPr/>
+          <p:nvPr/>
+        </p:nvSpPr>
+        <p:spPr>
+          <a:xfrm>
+            <a:off x="9509760" y="914400"/>
+            <a:ext cx="914400" cy="411480"/>
+          </a:xfrm>
+          <a:prstGeom prst="rect">
+            <a:avLst/>
+          </a:prstGeom>
+          <a:solidFill>
+            <a:srgbClr val="1A237E"/>
+          </a:solidFill>
+          <a:ln>
+            <a:solidFill>
+              <a:srgbClr val="FFFFFF"/>
+            </a:solidFill>
+          </a:ln>
+        </p:spPr>
+        <p:style>
+          <a:lnRef idx="1">
+            <a:schemeClr val="accent1"/>
+          </a:lnRef>
+          <a:fillRef idx="3">
+            <a:schemeClr val="accent1"/>
+          </a:fillRef>
+          <a:effectRef idx="2">
+            <a:schemeClr val="accent1"/>
+          </a:effectRef>
+          <a:fontRef idx="minor">
+            <a:schemeClr val="lt1"/>
+          </a:fontRef>
+        </p:style>
+        <p:txBody>
+          <a:bodyPr rtlCol="0" anchor="ctr" wrap="square"/>
+          <a:lstStyle/>
+          <a:p>
+            <a:pPr algn="ctr"/>
+            <a:r>
+              <a:rPr sz="1000" b="1">
+                <a:solidFill>
+                  <a:srgbClr val="FFFFFF"/>
+                </a:solidFill>
+              </a:rPr>
+              <a:t>Conv.</a:t>
+            </a:r>
+          </a:p>
+        </p:txBody>
+      </p:sp>
+      <p:sp>
+        <p:nvSpPr>
+          <p:cNvPr id="10" name="Rectangle 9"/>
+          <p:cNvSpPr/>
+          <p:nvPr/>
+        </p:nvSpPr>
+        <p:spPr>
+          <a:xfrm>
+            <a:off x="1371600" y="1325880"/>
+            <a:ext cx="1371600" cy="411480"/>
+          </a:xfrm>
+          <a:prstGeom prst="rect">
+            <a:avLst/>
+          </a:prstGeom>
+          <a:solidFill>
+            <a:srgbClr val="F5F5F5"/>
+          </a:solidFill>
+          <a:ln w="6350">
+            <a:solidFill>
+              <a:srgbClr val="CCCCCC"/>
+            </a:solidFill>
+          </a:ln>
+        </p:spPr>
+        <p:style>
+          <a:lnRef idx="1">
+            <a:schemeClr val="accent1"/>
+          </a:lnRef>
+          <a:fillRef idx="3">
+            <a:schemeClr val="accent1"/>
+          </a:fillRef>
+          <a:effectRef idx="2">
+            <a:schemeClr val="accent1"/>
+          </a:effectRef>
+          <a:fontRef idx="minor">
+            <a:schemeClr val="lt1"/>
+          </a:fontRef>
+        </p:style>
+        <p:txBody>
+          <a:bodyPr rtlCol="0" anchor="ctr" wrap="square"/>
+          <a:lstStyle/>
+          <a:p>
+            <a:pPr algn="ctr"/>
+            <a:r>
+              <a:rPr sz="900">
+                <a:solidFill>
+                  <a:srgbClr val="000000"/>
+                </a:solidFill>
+              </a:rPr>
+              <a:t>Full cohort</a:t>
+            </a:r>
+          </a:p>
+        </p:txBody>
+      </p:sp>
+      <p:sp>
+        <p:nvSpPr>
+          <p:cNvPr id="11" name="Rectangle 10"/>
+          <p:cNvSpPr/>
+          <p:nvPr/>
+        </p:nvSpPr>
+        <p:spPr>
+          <a:xfrm>
+            <a:off x="2743200" y="1325880"/>
+            <a:ext cx="1828800" cy="411480"/>
+          </a:xfrm>
+          <a:prstGeom prst="rect">
+            <a:avLst/>
+          </a:prstGeom>
+          <a:solidFill>
+            <a:srgbClr val="F5F5F5"/>
+          </a:solidFill>
+          <a:ln w="6350">
+            <a:solidFill>
+              <a:srgbClr val="CCCCCC"/>
+            </a:solidFill>
+          </a:ln>
+        </p:spPr>
+        <p:style>
+          <a:lnRef idx="1">
+            <a:schemeClr val="accent1"/>
+          </a:lnRef>
+          <a:fillRef idx="3">
+            <a:schemeClr val="accent1"/>
+          </a:fillRef>
+          <a:effectRef idx="2">
+            <a:schemeClr val="accent1"/>
+          </a:effectRef>
+          <a:fontRef idx="minor">
+            <a:schemeClr val="lt1"/>
+          </a:fontRef>
+        </p:style>
+        <p:txBody>
+          <a:bodyPr rtlCol="0" anchor="ctr" wrap="square"/>
+          <a:lstStyle/>
+          <a:p>
+            <a:pPr algn="ctr"/>
+            <a:r>
+              <a:rPr sz="900">
+                <a:solidFill>
+                  <a:srgbClr val="000000"/>
+                </a:solidFill>
+              </a:rPr>
+              <a:t>Broad, Primary</a:t>
+            </a:r>
+          </a:p>
+        </p:txBody>
+      </p:sp>
+      <p:sp>
+        <p:nvSpPr>
+          <p:cNvPr id="12" name="Rectangle 11"/>
+          <p:cNvSpPr/>
+          <p:nvPr/>
+        </p:nvSpPr>
+        <p:spPr>
+          <a:xfrm>
+            <a:off x="4572000" y="1325880"/>
+            <a:ext cx="914400" cy="411480"/>
+          </a:xfrm>
+          <a:prstGeom prst="rect">
+            <a:avLst/>
+          </a:prstGeom>
+          <a:solidFill>
+            <a:srgbClr val="F5F5F5"/>
+          </a:solidFill>
+          <a:ln w="6350">
+            <a:solidFill>
+              <a:srgbClr val="CCCCCC"/>
+            </a:solidFill>
+          </a:ln>
+        </p:spPr>
+        <p:style>
+          <a:lnRef idx="1">
+            <a:schemeClr val="accent1"/>
+          </a:lnRef>
+          <a:fillRef idx="3">
+            <a:schemeClr val="accent1"/>
+          </a:fillRef>
+          <a:effectRef idx="2">
+            <a:schemeClr val="accent1"/>
+          </a:effectRef>
+          <a:fontRef idx="minor">
+            <a:schemeClr val="lt1"/>
+          </a:fontRef>
+        </p:style>
+        <p:txBody>
+          <a:bodyPr rtlCol="0" anchor="ctr" wrap="square"/>
+          <a:lstStyle/>
+          <a:p>
+            <a:pPr algn="ctr"/>
+            <a:r>
+              <a:rPr sz="900">
+                <a:solidFill>
+                  <a:srgbClr val="000000"/>
+                </a:solidFill>
+              </a:rPr>
+              <a:t>0.92</a:t>
+            </a:r>
+          </a:p>
+        </p:txBody>
+      </p:sp>
+      <p:sp>
+        <p:nvSpPr>
+          <p:cNvPr id="13" name="Rectangle 12"/>
+          <p:cNvSpPr/>
+          <p:nvPr/>
+        </p:nvSpPr>
+        <p:spPr>
+          <a:xfrm>
+            <a:off x="5486400" y="1325880"/>
+            <a:ext cx="2011680" cy="411480"/>
+          </a:xfrm>
+          <a:prstGeom prst="rect">
+            <a:avLst/>
+          </a:prstGeom>
+          <a:solidFill>
+            <a:srgbClr val="F5F5F5"/>
+          </a:solidFill>
+          <a:ln w="6350">
+            <a:solidFill>
+              <a:srgbClr val="CCCCCC"/>
+            </a:solidFill>
+          </a:ln>
+        </p:spPr>
+        <p:style>
+          <a:lnRef idx="1">
+            <a:schemeClr val="accent1"/>
+          </a:lnRef>
+          <a:fillRef idx="3">
+            <a:schemeClr val="accent1"/>
+          </a:fillRef>
+          <a:effectRef idx="2">
+            <a:schemeClr val="accent1"/>
+          </a:effectRef>
+          <a:fontRef idx="minor">
+            <a:schemeClr val="lt1"/>
+          </a:fontRef>
+        </p:style>
+        <p:txBody>
+          <a:bodyPr rtlCol="0" anchor="ctr" wrap="square"/>
+          <a:lstStyle/>
+          <a:p>
+            <a:pPr algn="ctr"/>
+            <a:r>
+              <a:rPr sz="900">
+                <a:solidFill>
+                  <a:srgbClr val="000000"/>
+                </a:solidFill>
+              </a:rPr>
+              <a:t>0.67–1.27</a:t>
+            </a:r>
+          </a:p>
+        </p:txBody>
+      </p:sp>
+      <p:sp>
+        <p:nvSpPr>
+          <p:cNvPr id="14" name="Rectangle 13"/>
+          <p:cNvSpPr/>
+          <p:nvPr/>
+        </p:nvSpPr>
+        <p:spPr>
+          <a:xfrm>
+            <a:off x="7498080" y="1325880"/>
+            <a:ext cx="2011680" cy="411480"/>
+          </a:xfrm>
+          <a:prstGeom prst="rect">
+            <a:avLst/>
+          </a:prstGeom>
+          <a:solidFill>
+            <a:srgbClr val="F5F5F5"/>
+          </a:solidFill>
+          <a:ln w="6350">
+            <a:solidFill>
+              <a:srgbClr val="CCCCCC"/>
+            </a:solidFill>
+          </a:ln>
+        </p:spPr>
+        <p:style>
+          <a:lnRef idx="1">
+            <a:schemeClr val="accent1"/>
+          </a:lnRef>
+          <a:fillRef idx="3">
+            <a:schemeClr val="accent1"/>
+          </a:fillRef>
+          <a:effectRef idx="2">
+            <a:schemeClr val="accent1"/>
+          </a:effectRef>
+          <a:fontRef idx="minor">
+            <a:schemeClr val="lt1"/>
+          </a:fontRef>
+        </p:style>
+        <p:txBody>
+          <a:bodyPr rtlCol="0" anchor="ctr" wrap="square"/>
+          <a:lstStyle/>
+          <a:p>
+            <a:pPr algn="ctr"/>
+            <a:r>
+              <a:rPr sz="900">
+                <a:solidFill>
+                  <a:srgbClr val="000000"/>
+                </a:solidFill>
+              </a:rPr>
+              <a:t>0.68–1.26</a:t>
+            </a:r>
+          </a:p>
+        </p:txBody>
+      </p:sp>
+      <p:sp>
+        <p:nvSpPr>
+          <p:cNvPr id="15" name="Rectangle 14"/>
+          <p:cNvSpPr/>
+          <p:nvPr/>
+        </p:nvSpPr>
+        <p:spPr>
+          <a:xfrm>
+            <a:off x="9509760" y="1325880"/>
+            <a:ext cx="914400" cy="411480"/>
+          </a:xfrm>
+          <a:prstGeom prst="rect">
+            <a:avLst/>
+          </a:prstGeom>
+          <a:solidFill>
+            <a:srgbClr val="F5F5F5"/>
+          </a:solidFill>
+          <a:ln w="6350">
+            <a:solidFill>
+              <a:srgbClr val="CCCCCC"/>
+            </a:solidFill>
+          </a:ln>
+        </p:spPr>
+        <p:style>
+          <a:lnRef idx="1">
+            <a:schemeClr val="accent1"/>
+          </a:lnRef>
+          <a:fillRef idx="3">
+            <a:schemeClr val="accent1"/>
+          </a:fillRef>
+          <a:effectRef idx="2">
+            <a:schemeClr val="accent1"/>
+          </a:effectRef>
+          <a:fontRef idx="minor">
+            <a:schemeClr val="lt1"/>
+          </a:fontRef>
+        </p:style>
+        <p:txBody>
+          <a:bodyPr rtlCol="0" anchor="ctr" wrap="square"/>
+          <a:lstStyle/>
+          <a:p>
+            <a:pPr algn="ctr"/>
+            <a:r>
+              <a:rPr sz="900">
+                <a:solidFill>
+                  <a:srgbClr val="000000"/>
+                </a:solidFill>
+              </a:rPr>
+              <a:t>100.0%</a:t>
+            </a:r>
+          </a:p>
+        </p:txBody>
+      </p:sp>
+      <p:sp>
+        <p:nvSpPr>
+          <p:cNvPr id="16" name="Rectangle 15"/>
+          <p:cNvSpPr/>
+          <p:nvPr/>
+        </p:nvSpPr>
+        <p:spPr>
+          <a:xfrm>
+            <a:off x="1371600" y="1737360"/>
+            <a:ext cx="1371600" cy="411480"/>
+          </a:xfrm>
+          <a:prstGeom prst="rect">
+            <a:avLst/>
+          </a:prstGeom>
+          <a:solidFill>
+            <a:srgbClr val="FFFFFF"/>
+          </a:solidFill>
+          <a:ln w="6350">
+            <a:solidFill>
+              <a:srgbClr val="CCCCCC"/>
+            </a:solidFill>
+          </a:ln>
+        </p:spPr>
+        <p:style>
+          <a:lnRef idx="1">
+            <a:schemeClr val="accent1"/>
+          </a:lnRef>
+          <a:fillRef idx="3">
+            <a:schemeClr val="accent1"/>
+          </a:fillRef>
+          <a:effectRef idx="2">
+            <a:schemeClr val="accent1"/>
+          </a:effectRef>
+          <a:fontRef idx="minor">
+            <a:schemeClr val="lt1"/>
+          </a:fontRef>
+        </p:style>
+        <p:txBody>
+          <a:bodyPr rtlCol="0" anchor="ctr" wrap="square"/>
+          <a:lstStyle/>
+          <a:p>
+            <a:pPr algn="ctr"/>
+          </a:p>
+        </p:txBody>
+      </p:sp>
+      <p:sp>
+        <p:nvSpPr>
+          <p:cNvPr id="17" name="Rectangle 16"/>
+          <p:cNvSpPr/>
+          <p:nvPr/>
+        </p:nvSpPr>
+        <p:spPr>
+          <a:xfrm>
+            <a:off x="2743200" y="1737360"/>
+            <a:ext cx="1828800" cy="411480"/>
+          </a:xfrm>
+          <a:prstGeom prst="rect">
+            <a:avLst/>
+          </a:prstGeom>
+          <a:solidFill>
+            <a:srgbClr val="FFFFFF"/>
+          </a:solidFill>
+          <a:ln w="6350">
+            <a:solidFill>
+              <a:srgbClr val="CCCCCC"/>
+            </a:solidFill>
+          </a:ln>
+        </p:spPr>
+        <p:style>
+          <a:lnRef idx="1">
+            <a:schemeClr val="accent1"/>
+          </a:lnRef>
+          <a:fillRef idx="3">
+            <a:schemeClr val="accent1"/>
+          </a:fillRef>
+          <a:effectRef idx="2">
+            <a:schemeClr val="accent1"/>
+          </a:effectRef>
+          <a:fontRef idx="minor">
+            <a:schemeClr val="lt1"/>
+          </a:fontRef>
+        </p:style>
+        <p:txBody>
+          <a:bodyPr rtlCol="0" anchor="ctr" wrap="square"/>
+          <a:lstStyle/>
+          <a:p>
+            <a:pPr algn="ctr"/>
+            <a:r>
+              <a:rPr sz="900">
+                <a:solidFill>
+                  <a:srgbClr val="000000"/>
+                </a:solidFill>
+              </a:rPr>
+              <a:t>Broad, Secondary</a:t>
+            </a:r>
+          </a:p>
+        </p:txBody>
+      </p:sp>
+      <p:sp>
+        <p:nvSpPr>
+          <p:cNvPr id="18" name="Rectangle 17"/>
+          <p:cNvSpPr/>
+          <p:nvPr/>
+        </p:nvSpPr>
+        <p:spPr>
+          <a:xfrm>
+            <a:off x="4572000" y="1737360"/>
+            <a:ext cx="914400" cy="411480"/>
+          </a:xfrm>
+          <a:prstGeom prst="rect">
+            <a:avLst/>
+          </a:prstGeom>
+          <a:solidFill>
+            <a:srgbClr val="FFFFFF"/>
+          </a:solidFill>
+          <a:ln w="6350">
+            <a:solidFill>
+              <a:srgbClr val="CCCCCC"/>
+            </a:solidFill>
+          </a:ln>
+        </p:spPr>
+        <p:style>
+          <a:lnRef idx="1">
+            <a:schemeClr val="accent1"/>
+          </a:lnRef>
+          <a:fillRef idx="3">
+            <a:schemeClr val="accent1"/>
+          </a:fillRef>
+          <a:effectRef idx="2">
+            <a:schemeClr val="accent1"/>
+          </a:effectRef>
+          <a:fontRef idx="minor">
+            <a:schemeClr val="lt1"/>
+          </a:fontRef>
+        </p:style>
+        <p:txBody>
+          <a:bodyPr rtlCol="0" anchor="ctr" wrap="square"/>
+          <a:lstStyle/>
+          <a:p>
+            <a:pPr algn="ctr"/>
+            <a:r>
+              <a:rPr sz="900">
+                <a:solidFill>
+                  <a:srgbClr val="000000"/>
+                </a:solidFill>
+              </a:rPr>
+              <a:t>0.82</a:t>
+            </a:r>
+          </a:p>
+        </p:txBody>
+      </p:sp>
+      <p:sp>
+        <p:nvSpPr>
+          <p:cNvPr id="19" name="Rectangle 18"/>
+          <p:cNvSpPr/>
+          <p:nvPr/>
+        </p:nvSpPr>
+        <p:spPr>
+          <a:xfrm>
+            <a:off x="5486400" y="1737360"/>
+            <a:ext cx="2011680" cy="411480"/>
+          </a:xfrm>
+          <a:prstGeom prst="rect">
+            <a:avLst/>
+          </a:prstGeom>
+          <a:solidFill>
+            <a:srgbClr val="FFFFFF"/>
+          </a:solidFill>
+          <a:ln w="6350">
+            <a:solidFill>
+              <a:srgbClr val="CCCCCC"/>
+            </a:solidFill>
+          </a:ln>
+        </p:spPr>
+        <p:style>
+          <a:lnRef idx="1">
+            <a:schemeClr val="accent1"/>
+          </a:lnRef>
+          <a:fillRef idx="3">
+            <a:schemeClr val="accent1"/>
+          </a:fillRef>
+          <a:effectRef idx="2">
+            <a:schemeClr val="accent1"/>
+          </a:effectRef>
+          <a:fontRef idx="minor">
+            <a:schemeClr val="lt1"/>
+          </a:fontRef>
+        </p:style>
+        <p:txBody>
+          <a:bodyPr rtlCol="0" anchor="ctr" wrap="square"/>
+          <a:lstStyle/>
+          <a:p>
+            <a:pPr algn="ctr"/>
+            <a:r>
+              <a:rPr sz="900">
+                <a:solidFill>
+                  <a:srgbClr val="000000"/>
+                </a:solidFill>
+              </a:rPr>
+              <a:t>0.31–2.15</a:t>
+            </a:r>
+          </a:p>
+        </p:txBody>
+      </p:sp>
+      <p:sp>
+        <p:nvSpPr>
+          <p:cNvPr id="20" name="Rectangle 19"/>
+          <p:cNvSpPr/>
+          <p:nvPr/>
+        </p:nvSpPr>
+        <p:spPr>
+          <a:xfrm>
+            <a:off x="7498080" y="1737360"/>
+            <a:ext cx="2011680" cy="411480"/>
+          </a:xfrm>
+          <a:prstGeom prst="rect">
+            <a:avLst/>
+          </a:prstGeom>
+          <a:solidFill>
+            <a:srgbClr val="FFFFFF"/>
+          </a:solidFill>
+          <a:ln w="6350">
+            <a:solidFill>
+              <a:srgbClr val="CCCCCC"/>
+            </a:solidFill>
+          </a:ln>
+        </p:spPr>
+        <p:style>
+          <a:lnRef idx="1">
+            <a:schemeClr val="accent1"/>
+          </a:lnRef>
+          <a:fillRef idx="3">
+            <a:schemeClr val="accent1"/>
+          </a:fillRef>
+          <a:effectRef idx="2">
+            <a:schemeClr val="accent1"/>
+          </a:effectRef>
+          <a:fontRef idx="minor">
+            <a:schemeClr val="lt1"/>
+          </a:fontRef>
+        </p:style>
+        <p:txBody>
+          <a:bodyPr rtlCol="0" anchor="ctr" wrap="square"/>
+          <a:lstStyle/>
+          <a:p>
+            <a:pPr algn="ctr"/>
+            <a:r>
+              <a:rPr sz="900">
+                <a:solidFill>
+                  <a:srgbClr val="000000"/>
+                </a:solidFill>
+              </a:rPr>
+              <a:t>0.30–2.29</a:t>
+            </a:r>
+          </a:p>
+        </p:txBody>
+      </p:sp>
+      <p:sp>
+        <p:nvSpPr>
+          <p:cNvPr id="21" name="Rectangle 20"/>
+          <p:cNvSpPr/>
+          <p:nvPr/>
+        </p:nvSpPr>
+        <p:spPr>
+          <a:xfrm>
+            <a:off x="9509760" y="1737360"/>
+            <a:ext cx="914400" cy="411480"/>
+          </a:xfrm>
+          <a:prstGeom prst="rect">
+            <a:avLst/>
+          </a:prstGeom>
+          <a:solidFill>
+            <a:srgbClr val="FFFFFF"/>
+          </a:solidFill>
+          <a:ln w="6350">
+            <a:solidFill>
+              <a:srgbClr val="CCCCCC"/>
+            </a:solidFill>
+          </a:ln>
+        </p:spPr>
+        <p:style>
+          <a:lnRef idx="1">
+            <a:schemeClr val="accent1"/>
+          </a:lnRef>
+          <a:fillRef idx="3">
+            <a:schemeClr val="accent1"/>
+          </a:fillRef>
+          <a:effectRef idx="2">
+            <a:schemeClr val="accent1"/>
+          </a:effectRef>
+          <a:fontRef idx="minor">
+            <a:schemeClr val="lt1"/>
+          </a:fontRef>
+        </p:style>
+        <p:txBody>
+          <a:bodyPr rtlCol="0" anchor="ctr" wrap="square"/>
+          <a:lstStyle/>
+          <a:p>
+            <a:pPr algn="ctr"/>
+            <a:r>
+              <a:rPr sz="900">
+                <a:solidFill>
+                  <a:srgbClr val="000000"/>
+                </a:solidFill>
+              </a:rPr>
+              <a:t>100.0%</a:t>
+            </a:r>
+          </a:p>
+        </p:txBody>
+      </p:sp>
+      <p:sp>
+        <p:nvSpPr>
+          <p:cNvPr id="22" name="Rectangle 21"/>
+          <p:cNvSpPr/>
+          <p:nvPr/>
+        </p:nvSpPr>
+        <p:spPr>
+          <a:xfrm>
+            <a:off x="1371600" y="2148840"/>
+            <a:ext cx="1371600" cy="411480"/>
+          </a:xfrm>
+          <a:prstGeom prst="rect">
+            <a:avLst/>
+          </a:prstGeom>
+          <a:solidFill>
+            <a:srgbClr val="E8F5E9"/>
+          </a:solidFill>
+          <a:ln w="6350">
+            <a:solidFill>
+              <a:srgbClr val="CCCCCC"/>
+            </a:solidFill>
+          </a:ln>
+        </p:spPr>
+        <p:style>
+          <a:lnRef idx="1">
+            <a:schemeClr val="accent1"/>
+          </a:lnRef>
+          <a:fillRef idx="3">
+            <a:schemeClr val="accent1"/>
+          </a:fillRef>
+          <a:effectRef idx="2">
+            <a:schemeClr val="accent1"/>
+          </a:effectRef>
+          <a:fontRef idx="minor">
+            <a:schemeClr val="lt1"/>
+          </a:fontRef>
+        </p:style>
+        <p:txBody>
+          <a:bodyPr rtlCol="0" anchor="ctr" wrap="square"/>
+          <a:lstStyle/>
+          <a:p>
+            <a:pPr algn="ctr"/>
+          </a:p>
+        </p:txBody>
+      </p:sp>
+      <p:sp>
+        <p:nvSpPr>
+          <p:cNvPr id="23" name="Rectangle 22"/>
+          <p:cNvSpPr/>
+          <p:nvPr/>
+        </p:nvSpPr>
+        <p:spPr>
+          <a:xfrm>
+            <a:off x="2743200" y="2148840"/>
+            <a:ext cx="1828800" cy="411480"/>
+          </a:xfrm>
+          <a:prstGeom prst="rect">
+            <a:avLst/>
+          </a:prstGeom>
+          <a:solidFill>
+            <a:srgbClr val="E8F5E9"/>
+          </a:solidFill>
+          <a:ln w="6350">
+            <a:solidFill>
+              <a:srgbClr val="CCCCCC"/>
+            </a:solidFill>
+          </a:ln>
+        </p:spPr>
+        <p:style>
+          <a:lnRef idx="1">
+            <a:schemeClr val="accent1"/>
+          </a:lnRef>
+          <a:fillRef idx="3">
+            <a:schemeClr val="accent1"/>
+          </a:fillRef>
+          <a:effectRef idx="2">
+            <a:schemeClr val="accent1"/>
+          </a:effectRef>
+          <a:fontRef idx="minor">
+            <a:schemeClr val="lt1"/>
+          </a:fontRef>
+        </p:style>
+        <p:txBody>
+          <a:bodyPr rtlCol="0" anchor="ctr" wrap="square"/>
+          <a:lstStyle/>
+          <a:p>
+            <a:pPr algn="ctr"/>
+            <a:r>
+              <a:rPr sz="900" b="1">
+                <a:solidFill>
+                  <a:srgbClr val="000000"/>
+                </a:solidFill>
+              </a:rPr>
+              <a:t>Narrow, Primary</a:t>
+            </a:r>
+          </a:p>
+        </p:txBody>
+      </p:sp>
+      <p:sp>
+        <p:nvSpPr>
+          <p:cNvPr id="24" name="Rectangle 23"/>
+          <p:cNvSpPr/>
+          <p:nvPr/>
+        </p:nvSpPr>
+        <p:spPr>
+          <a:xfrm>
+            <a:off x="4572000" y="2148840"/>
+            <a:ext cx="914400" cy="411480"/>
+          </a:xfrm>
+          <a:prstGeom prst="rect">
+            <a:avLst/>
+          </a:prstGeom>
+          <a:solidFill>
+            <a:srgbClr val="E8F5E9"/>
+          </a:solidFill>
+          <a:ln w="6350">
+            <a:solidFill>
+              <a:srgbClr val="CCCCCC"/>
+            </a:solidFill>
+          </a:ln>
+        </p:spPr>
+        <p:style>
+          <a:lnRef idx="1">
+            <a:schemeClr val="accent1"/>
+          </a:lnRef>
+          <a:fillRef idx="3">
+            <a:schemeClr val="accent1"/>
+          </a:fillRef>
+          <a:effectRef idx="2">
+            <a:schemeClr val="accent1"/>
+          </a:effectRef>
+          <a:fontRef idx="minor">
+            <a:schemeClr val="lt1"/>
+          </a:fontRef>
+        </p:style>
+        <p:txBody>
+          <a:bodyPr rtlCol="0" anchor="ctr" wrap="square"/>
+          <a:lstStyle/>
+          <a:p>
+            <a:pPr algn="ctr"/>
+            <a:r>
+              <a:rPr sz="900" b="1">
+                <a:solidFill>
+                  <a:srgbClr val="000000"/>
+                </a:solidFill>
+              </a:rPr>
+              <a:t>3.18</a:t>
+            </a:r>
+          </a:p>
+        </p:txBody>
+      </p:sp>
+      <p:sp>
+        <p:nvSpPr>
+          <p:cNvPr id="25" name="Rectangle 24"/>
+          <p:cNvSpPr/>
+          <p:nvPr/>
+        </p:nvSpPr>
+        <p:spPr>
+          <a:xfrm>
+            <a:off x="5486400" y="2148840"/>
+            <a:ext cx="2011680" cy="411480"/>
+          </a:xfrm>
+          <a:prstGeom prst="rect">
+            <a:avLst/>
+          </a:prstGeom>
+          <a:solidFill>
+            <a:srgbClr val="E8F5E9"/>
+          </a:solidFill>
+          <a:ln w="6350">
+            <a:solidFill>
+              <a:srgbClr val="CCCCCC"/>
+            </a:solidFill>
+          </a:ln>
+        </p:spPr>
+        <p:style>
+          <a:lnRef idx="1">
+            <a:schemeClr val="accent1"/>
+          </a:lnRef>
+          <a:fillRef idx="3">
+            <a:schemeClr val="accent1"/>
+          </a:fillRef>
+          <a:effectRef idx="2">
+            <a:schemeClr val="accent1"/>
+          </a:effectRef>
+          <a:fontRef idx="minor">
+            <a:schemeClr val="lt1"/>
+          </a:fontRef>
+        </p:style>
+        <p:txBody>
+          <a:bodyPr rtlCol="0" anchor="ctr" wrap="square"/>
+          <a:lstStyle/>
+          <a:p>
+            <a:pPr algn="ctr"/>
+            <a:r>
+              <a:rPr sz="900" b="1">
+                <a:solidFill>
+                  <a:srgbClr val="000000"/>
+                </a:solidFill>
+              </a:rPr>
+              <a:t>1.38–7.36</a:t>
+            </a:r>
+          </a:p>
+        </p:txBody>
+      </p:sp>
+      <p:sp>
+        <p:nvSpPr>
+          <p:cNvPr id="26" name="Rectangle 25"/>
+          <p:cNvSpPr/>
+          <p:nvPr/>
+        </p:nvSpPr>
+        <p:spPr>
+          <a:xfrm>
+            <a:off x="7498080" y="2148840"/>
+            <a:ext cx="2011680" cy="411480"/>
+          </a:xfrm>
+          <a:prstGeom prst="rect">
+            <a:avLst/>
+          </a:prstGeom>
+          <a:solidFill>
+            <a:srgbClr val="E8F5E9"/>
+          </a:solidFill>
+          <a:ln w="6350">
+            <a:solidFill>
+              <a:srgbClr val="CCCCCC"/>
+            </a:solidFill>
+          </a:ln>
+        </p:spPr>
+        <p:style>
+          <a:lnRef idx="1">
+            <a:schemeClr val="accent1"/>
+          </a:lnRef>
+          <a:fillRef idx="3">
+            <a:schemeClr val="accent1"/>
+          </a:fillRef>
+          <a:effectRef idx="2">
+            <a:schemeClr val="accent1"/>
+          </a:effectRef>
+          <a:fontRef idx="minor">
+            <a:schemeClr val="lt1"/>
+          </a:fontRef>
+        </p:style>
+        <p:txBody>
+          <a:bodyPr rtlCol="0" anchor="ctr" wrap="square"/>
+          <a:lstStyle/>
+          <a:p>
+            <a:pPr algn="ctr"/>
+            <a:r>
+              <a:rPr sz="900" b="1">
+                <a:solidFill>
+                  <a:srgbClr val="000000"/>
+                </a:solidFill>
+              </a:rPr>
+              <a:t>1.23–7.01</a:t>
+            </a:r>
+          </a:p>
+        </p:txBody>
+      </p:sp>
+      <p:sp>
+        <p:nvSpPr>
+          <p:cNvPr id="27" name="Rectangle 26"/>
+          <p:cNvSpPr/>
+          <p:nvPr/>
+        </p:nvSpPr>
+        <p:spPr>
+          <a:xfrm>
+            <a:off x="9509760" y="2148840"/>
+            <a:ext cx="914400" cy="411480"/>
+          </a:xfrm>
+          <a:prstGeom prst="rect">
+            <a:avLst/>
+          </a:prstGeom>
+          <a:solidFill>
+            <a:srgbClr val="E8F5E9"/>
+          </a:solidFill>
+          <a:ln w="6350">
+            <a:solidFill>
+              <a:srgbClr val="CCCCCC"/>
+            </a:solidFill>
+          </a:ln>
+        </p:spPr>
+        <p:style>
+          <a:lnRef idx="1">
+            <a:schemeClr val="accent1"/>
+          </a:lnRef>
+          <a:fillRef idx="3">
+            <a:schemeClr val="accent1"/>
+          </a:fillRef>
+          <a:effectRef idx="2">
+            <a:schemeClr val="accent1"/>
+          </a:effectRef>
+          <a:fontRef idx="minor">
+            <a:schemeClr val="lt1"/>
+          </a:fontRef>
+        </p:style>
+        <p:txBody>
+          <a:bodyPr rtlCol="0" anchor="ctr" wrap="square"/>
+          <a:lstStyle/>
+          <a:p>
+            <a:pPr algn="ctr"/>
+            <a:r>
+              <a:rPr sz="900" b="1">
+                <a:solidFill>
+                  <a:srgbClr val="000000"/>
+                </a:solidFill>
+              </a:rPr>
+              <a:t>100.0%</a:t>
+            </a:r>
+          </a:p>
+        </p:txBody>
+      </p:sp>
+      <p:sp>
+        <p:nvSpPr>
+          <p:cNvPr id="28" name="Rectangle 27"/>
+          <p:cNvSpPr/>
+          <p:nvPr/>
+        </p:nvSpPr>
+        <p:spPr>
+          <a:xfrm>
+            <a:off x="1371600" y="2560320"/>
+            <a:ext cx="1371600" cy="411480"/>
+          </a:xfrm>
+          <a:prstGeom prst="rect">
+            <a:avLst/>
+          </a:prstGeom>
+          <a:solidFill>
+            <a:srgbClr val="FFFFFF"/>
+          </a:solidFill>
+          <a:ln w="6350">
+            <a:solidFill>
+              <a:srgbClr val="CCCCCC"/>
+            </a:solidFill>
+          </a:ln>
+        </p:spPr>
+        <p:style>
+          <a:lnRef idx="1">
+            <a:schemeClr val="accent1"/>
+          </a:lnRef>
+          <a:fillRef idx="3">
+            <a:schemeClr val="accent1"/>
+          </a:fillRef>
+          <a:effectRef idx="2">
+            <a:schemeClr val="accent1"/>
+          </a:effectRef>
+          <a:fontRef idx="minor">
+            <a:schemeClr val="lt1"/>
+          </a:fontRef>
+        </p:style>
+        <p:txBody>
+          <a:bodyPr rtlCol="0" anchor="ctr" wrap="square"/>
+          <a:lstStyle/>
+          <a:p>
+            <a:pPr algn="ctr"/>
+          </a:p>
+        </p:txBody>
+      </p:sp>
+      <p:sp>
+        <p:nvSpPr>
+          <p:cNvPr id="29" name="Rectangle 28"/>
+          <p:cNvSpPr/>
+          <p:nvPr/>
+        </p:nvSpPr>
+        <p:spPr>
+          <a:xfrm>
+            <a:off x="2743200" y="2560320"/>
+            <a:ext cx="1828800" cy="411480"/>
+          </a:xfrm>
+          <a:prstGeom prst="rect">
+            <a:avLst/>
+          </a:prstGeom>
+          <a:solidFill>
+            <a:srgbClr val="FFFFFF"/>
+          </a:solidFill>
+          <a:ln w="6350">
+            <a:solidFill>
+              <a:srgbClr val="CCCCCC"/>
+            </a:solidFill>
+          </a:ln>
+        </p:spPr>
+        <p:style>
+          <a:lnRef idx="1">
+            <a:schemeClr val="accent1"/>
+          </a:lnRef>
+          <a:fillRef idx="3">
+            <a:schemeClr val="accent1"/>
+          </a:fillRef>
+          <a:effectRef idx="2">
+            <a:schemeClr val="accent1"/>
+          </a:effectRef>
+          <a:fontRef idx="minor">
+            <a:schemeClr val="lt1"/>
+          </a:fontRef>
+        </p:style>
+        <p:txBody>
+          <a:bodyPr rtlCol="0" anchor="ctr" wrap="square"/>
+          <a:lstStyle/>
+          <a:p>
+            <a:pPr algn="ctr"/>
+            <a:r>
+              <a:rPr sz="900">
+                <a:solidFill>
+                  <a:srgbClr val="000000"/>
+                </a:solidFill>
+              </a:rPr>
+              <a:t>Narrow, Secondary</a:t>
+            </a:r>
+          </a:p>
+        </p:txBody>
+      </p:sp>
+      <p:sp>
+        <p:nvSpPr>
+          <p:cNvPr id="30" name="Rectangle 29"/>
+          <p:cNvSpPr/>
+          <p:nvPr/>
+        </p:nvSpPr>
+        <p:spPr>
+          <a:xfrm>
+            <a:off x="4572000" y="2560320"/>
+            <a:ext cx="914400" cy="411480"/>
+          </a:xfrm>
+          <a:prstGeom prst="rect">
+            <a:avLst/>
+          </a:prstGeom>
+          <a:solidFill>
+            <a:srgbClr val="FFFFFF"/>
+          </a:solidFill>
+          <a:ln w="6350">
+            <a:solidFill>
+              <a:srgbClr val="CCCCCC"/>
+            </a:solidFill>
+          </a:ln>
+        </p:spPr>
+        <p:style>
+          <a:lnRef idx="1">
+            <a:schemeClr val="accent1"/>
+          </a:lnRef>
+          <a:fillRef idx="3">
+            <a:schemeClr val="accent1"/>
+          </a:fillRef>
+          <a:effectRef idx="2">
+            <a:schemeClr val="accent1"/>
+          </a:effectRef>
+          <a:fontRef idx="minor">
+            <a:schemeClr val="lt1"/>
+          </a:fontRef>
+        </p:style>
+        <p:txBody>
+          <a:bodyPr rtlCol="0" anchor="ctr" wrap="square"/>
+          <a:lstStyle/>
+          <a:p>
+            <a:pPr algn="ctr"/>
+            <a:r>
+              <a:rPr sz="900">
+                <a:solidFill>
+                  <a:srgbClr val="000000"/>
+                </a:solidFill>
+              </a:rPr>
+              <a:t>3.48</a:t>
+            </a:r>
+          </a:p>
+        </p:txBody>
+      </p:sp>
+      <p:sp>
+        <p:nvSpPr>
+          <p:cNvPr id="31" name="Rectangle 30"/>
+          <p:cNvSpPr/>
+          <p:nvPr/>
+        </p:nvSpPr>
+        <p:spPr>
+          <a:xfrm>
+            <a:off x="5486400" y="2560320"/>
+            <a:ext cx="2011680" cy="411480"/>
+          </a:xfrm>
+          <a:prstGeom prst="rect">
+            <a:avLst/>
+          </a:prstGeom>
+          <a:solidFill>
+            <a:srgbClr val="FFFFFF"/>
+          </a:solidFill>
+          <a:ln w="6350">
+            <a:solidFill>
+              <a:srgbClr val="CCCCCC"/>
+            </a:solidFill>
+          </a:ln>
+        </p:spPr>
+        <p:style>
+          <a:lnRef idx="1">
+            <a:schemeClr val="accent1"/>
+          </a:lnRef>
+          <a:fillRef idx="3">
+            <a:schemeClr val="accent1"/>
+          </a:fillRef>
+          <a:effectRef idx="2">
+            <a:schemeClr val="accent1"/>
+          </a:effectRef>
+          <a:fontRef idx="minor">
+            <a:schemeClr val="lt1"/>
+          </a:fontRef>
+        </p:style>
+        <p:txBody>
+          <a:bodyPr rtlCol="0" anchor="ctr" wrap="square"/>
+          <a:lstStyle/>
+          <a:p>
+            <a:pPr algn="ctr"/>
+            <a:r>
+              <a:rPr sz="900">
+                <a:solidFill>
+                  <a:srgbClr val="000000"/>
+                </a:solidFill>
+              </a:rPr>
+              <a:t>0.81–15.06</a:t>
+            </a:r>
+          </a:p>
+        </p:txBody>
+      </p:sp>
+      <p:sp>
+        <p:nvSpPr>
+          <p:cNvPr id="32" name="Rectangle 31"/>
+          <p:cNvSpPr/>
+          <p:nvPr/>
+        </p:nvSpPr>
+        <p:spPr>
+          <a:xfrm>
+            <a:off x="7498080" y="2560320"/>
+            <a:ext cx="2011680" cy="411480"/>
+          </a:xfrm>
+          <a:prstGeom prst="rect">
+            <a:avLst/>
+          </a:prstGeom>
+          <a:solidFill>
+            <a:srgbClr val="FFFFFF"/>
+          </a:solidFill>
+          <a:ln w="6350">
+            <a:solidFill>
+              <a:srgbClr val="CCCCCC"/>
+            </a:solidFill>
+          </a:ln>
+        </p:spPr>
+        <p:style>
+          <a:lnRef idx="1">
+            <a:schemeClr val="accent1"/>
+          </a:lnRef>
+          <a:fillRef idx="3">
+            <a:schemeClr val="accent1"/>
+          </a:fillRef>
+          <a:effectRef idx="2">
+            <a:schemeClr val="accent1"/>
+          </a:effectRef>
+          <a:fontRef idx="minor">
+            <a:schemeClr val="lt1"/>
+          </a:fontRef>
+        </p:style>
+        <p:txBody>
+          <a:bodyPr rtlCol="0" anchor="ctr" wrap="square"/>
+          <a:lstStyle/>
+          <a:p>
+            <a:pPr algn="ctr"/>
+            <a:r>
+              <a:rPr sz="900">
+                <a:solidFill>
+                  <a:srgbClr val="000000"/>
+                </a:solidFill>
+              </a:rPr>
+              <a:t>0.00–21.33</a:t>
+            </a:r>
+          </a:p>
+        </p:txBody>
+      </p:sp>
+      <p:sp>
+        <p:nvSpPr>
+          <p:cNvPr id="33" name="Rectangle 32"/>
+          <p:cNvSpPr/>
+          <p:nvPr/>
+        </p:nvSpPr>
+        <p:spPr>
+          <a:xfrm>
+            <a:off x="9509760" y="2560320"/>
+            <a:ext cx="914400" cy="411480"/>
+          </a:xfrm>
+          <a:prstGeom prst="rect">
+            <a:avLst/>
+          </a:prstGeom>
+          <a:solidFill>
+            <a:srgbClr val="FFFFFF"/>
+          </a:solidFill>
+          <a:ln w="6350">
+            <a:solidFill>
+              <a:srgbClr val="CCCCCC"/>
+            </a:solidFill>
+          </a:ln>
+        </p:spPr>
+        <p:style>
+          <a:lnRef idx="1">
+            <a:schemeClr val="accent1"/>
+          </a:lnRef>
+          <a:fillRef idx="3">
+            <a:schemeClr val="accent1"/>
+          </a:fillRef>
+          <a:effectRef idx="2">
+            <a:schemeClr val="accent1"/>
+          </a:effectRef>
+          <a:fontRef idx="minor">
+            <a:schemeClr val="lt1"/>
+          </a:fontRef>
+        </p:style>
+        <p:txBody>
+          <a:bodyPr rtlCol="0" anchor="ctr" wrap="square"/>
+          <a:lstStyle/>
+          <a:p>
+            <a:pPr algn="ctr"/>
+            <a:r>
+              <a:rPr sz="900">
+                <a:solidFill>
+                  <a:srgbClr val="000000"/>
+                </a:solidFill>
+              </a:rPr>
+              <a:t>99.8%</a:t>
+            </a:r>
+          </a:p>
+        </p:txBody>
+      </p:sp>
+      <p:sp>
+        <p:nvSpPr>
+          <p:cNvPr id="34" name="Rectangle 33"/>
+          <p:cNvSpPr/>
+          <p:nvPr/>
+        </p:nvSpPr>
+        <p:spPr>
+          <a:xfrm>
+            <a:off x="1371600" y="2971800"/>
+            <a:ext cx="1371600" cy="411480"/>
+          </a:xfrm>
+          <a:prstGeom prst="rect">
+            <a:avLst/>
+          </a:prstGeom>
+          <a:solidFill>
+            <a:srgbClr val="F5F5F5"/>
+          </a:solidFill>
+          <a:ln w="6350">
+            <a:solidFill>
+              <a:srgbClr val="CCCCCC"/>
+            </a:solidFill>
+          </a:ln>
+        </p:spPr>
+        <p:style>
+          <a:lnRef idx="1">
+            <a:schemeClr val="accent1"/>
+          </a:lnRef>
+          <a:fillRef idx="3">
+            <a:schemeClr val="accent1"/>
+          </a:fillRef>
+          <a:effectRef idx="2">
+            <a:schemeClr val="accent1"/>
+          </a:effectRef>
+          <a:fontRef idx="minor">
+            <a:schemeClr val="lt1"/>
+          </a:fontRef>
+        </p:style>
+        <p:txBody>
+          <a:bodyPr rtlCol="0" anchor="ctr" wrap="square"/>
+          <a:lstStyle/>
+          <a:p>
+            <a:pPr algn="ctr"/>
+            <a:r>
+              <a:rPr sz="900">
+                <a:solidFill>
+                  <a:srgbClr val="000000"/>
+                </a:solidFill>
+              </a:rPr>
+              <a:t>Low-risk</a:t>
+            </a:r>
+          </a:p>
+        </p:txBody>
+      </p:sp>
+      <p:sp>
+        <p:nvSpPr>
+          <p:cNvPr id="35" name="Rectangle 34"/>
+          <p:cNvSpPr/>
+          <p:nvPr/>
+        </p:nvSpPr>
+        <p:spPr>
+          <a:xfrm>
+            <a:off x="2743200" y="2971800"/>
+            <a:ext cx="1828800" cy="411480"/>
+          </a:xfrm>
+          <a:prstGeom prst="rect">
+            <a:avLst/>
+          </a:prstGeom>
+          <a:solidFill>
+            <a:srgbClr val="F5F5F5"/>
+          </a:solidFill>
+          <a:ln w="6350">
+            <a:solidFill>
+              <a:srgbClr val="CCCCCC"/>
+            </a:solidFill>
+          </a:ln>
+        </p:spPr>
+        <p:style>
+          <a:lnRef idx="1">
+            <a:schemeClr val="accent1"/>
+          </a:lnRef>
+          <a:fillRef idx="3">
+            <a:schemeClr val="accent1"/>
+          </a:fillRef>
+          <a:effectRef idx="2">
+            <a:schemeClr val="accent1"/>
+          </a:effectRef>
+          <a:fontRef idx="minor">
+            <a:schemeClr val="lt1"/>
+          </a:fontRef>
+        </p:style>
+        <p:txBody>
+          <a:bodyPr rtlCol="0" anchor="ctr" wrap="square"/>
+          <a:lstStyle/>
+          <a:p>
+            <a:pPr algn="ctr"/>
+            <a:r>
+              <a:rPr sz="900">
+                <a:solidFill>
+                  <a:srgbClr val="000000"/>
+                </a:solidFill>
+              </a:rPr>
+              <a:t>Broad, Primary</a:t>
+            </a:r>
+          </a:p>
+        </p:txBody>
+      </p:sp>
+      <p:sp>
+        <p:nvSpPr>
+          <p:cNvPr id="36" name="Rectangle 35"/>
+          <p:cNvSpPr/>
+          <p:nvPr/>
+        </p:nvSpPr>
+        <p:spPr>
+          <a:xfrm>
+            <a:off x="4572000" y="2971800"/>
+            <a:ext cx="914400" cy="411480"/>
+          </a:xfrm>
+          <a:prstGeom prst="rect">
+            <a:avLst/>
+          </a:prstGeom>
+          <a:solidFill>
+            <a:srgbClr val="F5F5F5"/>
+          </a:solidFill>
+          <a:ln w="6350">
+            <a:solidFill>
+              <a:srgbClr val="CCCCCC"/>
+            </a:solidFill>
+          </a:ln>
+        </p:spPr>
+        <p:style>
+          <a:lnRef idx="1">
+            <a:schemeClr val="accent1"/>
+          </a:lnRef>
+          <a:fillRef idx="3">
+            <a:schemeClr val="accent1"/>
+          </a:fillRef>
+          <a:effectRef idx="2">
+            <a:schemeClr val="accent1"/>
+          </a:effectRef>
+          <a:fontRef idx="minor">
+            <a:schemeClr val="lt1"/>
+          </a:fontRef>
+        </p:style>
+        <p:txBody>
+          <a:bodyPr rtlCol="0" anchor="ctr" wrap="square"/>
+          <a:lstStyle/>
+          <a:p>
+            <a:pPr algn="ctr"/>
+            <a:r>
+              <a:rPr sz="900">
+                <a:solidFill>
+                  <a:srgbClr val="000000"/>
+                </a:solidFill>
+              </a:rPr>
+              <a:t>0.65</a:t>
+            </a:r>
+          </a:p>
+        </p:txBody>
+      </p:sp>
+      <p:sp>
+        <p:nvSpPr>
+          <p:cNvPr id="37" name="Rectangle 36"/>
+          <p:cNvSpPr/>
+          <p:nvPr/>
+        </p:nvSpPr>
+        <p:spPr>
+          <a:xfrm>
+            <a:off x="5486400" y="2971800"/>
+            <a:ext cx="2011680" cy="411480"/>
+          </a:xfrm>
+          <a:prstGeom prst="rect">
+            <a:avLst/>
+          </a:prstGeom>
+          <a:solidFill>
+            <a:srgbClr val="F5F5F5"/>
+          </a:solidFill>
+          <a:ln w="6350">
+            <a:solidFill>
+              <a:srgbClr val="CCCCCC"/>
+            </a:solidFill>
+          </a:ln>
+        </p:spPr>
+        <p:style>
+          <a:lnRef idx="1">
+            <a:schemeClr val="accent1"/>
+          </a:lnRef>
+          <a:fillRef idx="3">
+            <a:schemeClr val="accent1"/>
+          </a:fillRef>
+          <a:effectRef idx="2">
+            <a:schemeClr val="accent1"/>
+          </a:effectRef>
+          <a:fontRef idx="minor">
+            <a:schemeClr val="lt1"/>
+          </a:fontRef>
+        </p:style>
+        <p:txBody>
+          <a:bodyPr rtlCol="0" anchor="ctr" wrap="square"/>
+          <a:lstStyle/>
+          <a:p>
+            <a:pPr algn="ctr"/>
+            <a:r>
+              <a:rPr sz="900">
+                <a:solidFill>
+                  <a:srgbClr val="000000"/>
+                </a:solidFill>
+              </a:rPr>
+              <a:t>0.40–1.06</a:t>
+            </a:r>
+          </a:p>
+        </p:txBody>
+      </p:sp>
+      <p:sp>
+        <p:nvSpPr>
+          <p:cNvPr id="38" name="Rectangle 37"/>
+          <p:cNvSpPr/>
+          <p:nvPr/>
+        </p:nvSpPr>
+        <p:spPr>
+          <a:xfrm>
+            <a:off x="7498080" y="2971800"/>
+            <a:ext cx="2011680" cy="411480"/>
+          </a:xfrm>
+          <a:prstGeom prst="rect">
+            <a:avLst/>
+          </a:prstGeom>
+          <a:solidFill>
+            <a:srgbClr val="F5F5F5"/>
+          </a:solidFill>
+          <a:ln w="6350">
+            <a:solidFill>
+              <a:srgbClr val="CCCCCC"/>
+            </a:solidFill>
+          </a:ln>
+        </p:spPr>
+        <p:style>
+          <a:lnRef idx="1">
+            <a:schemeClr val="accent1"/>
+          </a:lnRef>
+          <a:fillRef idx="3">
+            <a:schemeClr val="accent1"/>
+          </a:fillRef>
+          <a:effectRef idx="2">
+            <a:schemeClr val="accent1"/>
+          </a:effectRef>
+          <a:fontRef idx="minor">
+            <a:schemeClr val="lt1"/>
+          </a:fontRef>
+        </p:style>
+        <p:txBody>
+          <a:bodyPr rtlCol="0" anchor="ctr" wrap="square"/>
+          <a:lstStyle/>
+          <a:p>
+            <a:pPr algn="ctr"/>
+            <a:r>
+              <a:rPr sz="900">
+                <a:solidFill>
+                  <a:srgbClr val="000000"/>
+                </a:solidFill>
+              </a:rPr>
+              <a:t>0.39–1.06</a:t>
+            </a:r>
+          </a:p>
+        </p:txBody>
+      </p:sp>
+      <p:sp>
+        <p:nvSpPr>
+          <p:cNvPr id="39" name="Rectangle 38"/>
+          <p:cNvSpPr/>
+          <p:nvPr/>
+        </p:nvSpPr>
+        <p:spPr>
+          <a:xfrm>
+            <a:off x="9509760" y="2971800"/>
+            <a:ext cx="914400" cy="411480"/>
+          </a:xfrm>
+          <a:prstGeom prst="rect">
+            <a:avLst/>
+          </a:prstGeom>
+          <a:solidFill>
+            <a:srgbClr val="F5F5F5"/>
+          </a:solidFill>
+          <a:ln w="6350">
+            <a:solidFill>
+              <a:srgbClr val="CCCCCC"/>
+            </a:solidFill>
+          </a:ln>
+        </p:spPr>
+        <p:style>
+          <a:lnRef idx="1">
+            <a:schemeClr val="accent1"/>
+          </a:lnRef>
+          <a:fillRef idx="3">
+            <a:schemeClr val="accent1"/>
+          </a:fillRef>
+          <a:effectRef idx="2">
+            <a:schemeClr val="accent1"/>
+          </a:effectRef>
+          <a:fontRef idx="minor">
+            <a:schemeClr val="lt1"/>
+          </a:fontRef>
+        </p:style>
+        <p:txBody>
+          <a:bodyPr rtlCol="0" anchor="ctr" wrap="square"/>
+          <a:lstStyle/>
+          <a:p>
+            <a:pPr algn="ctr"/>
+            <a:r>
+              <a:rPr sz="900">
+                <a:solidFill>
+                  <a:srgbClr val="000000"/>
+                </a:solidFill>
+              </a:rPr>
+              <a:t>100.0%</a:t>
+            </a:r>
+          </a:p>
+        </p:txBody>
+      </p:sp>
+      <p:sp>
+        <p:nvSpPr>
+          <p:cNvPr id="40" name="Rectangle 39"/>
+          <p:cNvSpPr/>
+          <p:nvPr/>
+        </p:nvSpPr>
+        <p:spPr>
+          <a:xfrm>
+            <a:off x="1371600" y="3383280"/>
+            <a:ext cx="1371600" cy="411480"/>
+          </a:xfrm>
+          <a:prstGeom prst="rect">
+            <a:avLst/>
+          </a:prstGeom>
+          <a:solidFill>
+            <a:srgbClr val="FFFFFF"/>
+          </a:solidFill>
+          <a:ln w="6350">
+            <a:solidFill>
+              <a:srgbClr val="CCCCCC"/>
+            </a:solidFill>
+          </a:ln>
+        </p:spPr>
+        <p:style>
+          <a:lnRef idx="1">
+            <a:schemeClr val="accent1"/>
+          </a:lnRef>
+          <a:fillRef idx="3">
+            <a:schemeClr val="accent1"/>
+          </a:fillRef>
+          <a:effectRef idx="2">
+            <a:schemeClr val="accent1"/>
+          </a:effectRef>
+          <a:fontRef idx="minor">
+            <a:schemeClr val="lt1"/>
+          </a:fontRef>
+        </p:style>
+        <p:txBody>
+          <a:bodyPr rtlCol="0" anchor="ctr" wrap="square"/>
+          <a:lstStyle/>
+          <a:p>
+            <a:pPr algn="ctr"/>
+          </a:p>
+        </p:txBody>
+      </p:sp>
+      <p:sp>
+        <p:nvSpPr>
+          <p:cNvPr id="41" name="Rectangle 40"/>
+          <p:cNvSpPr/>
+          <p:nvPr/>
+        </p:nvSpPr>
+        <p:spPr>
+          <a:xfrm>
+            <a:off x="2743200" y="3383280"/>
+            <a:ext cx="1828800" cy="411480"/>
+          </a:xfrm>
+          <a:prstGeom prst="rect">
+            <a:avLst/>
+          </a:prstGeom>
+          <a:solidFill>
+            <a:srgbClr val="FFFFFF"/>
+          </a:solidFill>
+          <a:ln w="6350">
+            <a:solidFill>
+              <a:srgbClr val="CCCCCC"/>
+            </a:solidFill>
+          </a:ln>
+        </p:spPr>
+        <p:style>
+          <a:lnRef idx="1">
+            <a:schemeClr val="accent1"/>
+          </a:lnRef>
+          <a:fillRef idx="3">
+            <a:schemeClr val="accent1"/>
+          </a:fillRef>
+          <a:effectRef idx="2">
+            <a:schemeClr val="accent1"/>
+          </a:effectRef>
+          <a:fontRef idx="minor">
+            <a:schemeClr val="lt1"/>
+          </a:fontRef>
+        </p:style>
+        <p:txBody>
+          <a:bodyPr rtlCol="0" anchor="ctr" wrap="square"/>
+          <a:lstStyle/>
+          <a:p>
+            <a:pPr algn="ctr"/>
+            <a:r>
+              <a:rPr sz="900">
+                <a:solidFill>
+                  <a:srgbClr val="000000"/>
+                </a:solidFill>
+              </a:rPr>
+              <a:t>Broad, Secondary</a:t>
+            </a:r>
+          </a:p>
+        </p:txBody>
+      </p:sp>
+      <p:sp>
+        <p:nvSpPr>
+          <p:cNvPr id="42" name="Rectangle 41"/>
+          <p:cNvSpPr/>
+          <p:nvPr/>
+        </p:nvSpPr>
+        <p:spPr>
+          <a:xfrm>
+            <a:off x="4572000" y="3383280"/>
+            <a:ext cx="914400" cy="411480"/>
+          </a:xfrm>
+          <a:prstGeom prst="rect">
+            <a:avLst/>
+          </a:prstGeom>
+          <a:solidFill>
+            <a:srgbClr val="FFFFFF"/>
+          </a:solidFill>
+          <a:ln w="6350">
+            <a:solidFill>
+              <a:srgbClr val="CCCCCC"/>
+            </a:solidFill>
+          </a:ln>
+        </p:spPr>
+        <p:style>
+          <a:lnRef idx="1">
+            <a:schemeClr val="accent1"/>
+          </a:lnRef>
+          <a:fillRef idx="3">
+            <a:schemeClr val="accent1"/>
+          </a:fillRef>
+          <a:effectRef idx="2">
+            <a:schemeClr val="accent1"/>
+          </a:effectRef>
+          <a:fontRef idx="minor">
+            <a:schemeClr val="lt1"/>
+          </a:fontRef>
+        </p:style>
+        <p:txBody>
+          <a:bodyPr rtlCol="0" anchor="ctr" wrap="square"/>
+          <a:lstStyle/>
+          <a:p>
+            <a:pPr algn="ctr"/>
+            <a:r>
+              <a:rPr sz="900">
+                <a:solidFill>
+                  <a:srgbClr val="000000"/>
+                </a:solidFill>
+              </a:rPr>
+              <a:t>0.70</a:t>
+            </a:r>
+          </a:p>
+        </p:txBody>
+      </p:sp>
+      <p:sp>
+        <p:nvSpPr>
+          <p:cNvPr id="43" name="Rectangle 42"/>
+          <p:cNvSpPr/>
+          <p:nvPr/>
+        </p:nvSpPr>
+        <p:spPr>
+          <a:xfrm>
+            <a:off x="5486400" y="3383280"/>
+            <a:ext cx="2011680" cy="411480"/>
+          </a:xfrm>
+          <a:prstGeom prst="rect">
+            <a:avLst/>
+          </a:prstGeom>
+          <a:solidFill>
+            <a:srgbClr val="FFFFFF"/>
+          </a:solidFill>
+          <a:ln w="6350">
+            <a:solidFill>
+              <a:srgbClr val="CCCCCC"/>
+            </a:solidFill>
+          </a:ln>
+        </p:spPr>
+        <p:style>
+          <a:lnRef idx="1">
+            <a:schemeClr val="accent1"/>
+          </a:lnRef>
+          <a:fillRef idx="3">
+            <a:schemeClr val="accent1"/>
+          </a:fillRef>
+          <a:effectRef idx="2">
+            <a:schemeClr val="accent1"/>
+          </a:effectRef>
+          <a:fontRef idx="minor">
+            <a:schemeClr val="lt1"/>
+          </a:fontRef>
+        </p:style>
+        <p:txBody>
+          <a:bodyPr rtlCol="0" anchor="ctr" wrap="square"/>
+          <a:lstStyle/>
+          <a:p>
+            <a:pPr algn="ctr"/>
+            <a:r>
+              <a:rPr sz="900">
+                <a:solidFill>
+                  <a:srgbClr val="000000"/>
+                </a:solidFill>
+              </a:rPr>
+              <a:t>0.22–2.26</a:t>
+            </a:r>
+          </a:p>
+        </p:txBody>
+      </p:sp>
+      <p:sp>
+        <p:nvSpPr>
+          <p:cNvPr id="44" name="Rectangle 43"/>
+          <p:cNvSpPr/>
+          <p:nvPr/>
+        </p:nvSpPr>
+        <p:spPr>
+          <a:xfrm>
+            <a:off x="7498080" y="3383280"/>
+            <a:ext cx="2011680" cy="411480"/>
+          </a:xfrm>
+          <a:prstGeom prst="rect">
+            <a:avLst/>
+          </a:prstGeom>
+          <a:solidFill>
+            <a:srgbClr val="FFFFFF"/>
+          </a:solidFill>
+          <a:ln w="6350">
+            <a:solidFill>
+              <a:srgbClr val="CCCCCC"/>
+            </a:solidFill>
+          </a:ln>
+        </p:spPr>
+        <p:style>
+          <a:lnRef idx="1">
+            <a:schemeClr val="accent1"/>
+          </a:lnRef>
+          <a:fillRef idx="3">
+            <a:schemeClr val="accent1"/>
+          </a:fillRef>
+          <a:effectRef idx="2">
+            <a:schemeClr val="accent1"/>
+          </a:effectRef>
+          <a:fontRef idx="minor">
+            <a:schemeClr val="lt1"/>
+          </a:fontRef>
+        </p:style>
+        <p:txBody>
+          <a:bodyPr rtlCol="0" anchor="ctr" wrap="square"/>
+          <a:lstStyle/>
+          <a:p>
+            <a:pPr algn="ctr"/>
+            <a:r>
+              <a:rPr sz="900">
+                <a:solidFill>
+                  <a:srgbClr val="000000"/>
+                </a:solidFill>
+              </a:rPr>
+              <a:t>0.15–2.72</a:t>
+            </a:r>
+          </a:p>
+        </p:txBody>
+      </p:sp>
+      <p:sp>
+        <p:nvSpPr>
+          <p:cNvPr id="45" name="Rectangle 44"/>
+          <p:cNvSpPr/>
+          <p:nvPr/>
+        </p:nvSpPr>
+        <p:spPr>
+          <a:xfrm>
+            <a:off x="9509760" y="3383280"/>
+            <a:ext cx="914400" cy="411480"/>
+          </a:xfrm>
+          <a:prstGeom prst="rect">
+            <a:avLst/>
+          </a:prstGeom>
+          <a:solidFill>
+            <a:srgbClr val="FFFFFF"/>
+          </a:solidFill>
+          <a:ln w="6350">
+            <a:solidFill>
+              <a:srgbClr val="CCCCCC"/>
+            </a:solidFill>
+          </a:ln>
+        </p:spPr>
+        <p:style>
+          <a:lnRef idx="1">
+            <a:schemeClr val="accent1"/>
+          </a:lnRef>
+          <a:fillRef idx="3">
+            <a:schemeClr val="accent1"/>
+          </a:fillRef>
+          <a:effectRef idx="2">
+            <a:schemeClr val="accent1"/>
+          </a:effectRef>
+          <a:fontRef idx="minor">
+            <a:schemeClr val="lt1"/>
+          </a:fontRef>
+        </p:style>
+        <p:txBody>
+          <a:bodyPr rtlCol="0" anchor="ctr" wrap="square"/>
+          <a:lstStyle/>
+          <a:p>
+            <a:pPr algn="ctr"/>
+            <a:r>
+              <a:rPr sz="900">
+                <a:solidFill>
+                  <a:srgbClr val="000000"/>
+                </a:solidFill>
+              </a:rPr>
+              <a:t>100.0%</a:t>
+            </a:r>
+          </a:p>
+        </p:txBody>
+      </p:sp>
+      <p:sp>
+        <p:nvSpPr>
+          <p:cNvPr id="46" name="Rectangle 45"/>
+          <p:cNvSpPr/>
+          <p:nvPr/>
+        </p:nvSpPr>
+        <p:spPr>
+          <a:xfrm>
+            <a:off x="1371600" y="3794760"/>
+            <a:ext cx="1371600" cy="411480"/>
+          </a:xfrm>
+          <a:prstGeom prst="rect">
+            <a:avLst/>
+          </a:prstGeom>
+          <a:solidFill>
+            <a:srgbClr val="F5F5F5"/>
+          </a:solidFill>
+          <a:ln w="6350">
+            <a:solidFill>
+              <a:srgbClr val="CCCCCC"/>
+            </a:solidFill>
+          </a:ln>
+        </p:spPr>
+        <p:style>
+          <a:lnRef idx="1">
+            <a:schemeClr val="accent1"/>
+          </a:lnRef>
+          <a:fillRef idx="3">
+            <a:schemeClr val="accent1"/>
+          </a:fillRef>
+          <a:effectRef idx="2">
+            <a:schemeClr val="accent1"/>
+          </a:effectRef>
+          <a:fontRef idx="minor">
+            <a:schemeClr val="lt1"/>
+          </a:fontRef>
+        </p:style>
+        <p:txBody>
+          <a:bodyPr rtlCol="0" anchor="ctr" wrap="square"/>
+          <a:lstStyle/>
+          <a:p>
+            <a:pPr algn="ctr"/>
+          </a:p>
+        </p:txBody>
+      </p:sp>
+      <p:sp>
+        <p:nvSpPr>
+          <p:cNvPr id="47" name="Rectangle 46"/>
+          <p:cNvSpPr/>
+          <p:nvPr/>
+        </p:nvSpPr>
+        <p:spPr>
+          <a:xfrm>
+            <a:off x="2743200" y="3794760"/>
+            <a:ext cx="1828800" cy="411480"/>
+          </a:xfrm>
+          <a:prstGeom prst="rect">
+            <a:avLst/>
+          </a:prstGeom>
+          <a:solidFill>
+            <a:srgbClr val="F5F5F5"/>
+          </a:solidFill>
+          <a:ln w="6350">
+            <a:solidFill>
+              <a:srgbClr val="CCCCCC"/>
+            </a:solidFill>
+          </a:ln>
+        </p:spPr>
+        <p:style>
+          <a:lnRef idx="1">
+            <a:schemeClr val="accent1"/>
+          </a:lnRef>
+          <a:fillRef idx="3">
+            <a:schemeClr val="accent1"/>
+          </a:fillRef>
+          <a:effectRef idx="2">
+            <a:schemeClr val="accent1"/>
+          </a:effectRef>
+          <a:fontRef idx="minor">
+            <a:schemeClr val="lt1"/>
+          </a:fontRef>
+        </p:style>
+        <p:txBody>
+          <a:bodyPr rtlCol="0" anchor="ctr" wrap="square"/>
+          <a:lstStyle/>
+          <a:p>
+            <a:pPr algn="ctr"/>
+            <a:r>
+              <a:rPr sz="900">
+                <a:solidFill>
+                  <a:srgbClr val="000000"/>
+                </a:solidFill>
+              </a:rPr>
+              <a:t>Narrow, Primary</a:t>
+            </a:r>
+          </a:p>
+        </p:txBody>
+      </p:sp>
+      <p:sp>
+        <p:nvSpPr>
+          <p:cNvPr id="48" name="Rectangle 47"/>
+          <p:cNvSpPr/>
+          <p:nvPr/>
+        </p:nvSpPr>
+        <p:spPr>
+          <a:xfrm>
+            <a:off x="4572000" y="3794760"/>
+            <a:ext cx="914400" cy="411480"/>
+          </a:xfrm>
+          <a:prstGeom prst="rect">
+            <a:avLst/>
+          </a:prstGeom>
+          <a:solidFill>
+            <a:srgbClr val="F5F5F5"/>
+          </a:solidFill>
+          <a:ln w="6350">
+            <a:solidFill>
+              <a:srgbClr val="CCCCCC"/>
+            </a:solidFill>
+          </a:ln>
+        </p:spPr>
+        <p:style>
+          <a:lnRef idx="1">
+            <a:schemeClr val="accent1"/>
+          </a:lnRef>
+          <a:fillRef idx="3">
+            <a:schemeClr val="accent1"/>
+          </a:fillRef>
+          <a:effectRef idx="2">
+            <a:schemeClr val="accent1"/>
+          </a:effectRef>
+          <a:fontRef idx="minor">
+            <a:schemeClr val="lt1"/>
+          </a:fontRef>
+        </p:style>
+        <p:txBody>
+          <a:bodyPr rtlCol="0" anchor="ctr" wrap="square"/>
+          <a:lstStyle/>
+          <a:p>
+            <a:pPr algn="ctr"/>
+            <a:r>
+              <a:rPr sz="900">
+                <a:solidFill>
+                  <a:srgbClr val="000000"/>
+                </a:solidFill>
+              </a:rPr>
+              <a:t>13.59</a:t>
+            </a:r>
+          </a:p>
+        </p:txBody>
+      </p:sp>
+      <p:sp>
+        <p:nvSpPr>
+          <p:cNvPr id="49" name="Rectangle 48"/>
+          <p:cNvSpPr/>
+          <p:nvPr/>
+        </p:nvSpPr>
+        <p:spPr>
+          <a:xfrm>
+            <a:off x="5486400" y="3794760"/>
+            <a:ext cx="2011680" cy="411480"/>
+          </a:xfrm>
+          <a:prstGeom prst="rect">
+            <a:avLst/>
+          </a:prstGeom>
+          <a:solidFill>
+            <a:srgbClr val="F5F5F5"/>
+          </a:solidFill>
+          <a:ln w="6350">
+            <a:solidFill>
+              <a:srgbClr val="CCCCCC"/>
+            </a:solidFill>
+          </a:ln>
+        </p:spPr>
+        <p:style>
+          <a:lnRef idx="1">
+            <a:schemeClr val="accent1"/>
+          </a:lnRef>
+          <a:fillRef idx="3">
+            <a:schemeClr val="accent1"/>
+          </a:fillRef>
+          <a:effectRef idx="2">
+            <a:schemeClr val="accent1"/>
+          </a:effectRef>
+          <a:fontRef idx="minor">
+            <a:schemeClr val="lt1"/>
+          </a:fontRef>
+        </p:style>
+        <p:txBody>
+          <a:bodyPr rtlCol="0" anchor="ctr" wrap="square"/>
+          <a:lstStyle/>
+          <a:p>
+            <a:pPr algn="ctr"/>
+            <a:r>
+              <a:rPr sz="900">
+                <a:solidFill>
+                  <a:srgbClr val="000000"/>
+                </a:solidFill>
+              </a:rPr>
+              <a:t>1.74–106.04</a:t>
+            </a:r>
+          </a:p>
+        </p:txBody>
+      </p:sp>
+      <p:sp>
+        <p:nvSpPr>
+          <p:cNvPr id="50" name="Rectangle 49"/>
+          <p:cNvSpPr/>
+          <p:nvPr/>
+        </p:nvSpPr>
+        <p:spPr>
+          <a:xfrm>
+            <a:off x="7498080" y="3794760"/>
+            <a:ext cx="2011680" cy="411480"/>
+          </a:xfrm>
+          <a:prstGeom prst="rect">
+            <a:avLst/>
+          </a:prstGeom>
+          <a:solidFill>
+            <a:srgbClr val="F5F5F5"/>
+          </a:solidFill>
+          <a:ln w="6350">
+            <a:solidFill>
+              <a:srgbClr val="CCCCCC"/>
+            </a:solidFill>
+          </a:ln>
+        </p:spPr>
+        <p:style>
+          <a:lnRef idx="1">
+            <a:schemeClr val="accent1"/>
+          </a:lnRef>
+          <a:fillRef idx="3">
+            <a:schemeClr val="accent1"/>
+          </a:fillRef>
+          <a:effectRef idx="2">
+            <a:schemeClr val="accent1"/>
+          </a:effectRef>
+          <a:fontRef idx="minor">
+            <a:schemeClr val="lt1"/>
+          </a:fontRef>
+        </p:style>
+        <p:txBody>
+          <a:bodyPr rtlCol="0" anchor="ctr" wrap="square"/>
+          <a:lstStyle/>
+          <a:p>
+            <a:pPr algn="ctr"/>
+            <a:r>
+              <a:rPr sz="900">
+                <a:solidFill>
+                  <a:srgbClr val="000000"/>
+                </a:solidFill>
+              </a:rPr>
+              <a:t>0.00–700136.92</a:t>
+            </a:r>
+          </a:p>
+        </p:txBody>
+      </p:sp>
+      <p:sp>
+        <p:nvSpPr>
+          <p:cNvPr id="51" name="Rectangle 50"/>
+          <p:cNvSpPr/>
+          <p:nvPr/>
+        </p:nvSpPr>
+        <p:spPr>
+          <a:xfrm>
+            <a:off x="9509760" y="3794760"/>
+            <a:ext cx="914400" cy="411480"/>
+          </a:xfrm>
+          <a:prstGeom prst="rect">
+            <a:avLst/>
+          </a:prstGeom>
+          <a:solidFill>
+            <a:srgbClr val="F5F5F5"/>
+          </a:solidFill>
+          <a:ln w="6350">
+            <a:solidFill>
+              <a:srgbClr val="CCCCCC"/>
+            </a:solidFill>
+          </a:ln>
+        </p:spPr>
+        <p:style>
+          <a:lnRef idx="1">
+            <a:schemeClr val="accent1"/>
+          </a:lnRef>
+          <a:fillRef idx="3">
+            <a:schemeClr val="accent1"/>
+          </a:fillRef>
+          <a:effectRef idx="2">
+            <a:schemeClr val="accent1"/>
+          </a:effectRef>
+          <a:fontRef idx="minor">
+            <a:schemeClr val="lt1"/>
+          </a:fontRef>
+        </p:style>
+        <p:txBody>
+          <a:bodyPr rtlCol="0" anchor="ctr" wrap="square"/>
+          <a:lstStyle/>
+          <a:p>
+            <a:pPr algn="ctr"/>
+            <a:r>
+              <a:rPr sz="900">
+                <a:solidFill>
+                  <a:srgbClr val="000000"/>
+                </a:solidFill>
+              </a:rPr>
+              <a:t>99.8%</a:t>
+            </a:r>
+          </a:p>
+        </p:txBody>
+      </p:sp>
+      <p:sp>
+        <p:nvSpPr>
+          <p:cNvPr id="52" name="Rectangle 51"/>
+          <p:cNvSpPr/>
+          <p:nvPr/>
+        </p:nvSpPr>
+        <p:spPr>
+          <a:xfrm>
+            <a:off x="1371600" y="4206240"/>
+            <a:ext cx="1371600" cy="411480"/>
+          </a:xfrm>
+          <a:prstGeom prst="rect">
+            <a:avLst/>
+          </a:prstGeom>
+          <a:solidFill>
+            <a:srgbClr val="FFFFFF"/>
+          </a:solidFill>
+          <a:ln w="6350">
+            <a:solidFill>
+              <a:srgbClr val="CCCCCC"/>
+            </a:solidFill>
+          </a:ln>
+        </p:spPr>
+        <p:style>
+          <a:lnRef idx="1">
+            <a:schemeClr val="accent1"/>
+          </a:lnRef>
+          <a:fillRef idx="3">
+            <a:schemeClr val="accent1"/>
+          </a:fillRef>
+          <a:effectRef idx="2">
+            <a:schemeClr val="accent1"/>
+          </a:effectRef>
+          <a:fontRef idx="minor">
+            <a:schemeClr val="lt1"/>
+          </a:fontRef>
+        </p:style>
+        <p:txBody>
+          <a:bodyPr rtlCol="0" anchor="ctr" wrap="square"/>
+          <a:lstStyle/>
+          <a:p>
+            <a:pPr algn="ctr"/>
+          </a:p>
+        </p:txBody>
+      </p:sp>
+      <p:sp>
+        <p:nvSpPr>
+          <p:cNvPr id="53" name="Rectangle 52"/>
+          <p:cNvSpPr/>
+          <p:nvPr/>
+        </p:nvSpPr>
+        <p:spPr>
+          <a:xfrm>
+            <a:off x="2743200" y="4206240"/>
+            <a:ext cx="1828800" cy="411480"/>
+          </a:xfrm>
+          <a:prstGeom prst="rect">
+            <a:avLst/>
+          </a:prstGeom>
+          <a:solidFill>
+            <a:srgbClr val="FFFFFF"/>
+          </a:solidFill>
+          <a:ln w="6350">
+            <a:solidFill>
+              <a:srgbClr val="CCCCCC"/>
+            </a:solidFill>
+          </a:ln>
+        </p:spPr>
+        <p:style>
+          <a:lnRef idx="1">
+            <a:schemeClr val="accent1"/>
+          </a:lnRef>
+          <a:fillRef idx="3">
+            <a:schemeClr val="accent1"/>
+          </a:fillRef>
+          <a:effectRef idx="2">
+            <a:schemeClr val="accent1"/>
+          </a:effectRef>
+          <a:fontRef idx="minor">
+            <a:schemeClr val="lt1"/>
+          </a:fontRef>
+        </p:style>
+        <p:txBody>
+          <a:bodyPr rtlCol="0" anchor="ctr" wrap="square"/>
+          <a:lstStyle/>
+          <a:p>
+            <a:pPr algn="ctr"/>
+            <a:r>
+              <a:rPr sz="900">
+                <a:solidFill>
+                  <a:srgbClr val="000000"/>
+                </a:solidFill>
+              </a:rPr>
+              <a:t>Narrow, Secondary</a:t>
+            </a:r>
+          </a:p>
+        </p:txBody>
+      </p:sp>
+      <p:sp>
+        <p:nvSpPr>
+          <p:cNvPr id="54" name="Rectangle 53"/>
+          <p:cNvSpPr/>
+          <p:nvPr/>
+        </p:nvSpPr>
+        <p:spPr>
+          <a:xfrm>
+            <a:off x="4572000" y="4206240"/>
+            <a:ext cx="914400" cy="411480"/>
+          </a:xfrm>
+          <a:prstGeom prst="rect">
+            <a:avLst/>
+          </a:prstGeom>
+          <a:solidFill>
+            <a:srgbClr val="FFFFFF"/>
+          </a:solidFill>
+          <a:ln w="6350">
+            <a:solidFill>
+              <a:srgbClr val="CCCCCC"/>
+            </a:solidFill>
+          </a:ln>
+        </p:spPr>
+        <p:style>
+          <a:lnRef idx="1">
+            <a:schemeClr val="accent1"/>
+          </a:lnRef>
+          <a:fillRef idx="3">
+            <a:schemeClr val="accent1"/>
+          </a:fillRef>
+          <a:effectRef idx="2">
+            <a:schemeClr val="accent1"/>
+          </a:effectRef>
+          <a:fontRef idx="minor">
+            <a:schemeClr val="lt1"/>
+          </a:fontRef>
+        </p:style>
+        <p:txBody>
+          <a:bodyPr rtlCol="0" anchor="ctr" wrap="square"/>
+          <a:lstStyle/>
+          <a:p>
+            <a:pPr algn="ctr"/>
+            <a:r>
+              <a:rPr sz="900">
+                <a:solidFill>
+                  <a:srgbClr val="000000"/>
+                </a:solidFill>
+              </a:rPr>
+              <a:t>14.14</a:t>
+            </a:r>
+          </a:p>
+        </p:txBody>
+      </p:sp>
+      <p:sp>
+        <p:nvSpPr>
+          <p:cNvPr id="55" name="Rectangle 54"/>
+          <p:cNvSpPr/>
+          <p:nvPr/>
+        </p:nvSpPr>
+        <p:spPr>
+          <a:xfrm>
+            <a:off x="5486400" y="4206240"/>
+            <a:ext cx="2011680" cy="411480"/>
+          </a:xfrm>
+          <a:prstGeom prst="rect">
+            <a:avLst/>
+          </a:prstGeom>
+          <a:solidFill>
+            <a:srgbClr val="FFFFFF"/>
+          </a:solidFill>
+          <a:ln w="6350">
+            <a:solidFill>
+              <a:srgbClr val="CCCCCC"/>
+            </a:solidFill>
+          </a:ln>
+        </p:spPr>
+        <p:style>
+          <a:lnRef idx="1">
+            <a:schemeClr val="accent1"/>
+          </a:lnRef>
+          <a:fillRef idx="3">
+            <a:schemeClr val="accent1"/>
+          </a:fillRef>
+          <a:effectRef idx="2">
+            <a:schemeClr val="accent1"/>
+          </a:effectRef>
+          <a:fontRef idx="minor">
+            <a:schemeClr val="lt1"/>
+          </a:fontRef>
+        </p:style>
+        <p:txBody>
+          <a:bodyPr rtlCol="0" anchor="ctr" wrap="square"/>
+          <a:lstStyle/>
+          <a:p>
+            <a:pPr algn="ctr"/>
+            <a:r>
+              <a:rPr sz="900">
+                <a:solidFill>
+                  <a:srgbClr val="000000"/>
+                </a:solidFill>
+              </a:rPr>
+              <a:t>0.72–277.39</a:t>
+            </a:r>
+          </a:p>
+        </p:txBody>
+      </p:sp>
+      <p:sp>
+        <p:nvSpPr>
+          <p:cNvPr id="56" name="Rectangle 55"/>
+          <p:cNvSpPr/>
+          <p:nvPr/>
+        </p:nvSpPr>
+        <p:spPr>
+          <a:xfrm>
+            <a:off x="7498080" y="4206240"/>
+            <a:ext cx="2011680" cy="411480"/>
+          </a:xfrm>
+          <a:prstGeom prst="rect">
+            <a:avLst/>
+          </a:prstGeom>
+          <a:solidFill>
+            <a:srgbClr val="FFFFFF"/>
+          </a:solidFill>
+          <a:ln w="6350">
+            <a:solidFill>
+              <a:srgbClr val="CCCCCC"/>
+            </a:solidFill>
+          </a:ln>
+        </p:spPr>
+        <p:style>
+          <a:lnRef idx="1">
+            <a:schemeClr val="accent1"/>
+          </a:lnRef>
+          <a:fillRef idx="3">
+            <a:schemeClr val="accent1"/>
+          </a:fillRef>
+          <a:effectRef idx="2">
+            <a:schemeClr val="accent1"/>
+          </a:effectRef>
+          <a:fontRef idx="minor">
+            <a:schemeClr val="lt1"/>
+          </a:fontRef>
+        </p:style>
+        <p:txBody>
+          <a:bodyPr rtlCol="0" anchor="ctr" wrap="square"/>
+          <a:lstStyle/>
+          <a:p>
+            <a:pPr algn="ctr"/>
+            <a:r>
+              <a:rPr sz="900">
+                <a:solidFill>
+                  <a:srgbClr val="000000"/>
+                </a:solidFill>
+              </a:rPr>
+              <a:t>Unstable</a:t>
+            </a:r>
+          </a:p>
+        </p:txBody>
+      </p:sp>
+      <p:sp>
+        <p:nvSpPr>
+          <p:cNvPr id="57" name="Rectangle 56"/>
+          <p:cNvSpPr/>
+          <p:nvPr/>
+        </p:nvSpPr>
+        <p:spPr>
+          <a:xfrm>
+            <a:off x="9509760" y="4206240"/>
+            <a:ext cx="914400" cy="411480"/>
+          </a:xfrm>
+          <a:prstGeom prst="rect">
+            <a:avLst/>
+          </a:prstGeom>
+          <a:solidFill>
+            <a:srgbClr val="FFFFFF"/>
+          </a:solidFill>
+          <a:ln w="6350">
+            <a:solidFill>
+              <a:srgbClr val="CCCCCC"/>
+            </a:solidFill>
+          </a:ln>
+        </p:spPr>
+        <p:style>
+          <a:lnRef idx="1">
+            <a:schemeClr val="accent1"/>
+          </a:lnRef>
+          <a:fillRef idx="3">
+            <a:schemeClr val="accent1"/>
+          </a:fillRef>
+          <a:effectRef idx="2">
+            <a:schemeClr val="accent1"/>
+          </a:effectRef>
+          <a:fontRef idx="minor">
+            <a:schemeClr val="lt1"/>
+          </a:fontRef>
+        </p:style>
+        <p:txBody>
+          <a:bodyPr rtlCol="0" anchor="ctr" wrap="square"/>
+          <a:lstStyle/>
+          <a:p>
+            <a:pPr algn="ctr"/>
+            <a:r>
+              <a:rPr sz="900">
+                <a:solidFill>
+                  <a:srgbClr val="000000"/>
+                </a:solidFill>
+              </a:rPr>
+              <a:t>91.5%</a:t>
+            </a:r>
+          </a:p>
+        </p:txBody>
+      </p:sp>
+    </p:spTree>
+  </p:cSld>
+  <p:clrMapOvr>
+    <a:masterClrMapping/>
+  </p:clrMapOvr>
+</p:sld>
+</file>
+
 <file path=ppt/theme/theme1.xml><?xml version="1.0" encoding="utf-8"?>
 <a:theme xmlns:a="http://schemas.openxmlformats.org/drawingml/2006/main" name="Office Theme">
   <a:themeElements>

</xml_diff>

<commit_message>
fix: analysis_def_e.py primary/secondary swap + 低血圧を記述統計のみに変更
- analysis_def_e.py: 主要/副次定義を他スクリプトと統一（Devin Review BUG指摘修正）
  - A-Primary: 麻酔→娩出、A-Secondary: 麻酔→退室
  - E-Primary: 5-HT3+娩出前、E-Secondary: 5-HT3全期間
- analysis_bootstrap.py: Wald CI mismatch修正（def_e_stats.json再生成で自動解消）
- 低血圧副次アウトカム: ロジスティック回帰・負の二項回帰を削除、記述統計のみに変更
  - 理由: IONVの共変量として使用しており、独立アウトカムとしての回帰は過剰
- STROBE checklist: INCLUDE_SENSITIVITY=False時の参照修正
- Figure legends: 感度分析図（Fig. 5-7）をINCLUDE_SENSITIVITYで条件分岐

Co-Authored-By: Tatsuki Onishi <bougtoir@gmail.com>
</commit_message>
<xml_diff>
--- a/yago_ionv/figures_strobe.pptx
+++ b/yago_ionv/figures_strobe.pptx
@@ -192,16 +192,16 @@
                 <c:formatCode>General</c:formatCode>
                 <c:ptCount val="4"/>
                 <c:pt idx="0">
+                  <c:v>1.8973998594518624</c:v>
+                </c:pt>
+                <c:pt idx="1">
                   <c:v>17.70906535488405</c:v>
                 </c:pt>
-                <c:pt idx="1">
-                  <c:v>1.8973998594518624</c:v>
-                </c:pt>
                 <c:pt idx="2">
-                  <c:v>0.8784258608573436</c:v>
+                  <c:v>0.21082220660576245</c:v>
                 </c:pt>
                 <c:pt idx="3">
-                  <c:v>0.21082220660576245</c:v>
+                  <c:v>0.8784258608573436</c:v>
                 </c:pt>
               </c:numCache>
             </c:numRef>
@@ -276,16 +276,16 @@
                 <c:formatCode>General</c:formatCode>
                 <c:ptCount val="4"/>
                 <c:pt idx="0">
+                  <c:v>1.461988304093567</c:v>
+                </c:pt>
+                <c:pt idx="1">
                   <c:v>16.95906432748538</c:v>
                 </c:pt>
-                <c:pt idx="1">
-                  <c:v>1.461988304093567</c:v>
-                </c:pt>
                 <c:pt idx="2">
-                  <c:v>2.3391812865497075</c:v>
+                  <c:v>0.8771929824561403</c:v>
                 </c:pt>
                 <c:pt idx="3">
-                  <c:v>0.8771929824561403</c:v>
+                  <c:v>2.3391812865497075</c:v>
                 </c:pt>
               </c:numCache>
             </c:numRef>
@@ -5066,7 +5066,7 @@
         </p:nvSpPr>
         <p:spPr>
           <a:xfrm>
-            <a:off x="4374488" y="1097280"/>
+            <a:off x="4007918" y="1097280"/>
             <a:ext cx="19050" cy="2468880"/>
           </a:xfrm>
           <a:prstGeom prst="rect">
@@ -5109,7 +5109,7 @@
         </p:nvSpPr>
         <p:spPr>
           <a:xfrm>
-            <a:off x="4100168" y="3611880"/>
+            <a:off x="3733598" y="3611880"/>
             <a:ext cx="548640" cy="228600"/>
           </a:xfrm>
           <a:prstGeom prst="rect">
@@ -5193,7 +5193,7 @@
               <a:defRPr sz="800"/>
             </a:pPr>
             <a:r>
-              <a:t>Emergency CS</a:t>
+              <a:t>Hypotension (SBP&lt;90)</a:t>
             </a:r>
           </a:p>
         </p:txBody>
@@ -5206,8 +5206,8 @@
         </p:nvSpPr>
         <p:spPr>
           <a:xfrm>
-            <a:off x="4015343" y="1283970"/>
-            <a:ext cx="1196770" cy="38100"/>
+            <a:off x="3756990" y="1283970"/>
+            <a:ext cx="1330779" cy="38100"/>
           </a:xfrm>
           <a:prstGeom prst="rect">
             <a:avLst/>
@@ -5249,7 +5249,7 @@
         </p:nvSpPr>
         <p:spPr>
           <a:xfrm>
-            <a:off x="4348468" y="1248156"/>
+            <a:off x="3979757" y="1248156"/>
             <a:ext cx="109728" cy="109728"/>
           </a:xfrm>
           <a:prstGeom prst="diamond">
@@ -5316,7 +5316,7 @@
               </a:defRPr>
             </a:pPr>
             <a:r>
-              <a:t>OR 1.04 [0.50–2.17] P=0.916</a:t>
+              <a:t>OR 1.08 [0.28–4.08] P=0.914</a:t>
             </a:r>
           </a:p>
         </p:txBody>
@@ -5360,8 +5360,8 @@
         </p:nvSpPr>
         <p:spPr>
           <a:xfrm>
-            <a:off x="4295992" y="1695450"/>
-            <a:ext cx="191177" cy="38100"/>
+            <a:off x="3890101" y="1695450"/>
+            <a:ext cx="268068" cy="38100"/>
           </a:xfrm>
           <a:prstGeom prst="rect">
             <a:avLst/>
@@ -5403,7 +5403,7 @@
         </p:nvSpPr>
         <p:spPr>
           <a:xfrm>
-            <a:off x="4330466" y="1659636"/>
+            <a:off x="3943885" y="1659636"/>
             <a:ext cx="109728" cy="109728"/>
           </a:xfrm>
           <a:prstGeom prst="diamond">
@@ -5470,7 +5470,7 @@
               </a:defRPr>
             </a:pPr>
             <a:r>
-              <a:t>OR 1.02 [0.89–1.16] P=0.822</a:t>
+              <a:t>OR 0.97 [0.66–1.43] P=0.892</a:t>
             </a:r>
           </a:p>
         </p:txBody>
@@ -5501,7 +5501,7 @@
               <a:defRPr sz="800"/>
             </a:pPr>
             <a:r>
-              <a:t>Hypotension (SBP&lt;90)</a:t>
+              <a:t>Age (per year)</a:t>
             </a:r>
           </a:p>
         </p:txBody>
@@ -5514,8 +5514,8 @@
         </p:nvSpPr>
         <p:spPr>
           <a:xfrm>
-            <a:off x="4131923" y="2106930"/>
-            <a:ext cx="1481817" cy="38100"/>
+            <a:off x="3959407" y="2106930"/>
+            <a:ext cx="91752" cy="38100"/>
           </a:xfrm>
           <a:prstGeom prst="rect">
             <a:avLst/>
@@ -5557,7 +5557,7 @@
         </p:nvSpPr>
         <p:spPr>
           <a:xfrm>
-            <a:off x="4565982" y="2071116"/>
+            <a:off x="3947379" y="2071116"/>
             <a:ext cx="109728" cy="109728"/>
           </a:xfrm>
           <a:prstGeom prst="diamond">
@@ -5624,7 +5624,7 @@
               </a:defRPr>
             </a:pPr>
             <a:r>
-              <a:t>OR 1.34 [0.66–2.73] P=0.414</a:t>
+              <a:t>OR 0.98 [0.86–1.12] P=0.809</a:t>
             </a:r>
           </a:p>
         </p:txBody>
@@ -5668,8 +5668,8 @@
         </p:nvSpPr>
         <p:spPr>
           <a:xfrm>
-            <a:off x="4373627" y="2518410"/>
-            <a:ext cx="13304" cy="38100"/>
+            <a:off x="4000422" y="2518410"/>
+            <a:ext cx="19265" cy="38100"/>
           </a:xfrm>
           <a:prstGeom prst="rect">
             <a:avLst/>
@@ -5711,7 +5711,7 @@
         </p:nvSpPr>
         <p:spPr>
           <a:xfrm>
-            <a:off x="4325384" y="2482596"/>
+            <a:off x="3955059" y="2482596"/>
             <a:ext cx="109728" cy="109728"/>
           </a:xfrm>
           <a:prstGeom prst="diamond">
@@ -5778,7 +5778,7 @@
               </a:defRPr>
             </a:pPr>
             <a:r>
-              <a:t>OR 1.01 [1.00–1.02] P=0.088</a:t>
+              <a:t>OR 1.01 [0.98–1.03] P=0.682</a:t>
             </a:r>
           </a:p>
         </p:txBody>
@@ -5809,7 +5809,7 @@
               <a:defRPr sz="800"/>
             </a:pPr>
             <a:r>
-              <a:t>Age (per year)</a:t>
+              <a:t>Emergency CS</a:t>
             </a:r>
           </a:p>
         </p:txBody>
@@ -5822,8 +5822,8 @@
         </p:nvSpPr>
         <p:spPr>
           <a:xfrm>
-            <a:off x="4373330" y="2929890"/>
-            <a:ext cx="107300" cy="38100"/>
+            <a:off x="3663278" y="2929890"/>
+            <a:ext cx="514115" cy="38100"/>
           </a:xfrm>
           <a:prstGeom prst="rect">
             <a:avLst/>
@@ -5865,7 +5865,7 @@
         </p:nvSpPr>
         <p:spPr>
           <a:xfrm>
-            <a:off x="4370243" y="2894076"/>
+            <a:off x="3657065" y="2894076"/>
             <a:ext cx="109728" cy="109728"/>
           </a:xfrm>
           <a:prstGeom prst="diamond">
@@ -5932,7 +5932,7 @@
               </a:defRPr>
             </a:pPr>
             <a:r>
-              <a:t>OR 1.07 [1.00–1.15] P=0.056</a:t>
+              <a:t>OR 0.16 [0.02–1.48] P=0.106</a:t>
             </a:r>
           </a:p>
         </p:txBody>
@@ -5976,8 +5976,8 @@
         </p:nvSpPr>
         <p:spPr>
           <a:xfrm>
-            <a:off x="4644233" y="3341370"/>
-            <a:ext cx="4288751" cy="38100"/>
+            <a:off x="3939744" y="3341370"/>
+            <a:ext cx="4993240" cy="38100"/>
           </a:xfrm>
           <a:prstGeom prst="rect">
             <a:avLst/>
@@ -6019,7 +6019,7 @@
         </p:nvSpPr>
         <p:spPr>
           <a:xfrm>
-            <a:off x="5884154" y="3305556"/>
+            <a:off x="4822745" y="3305556"/>
             <a:ext cx="109728" cy="109728"/>
           </a:xfrm>
           <a:prstGeom prst="diamond">
@@ -6086,7 +6086,7 @@
               </a:defRPr>
             </a:pPr>
             <a:r>
-              <a:t>OR 3.18 [1.38–7.36] P=0.007**</a:t>
+              <a:t>OR 3.48 [0.81–15.06] P=0.095</a:t>
             </a:r>
           </a:p>
         </p:txBody>
@@ -6310,7 +6310,7 @@
               <a:defRPr sz="800"/>
             </a:pPr>
             <a:r>
-              <a:t>Def E: 5-HT3 + before delivery phase</a:t>
+              <a:t>Narrow: 5-HT3 any phase (anesthesia→exit)</a:t>
             </a:r>
           </a:p>
         </p:txBody>
@@ -6323,14 +6323,14 @@
         </p:nvSpPr>
         <p:spPr>
           <a:xfrm>
-            <a:off x="3939744" y="1283970"/>
-            <a:ext cx="4993240" cy="38100"/>
-          </a:xfrm>
-          <a:prstGeom prst="rect">
-            <a:avLst/>
-          </a:prstGeom>
-          <a:solidFill>
-            <a:srgbClr val="4C72B0"/>
+            <a:off x="4139733" y="1283970"/>
+            <a:ext cx="2095764" cy="38100"/>
+          </a:xfrm>
+          <a:prstGeom prst="rect">
+            <a:avLst/>
+          </a:prstGeom>
+          <a:solidFill>
+            <a:srgbClr val="C44E52"/>
           </a:solidFill>
           <a:ln>
             <a:noFill/>
@@ -6366,7 +6366,161 @@
         </p:nvSpPr>
         <p:spPr>
           <a:xfrm>
-            <a:off x="4822745" y="1248156"/>
+            <a:off x="4717586" y="1248156"/>
+            <a:ext cx="109728" cy="109728"/>
+          </a:xfrm>
+          <a:prstGeom prst="diamond">
+            <a:avLst/>
+          </a:prstGeom>
+          <a:solidFill>
+            <a:srgbClr val="C44E52"/>
+          </a:solidFill>
+          <a:ln>
+            <a:solidFill>
+              <a:srgbClr val="C44E52"/>
+            </a:solidFill>
+          </a:ln>
+        </p:spPr>
+        <p:style>
+          <a:lnRef idx="1">
+            <a:schemeClr val="accent1"/>
+          </a:lnRef>
+          <a:fillRef idx="3">
+            <a:schemeClr val="accent1"/>
+          </a:fillRef>
+          <a:effectRef idx="2">
+            <a:schemeClr val="accent1"/>
+          </a:effectRef>
+          <a:fontRef idx="minor">
+            <a:schemeClr val="lt1"/>
+          </a:fontRef>
+        </p:style>
+        <p:txBody>
+          <a:bodyPr rtlCol="0" anchor="ctr"/>
+          <a:lstStyle/>
+          <a:p>
+            <a:pPr algn="ctr"/>
+          </a:p>
+        </p:txBody>
+      </p:sp>
+      <p:sp>
+        <p:nvSpPr>
+          <p:cNvPr id="9" name="TextBox 8"/>
+          <p:cNvSpPr txBox="1"/>
+          <p:nvPr/>
+        </p:nvSpPr>
+        <p:spPr>
+          <a:xfrm>
+            <a:off x="10607040" y="1193292"/>
+            <a:ext cx="1371600" cy="228600"/>
+          </a:xfrm>
+          <a:prstGeom prst="rect">
+            <a:avLst/>
+          </a:prstGeom>
+          <a:noFill/>
+        </p:spPr>
+        <p:txBody>
+          <a:bodyPr wrap="none">
+            <a:spAutoFit/>
+          </a:bodyPr>
+          <a:lstStyle/>
+          <a:p>
+            <a:pPr>
+              <a:defRPr sz="700">
+                <a:solidFill>
+                  <a:srgbClr val="C44E52"/>
+                </a:solidFill>
+              </a:defRPr>
+            </a:pPr>
+            <a:r>
+              <a:t>OR 3.18 [1.38–7.36] P=0.007**</a:t>
+            </a:r>
+          </a:p>
+        </p:txBody>
+      </p:sp>
+      <p:sp>
+        <p:nvSpPr>
+          <p:cNvPr id="10" name="TextBox 9"/>
+          <p:cNvSpPr txBox="1"/>
+          <p:nvPr/>
+        </p:nvSpPr>
+        <p:spPr>
+          <a:xfrm>
+            <a:off x="274320" y="1577340"/>
+            <a:ext cx="3200400" cy="274320"/>
+          </a:xfrm>
+          <a:prstGeom prst="rect">
+            <a:avLst/>
+          </a:prstGeom>
+          <a:noFill/>
+        </p:spPr>
+        <p:txBody>
+          <a:bodyPr wrap="square">
+            <a:spAutoFit/>
+          </a:bodyPr>
+          <a:lstStyle/>
+          <a:p>
+            <a:pPr algn="r">
+              <a:defRPr sz="800"/>
+            </a:pPr>
+            <a:r>
+              <a:t>Narrow: 5-HT3 before delivery</a:t>
+            </a:r>
+          </a:p>
+        </p:txBody>
+      </p:sp>
+      <p:sp>
+        <p:nvSpPr>
+          <p:cNvPr id="11" name="Rectangle 10"/>
+          <p:cNvSpPr/>
+          <p:nvPr/>
+        </p:nvSpPr>
+        <p:spPr>
+          <a:xfrm>
+            <a:off x="3939744" y="1695450"/>
+            <a:ext cx="4993240" cy="38100"/>
+          </a:xfrm>
+          <a:prstGeom prst="rect">
+            <a:avLst/>
+          </a:prstGeom>
+          <a:solidFill>
+            <a:srgbClr val="4C72B0"/>
+          </a:solidFill>
+          <a:ln>
+            <a:noFill/>
+          </a:ln>
+        </p:spPr>
+        <p:style>
+          <a:lnRef idx="1">
+            <a:schemeClr val="accent1"/>
+          </a:lnRef>
+          <a:fillRef idx="3">
+            <a:schemeClr val="accent1"/>
+          </a:fillRef>
+          <a:effectRef idx="2">
+            <a:schemeClr val="accent1"/>
+          </a:effectRef>
+          <a:fontRef idx="minor">
+            <a:schemeClr val="lt1"/>
+          </a:fontRef>
+        </p:style>
+        <p:txBody>
+          <a:bodyPr rtlCol="0" anchor="ctr"/>
+          <a:lstStyle/>
+          <a:p>
+            <a:pPr algn="ctr"/>
+          </a:p>
+        </p:txBody>
+      </p:sp>
+      <p:sp>
+        <p:nvSpPr>
+          <p:cNvPr id="12" name="Diamond 11"/>
+          <p:cNvSpPr/>
+          <p:nvPr/>
+        </p:nvSpPr>
+        <p:spPr>
+          <a:xfrm>
+            <a:off x="4822745" y="1659636"/>
             <a:ext cx="109728" cy="109728"/>
           </a:xfrm>
           <a:prstGeom prst="diamond">
@@ -6405,13 +6559,13 @@
       </p:sp>
       <p:sp>
         <p:nvSpPr>
-          <p:cNvPr id="9" name="TextBox 8"/>
+          <p:cNvPr id="13" name="TextBox 12"/>
           <p:cNvSpPr txBox="1"/>
           <p:nvPr/>
         </p:nvSpPr>
         <p:spPr>
           <a:xfrm>
-            <a:off x="10607040" y="1193292"/>
+            <a:off x="10607040" y="1604772"/>
             <a:ext cx="1371600" cy="228600"/>
           </a:xfrm>
           <a:prstGeom prst="rect">
@@ -6440,13 +6594,13 @@
       </p:sp>
       <p:sp>
         <p:nvSpPr>
-          <p:cNvPr id="10" name="TextBox 9"/>
+          <p:cNvPr id="14" name="TextBox 13"/>
           <p:cNvSpPr txBox="1"/>
           <p:nvPr/>
         </p:nvSpPr>
         <p:spPr>
           <a:xfrm>
-            <a:off x="274320" y="1577340"/>
+            <a:off x="274320" y="1988820"/>
             <a:ext cx="3200400" cy="274320"/>
           </a:xfrm>
           <a:prstGeom prst="rect">
@@ -6464,27 +6618,27 @@
               <a:defRPr sz="800"/>
             </a:pPr>
             <a:r>
-              <a:t>Def E: 5-HT3 antagonist (any phase)</a:t>
-            </a:r>
-          </a:p>
-        </p:txBody>
-      </p:sp>
-      <p:sp>
-        <p:nvSpPr>
-          <p:cNvPr id="11" name="Rectangle 10"/>
-          <p:cNvSpPr/>
-          <p:nvPr/>
-        </p:nvSpPr>
-        <p:spPr>
-          <a:xfrm>
-            <a:off x="4139733" y="1695450"/>
-            <a:ext cx="2095764" cy="38100"/>
-          </a:xfrm>
-          <a:prstGeom prst="rect">
-            <a:avLst/>
-          </a:prstGeom>
-          <a:solidFill>
-            <a:srgbClr val="C44E52"/>
+              <a:t>Broad: any antiemetic (anesthesia→exit)</a:t>
+            </a:r>
+          </a:p>
+        </p:txBody>
+      </p:sp>
+      <p:sp>
+        <p:nvSpPr>
+          <p:cNvPr id="15" name="Rectangle 14"/>
+          <p:cNvSpPr/>
+          <p:nvPr/>
+        </p:nvSpPr>
+        <p:spPr>
+          <a:xfrm>
+            <a:off x="3893871" y="2106930"/>
+            <a:ext cx="207380" cy="38100"/>
+          </a:xfrm>
+          <a:prstGeom prst="rect">
+            <a:avLst/>
+          </a:prstGeom>
+          <a:solidFill>
+            <a:srgbClr val="4C72B0"/>
           </a:solidFill>
           <a:ln>
             <a:noFill/>
@@ -6514,167 +6668,13 @@
       </p:sp>
       <p:sp>
         <p:nvSpPr>
-          <p:cNvPr id="12" name="Diamond 11"/>
-          <p:cNvSpPr/>
-          <p:nvPr/>
-        </p:nvSpPr>
-        <p:spPr>
-          <a:xfrm>
-            <a:off x="4717586" y="1659636"/>
-            <a:ext cx="109728" cy="109728"/>
-          </a:xfrm>
-          <a:prstGeom prst="diamond">
-            <a:avLst/>
-          </a:prstGeom>
-          <a:solidFill>
-            <a:srgbClr val="C44E52"/>
-          </a:solidFill>
-          <a:ln>
-            <a:solidFill>
-              <a:srgbClr val="C44E52"/>
-            </a:solidFill>
-          </a:ln>
-        </p:spPr>
-        <p:style>
-          <a:lnRef idx="1">
-            <a:schemeClr val="accent1"/>
-          </a:lnRef>
-          <a:fillRef idx="3">
-            <a:schemeClr val="accent1"/>
-          </a:fillRef>
-          <a:effectRef idx="2">
-            <a:schemeClr val="accent1"/>
-          </a:effectRef>
-          <a:fontRef idx="minor">
-            <a:schemeClr val="lt1"/>
-          </a:fontRef>
-        </p:style>
-        <p:txBody>
-          <a:bodyPr rtlCol="0" anchor="ctr"/>
-          <a:lstStyle/>
-          <a:p>
-            <a:pPr algn="ctr"/>
-          </a:p>
-        </p:txBody>
-      </p:sp>
-      <p:sp>
-        <p:nvSpPr>
-          <p:cNvPr id="13" name="TextBox 12"/>
-          <p:cNvSpPr txBox="1"/>
-          <p:nvPr/>
-        </p:nvSpPr>
-        <p:spPr>
-          <a:xfrm>
-            <a:off x="10607040" y="1604772"/>
-            <a:ext cx="1371600" cy="228600"/>
-          </a:xfrm>
-          <a:prstGeom prst="rect">
-            <a:avLst/>
-          </a:prstGeom>
-          <a:noFill/>
-        </p:spPr>
-        <p:txBody>
-          <a:bodyPr wrap="none">
-            <a:spAutoFit/>
-          </a:bodyPr>
-          <a:lstStyle/>
-          <a:p>
-            <a:pPr>
-              <a:defRPr sz="700">
-                <a:solidFill>
-                  <a:srgbClr val="C44E52"/>
-                </a:solidFill>
-              </a:defRPr>
-            </a:pPr>
-            <a:r>
-              <a:t>OR 3.18 [1.38–7.36] P=0.007**</a:t>
-            </a:r>
-          </a:p>
-        </p:txBody>
-      </p:sp>
-      <p:sp>
-        <p:nvSpPr>
-          <p:cNvPr id="14" name="TextBox 13"/>
-          <p:cNvSpPr txBox="1"/>
-          <p:nvPr/>
-        </p:nvSpPr>
-        <p:spPr>
-          <a:xfrm>
-            <a:off x="274320" y="1988820"/>
-            <a:ext cx="3200400" cy="274320"/>
-          </a:xfrm>
-          <a:prstGeom prst="rect">
-            <a:avLst/>
-          </a:prstGeom>
-          <a:noFill/>
-        </p:spPr>
-        <p:txBody>
-          <a:bodyPr wrap="square">
-            <a:spAutoFit/>
-          </a:bodyPr>
-          <a:lstStyle/>
-          <a:p>
-            <a:pPr algn="r">
-              <a:defRPr sz="800"/>
-            </a:pPr>
-            <a:r>
-              <a:t>Protocol: antiemetic before delivery</a:t>
-            </a:r>
-          </a:p>
-        </p:txBody>
-      </p:sp>
-      <p:sp>
-        <p:nvSpPr>
-          <p:cNvPr id="15" name="Rectangle 14"/>
-          <p:cNvSpPr/>
-          <p:nvPr/>
-        </p:nvSpPr>
-        <p:spPr>
-          <a:xfrm>
-            <a:off x="3766155" y="2106930"/>
-            <a:ext cx="646378" cy="38100"/>
-          </a:xfrm>
-          <a:prstGeom prst="rect">
-            <a:avLst/>
-          </a:prstGeom>
-          <a:solidFill>
-            <a:srgbClr val="4C72B0"/>
-          </a:solidFill>
-          <a:ln>
-            <a:noFill/>
-          </a:ln>
-        </p:spPr>
-        <p:style>
-          <a:lnRef idx="1">
-            <a:schemeClr val="accent1"/>
-          </a:lnRef>
-          <a:fillRef idx="3">
-            <a:schemeClr val="accent1"/>
-          </a:fillRef>
-          <a:effectRef idx="2">
-            <a:schemeClr val="accent1"/>
-          </a:effectRef>
-          <a:fontRef idx="minor">
-            <a:schemeClr val="lt1"/>
-          </a:fontRef>
-        </p:style>
-        <p:txBody>
-          <a:bodyPr rtlCol="0" anchor="ctr"/>
-          <a:lstStyle/>
-          <a:p>
-            <a:pPr algn="ctr"/>
-          </a:p>
-        </p:txBody>
-      </p:sp>
-      <p:sp>
-        <p:nvSpPr>
           <p:cNvPr id="16" name="Diamond 15"/>
           <p:cNvSpPr/>
           <p:nvPr/>
         </p:nvSpPr>
         <p:spPr>
           <a:xfrm>
-            <a:off x="3889008" y="2071116"/>
+            <a:off x="3926498" y="2071116"/>
             <a:ext cx="109728" cy="109728"/>
           </a:xfrm>
           <a:prstGeom prst="diamond">
@@ -6741,7 +6741,7 @@
               </a:defRPr>
             </a:pPr>
             <a:r>
-              <a:t>OR 0.82 [0.31–2.15] P=0.683</a:t>
+              <a:t>OR 0.92 [0.67–1.27] P=0.624</a:t>
             </a:r>
           </a:p>
         </p:txBody>
@@ -6772,7 +6772,7 @@
               <a:defRPr sz="800"/>
             </a:pPr>
             <a:r>
-              <a:t>Protocol: any antiemetic (any phase)</a:t>
+              <a:t>Broad: antiemetic before delivery</a:t>
             </a:r>
           </a:p>
         </p:txBody>
@@ -6785,8 +6785,8 @@
         </p:nvSpPr>
         <p:spPr>
           <a:xfrm>
-            <a:off x="3893871" y="2518410"/>
-            <a:ext cx="207380" cy="38100"/>
+            <a:off x="3766155" y="2518410"/>
+            <a:ext cx="646378" cy="38100"/>
           </a:xfrm>
           <a:prstGeom prst="rect">
             <a:avLst/>
@@ -6828,7 +6828,7 @@
         </p:nvSpPr>
         <p:spPr>
           <a:xfrm>
-            <a:off x="3926498" y="2482596"/>
+            <a:off x="3889008" y="2482596"/>
             <a:ext cx="109728" cy="109728"/>
           </a:xfrm>
           <a:prstGeom prst="diamond">
@@ -6895,7 +6895,7 @@
               </a:defRPr>
             </a:pPr>
             <a:r>
-              <a:t>OR 0.92 [0.67–1.27] P=0.624</a:t>
+              <a:t>OR 0.82 [0.31–2.15] P=0.683</a:t>
             </a:r>
           </a:p>
         </p:txBody>
@@ -6992,7 +6992,7 @@
         </p:nvSpPr>
         <p:spPr>
           <a:xfrm>
-            <a:off x="4262051" y="1097280"/>
+            <a:off x="3835371" y="1097280"/>
             <a:ext cx="19050" cy="4572000"/>
           </a:xfrm>
           <a:prstGeom prst="rect">
@@ -7035,7 +7035,7 @@
         </p:nvSpPr>
         <p:spPr>
           <a:xfrm>
-            <a:off x="3987731" y="5715000"/>
+            <a:off x="3561051" y="5715000"/>
             <a:ext cx="548640" cy="228600"/>
           </a:xfrm>
           <a:prstGeom prst="rect">
@@ -7101,7 +7101,7 @@
         </p:nvSpPr>
         <p:spPr>
           <a:xfrm>
-            <a:off x="274320" y="1087120"/>
+            <a:off x="274320" y="1080435"/>
             <a:ext cx="3200400" cy="274320"/>
           </a:xfrm>
           <a:prstGeom prst="rect">
@@ -7132,14 +7132,14 @@
         </p:nvSpPr>
         <p:spPr>
           <a:xfrm>
-            <a:off x="4489489" y="1205230"/>
-            <a:ext cx="3616104" cy="38100"/>
-          </a:xfrm>
-          <a:prstGeom prst="rect">
-            <a:avLst/>
-          </a:prstGeom>
-          <a:solidFill>
-            <a:srgbClr val="C44E52"/>
+            <a:off x="3800776" y="1198545"/>
+            <a:ext cx="2533853" cy="38100"/>
+          </a:xfrm>
+          <a:prstGeom prst="rect">
+            <a:avLst/>
+          </a:prstGeom>
+          <a:solidFill>
+            <a:srgbClr val="4C72B0"/>
           </a:solidFill>
           <a:ln>
             <a:noFill/>
@@ -7175,7 +7175,777 @@
         </p:nvSpPr>
         <p:spPr>
           <a:xfrm>
-            <a:off x="5526336" y="1169416"/>
+            <a:off x="4221837" y="1162731"/>
+            <a:ext cx="109728" cy="109728"/>
+          </a:xfrm>
+          <a:prstGeom prst="diamond">
+            <a:avLst/>
+          </a:prstGeom>
+          <a:solidFill>
+            <a:srgbClr val="4C72B0"/>
+          </a:solidFill>
+          <a:ln>
+            <a:solidFill>
+              <a:srgbClr val="4C72B0"/>
+            </a:solidFill>
+          </a:ln>
+        </p:spPr>
+        <p:style>
+          <a:lnRef idx="1">
+            <a:schemeClr val="accent1"/>
+          </a:lnRef>
+          <a:fillRef idx="3">
+            <a:schemeClr val="accent1"/>
+          </a:fillRef>
+          <a:effectRef idx="2">
+            <a:schemeClr val="accent1"/>
+          </a:effectRef>
+          <a:fontRef idx="minor">
+            <a:schemeClr val="lt1"/>
+          </a:fontRef>
+        </p:style>
+        <p:txBody>
+          <a:bodyPr rtlCol="0" anchor="ctr"/>
+          <a:lstStyle/>
+          <a:p>
+            <a:pPr algn="ctr"/>
+          </a:p>
+        </p:txBody>
+      </p:sp>
+      <p:sp>
+        <p:nvSpPr>
+          <p:cNvPr id="9" name="TextBox 8"/>
+          <p:cNvSpPr txBox="1"/>
+          <p:nvPr/>
+        </p:nvSpPr>
+        <p:spPr>
+          <a:xfrm>
+            <a:off x="10607040" y="1107867"/>
+            <a:ext cx="1371600" cy="228600"/>
+          </a:xfrm>
+          <a:prstGeom prst="rect">
+            <a:avLst/>
+          </a:prstGeom>
+          <a:noFill/>
+        </p:spPr>
+        <p:txBody>
+          <a:bodyPr wrap="none">
+            <a:spAutoFit/>
+          </a:bodyPr>
+          <a:lstStyle/>
+          <a:p>
+            <a:pPr>
+              <a:defRPr sz="700">
+                <a:solidFill>
+                  <a:srgbClr val="4C72B0"/>
+                </a:solidFill>
+              </a:defRPr>
+            </a:pPr>
+            <a:r>
+              <a:t>OR 3.48 [0.81–15.06] P=0.095</a:t>
+            </a:r>
+          </a:p>
+        </p:txBody>
+      </p:sp>
+      <p:sp>
+        <p:nvSpPr>
+          <p:cNvPr id="10" name="TextBox 9"/>
+          <p:cNvSpPr txBox="1"/>
+          <p:nvPr/>
+        </p:nvSpPr>
+        <p:spPr>
+          <a:xfrm>
+            <a:off x="274320" y="1321067"/>
+            <a:ext cx="3200400" cy="274320"/>
+          </a:xfrm>
+          <a:prstGeom prst="rect">
+            <a:avLst/>
+          </a:prstGeom>
+          <a:noFill/>
+        </p:spPr>
+        <p:txBody>
+          <a:bodyPr wrap="square">
+            <a:spAutoFit/>
+          </a:bodyPr>
+          <a:lstStyle/>
+          <a:p>
+            <a:pPr algn="r">
+              <a:defRPr sz="800"/>
+            </a:pPr>
+            <a:r>
+              <a:t>Full minus Surgery time (per min)</a:t>
+            </a:r>
+          </a:p>
+        </p:txBody>
+      </p:sp>
+      <p:sp>
+        <p:nvSpPr>
+          <p:cNvPr id="11" name="Rectangle 10"/>
+          <p:cNvSpPr/>
+          <p:nvPr/>
+        </p:nvSpPr>
+        <p:spPr>
+          <a:xfrm>
+            <a:off x="3757472" y="1439177"/>
+            <a:ext cx="2989223" cy="38100"/>
+          </a:xfrm>
+          <a:prstGeom prst="rect">
+            <a:avLst/>
+          </a:prstGeom>
+          <a:solidFill>
+            <a:srgbClr val="4C72B0"/>
+          </a:solidFill>
+          <a:ln>
+            <a:noFill/>
+          </a:ln>
+        </p:spPr>
+        <p:style>
+          <a:lnRef idx="1">
+            <a:schemeClr val="accent1"/>
+          </a:lnRef>
+          <a:fillRef idx="3">
+            <a:schemeClr val="accent1"/>
+          </a:fillRef>
+          <a:effectRef idx="2">
+            <a:schemeClr val="accent1"/>
+          </a:effectRef>
+          <a:fontRef idx="minor">
+            <a:schemeClr val="lt1"/>
+          </a:fontRef>
+        </p:style>
+        <p:txBody>
+          <a:bodyPr rtlCol="0" anchor="ctr"/>
+          <a:lstStyle/>
+          <a:p>
+            <a:pPr algn="ctr"/>
+          </a:p>
+        </p:txBody>
+      </p:sp>
+      <p:sp>
+        <p:nvSpPr>
+          <p:cNvPr id="12" name="Diamond 11"/>
+          <p:cNvSpPr/>
+          <p:nvPr/>
+        </p:nvSpPr>
+        <p:spPr>
+          <a:xfrm>
+            <a:off x="4158177" y="1403363"/>
+            <a:ext cx="109728" cy="109728"/>
+          </a:xfrm>
+          <a:prstGeom prst="diamond">
+            <a:avLst/>
+          </a:prstGeom>
+          <a:solidFill>
+            <a:srgbClr val="4C72B0"/>
+          </a:solidFill>
+          <a:ln>
+            <a:solidFill>
+              <a:srgbClr val="4C72B0"/>
+            </a:solidFill>
+          </a:ln>
+        </p:spPr>
+        <p:style>
+          <a:lnRef idx="1">
+            <a:schemeClr val="accent1"/>
+          </a:lnRef>
+          <a:fillRef idx="3">
+            <a:schemeClr val="accent1"/>
+          </a:fillRef>
+          <a:effectRef idx="2">
+            <a:schemeClr val="accent1"/>
+          </a:effectRef>
+          <a:fontRef idx="minor">
+            <a:schemeClr val="lt1"/>
+          </a:fontRef>
+        </p:style>
+        <p:txBody>
+          <a:bodyPr rtlCol="0" anchor="ctr"/>
+          <a:lstStyle/>
+          <a:p>
+            <a:pPr algn="ctr"/>
+          </a:p>
+        </p:txBody>
+      </p:sp>
+      <p:sp>
+        <p:nvSpPr>
+          <p:cNvPr id="13" name="TextBox 12"/>
+          <p:cNvSpPr txBox="1"/>
+          <p:nvPr/>
+        </p:nvSpPr>
+        <p:spPr>
+          <a:xfrm>
+            <a:off x="10607040" y="1348499"/>
+            <a:ext cx="1371600" cy="228600"/>
+          </a:xfrm>
+          <a:prstGeom prst="rect">
+            <a:avLst/>
+          </a:prstGeom>
+          <a:noFill/>
+        </p:spPr>
+        <p:txBody>
+          <a:bodyPr wrap="none">
+            <a:spAutoFit/>
+          </a:bodyPr>
+          <a:lstStyle/>
+          <a:p>
+            <a:pPr>
+              <a:defRPr sz="700">
+                <a:solidFill>
+                  <a:srgbClr val="4C72B0"/>
+                </a:solidFill>
+              </a:defRPr>
+            </a:pPr>
+            <a:r>
+              <a:t>OR 3.12 [0.56–17.38] P=0.193</a:t>
+            </a:r>
+          </a:p>
+        </p:txBody>
+      </p:sp>
+      <p:sp>
+        <p:nvSpPr>
+          <p:cNvPr id="14" name="TextBox 13"/>
+          <p:cNvSpPr txBox="1"/>
+          <p:nvPr/>
+        </p:nvSpPr>
+        <p:spPr>
+          <a:xfrm>
+            <a:off x="274320" y="1561698"/>
+            <a:ext cx="3200400" cy="274320"/>
+          </a:xfrm>
+          <a:prstGeom prst="rect">
+            <a:avLst/>
+          </a:prstGeom>
+          <a:noFill/>
+        </p:spPr>
+        <p:txBody>
+          <a:bodyPr wrap="square">
+            <a:spAutoFit/>
+          </a:bodyPr>
+          <a:lstStyle/>
+          <a:p>
+            <a:pPr algn="r">
+              <a:defRPr sz="800"/>
+            </a:pPr>
+            <a:r>
+              <a:t>Full minus Epidural anesthesia</a:t>
+            </a:r>
+          </a:p>
+        </p:txBody>
+      </p:sp>
+      <p:sp>
+        <p:nvSpPr>
+          <p:cNvPr id="15" name="Rectangle 14"/>
+          <p:cNvSpPr/>
+          <p:nvPr/>
+        </p:nvSpPr>
+        <p:spPr>
+          <a:xfrm>
+            <a:off x="3787858" y="1679808"/>
+            <a:ext cx="3580687" cy="38100"/>
+          </a:xfrm>
+          <a:prstGeom prst="rect">
+            <a:avLst/>
+          </a:prstGeom>
+          <a:solidFill>
+            <a:srgbClr val="4C72B0"/>
+          </a:solidFill>
+          <a:ln>
+            <a:noFill/>
+          </a:ln>
+        </p:spPr>
+        <p:style>
+          <a:lnRef idx="1">
+            <a:schemeClr val="accent1"/>
+          </a:lnRef>
+          <a:fillRef idx="3">
+            <a:schemeClr val="accent1"/>
+          </a:fillRef>
+          <a:effectRef idx="2">
+            <a:schemeClr val="accent1"/>
+          </a:effectRef>
+          <a:fontRef idx="minor">
+            <a:schemeClr val="lt1"/>
+          </a:fontRef>
+        </p:style>
+        <p:txBody>
+          <a:bodyPr rtlCol="0" anchor="ctr"/>
+          <a:lstStyle/>
+          <a:p>
+            <a:pPr algn="ctr"/>
+          </a:p>
+        </p:txBody>
+      </p:sp>
+      <p:sp>
+        <p:nvSpPr>
+          <p:cNvPr id="16" name="Diamond 15"/>
+          <p:cNvSpPr/>
+          <p:nvPr/>
+        </p:nvSpPr>
+        <p:spPr>
+          <a:xfrm>
+            <a:off x="4297992" y="1643994"/>
+            <a:ext cx="109728" cy="109728"/>
+          </a:xfrm>
+          <a:prstGeom prst="diamond">
+            <a:avLst/>
+          </a:prstGeom>
+          <a:solidFill>
+            <a:srgbClr val="4C72B0"/>
+          </a:solidFill>
+          <a:ln>
+            <a:solidFill>
+              <a:srgbClr val="4C72B0"/>
+            </a:solidFill>
+          </a:ln>
+        </p:spPr>
+        <p:style>
+          <a:lnRef idx="1">
+            <a:schemeClr val="accent1"/>
+          </a:lnRef>
+          <a:fillRef idx="3">
+            <a:schemeClr val="accent1"/>
+          </a:fillRef>
+          <a:effectRef idx="2">
+            <a:schemeClr val="accent1"/>
+          </a:effectRef>
+          <a:fontRef idx="minor">
+            <a:schemeClr val="lt1"/>
+          </a:fontRef>
+        </p:style>
+        <p:txBody>
+          <a:bodyPr rtlCol="0" anchor="ctr"/>
+          <a:lstStyle/>
+          <a:p>
+            <a:pPr algn="ctr"/>
+          </a:p>
+        </p:txBody>
+      </p:sp>
+      <p:sp>
+        <p:nvSpPr>
+          <p:cNvPr id="17" name="TextBox 16"/>
+          <p:cNvSpPr txBox="1"/>
+          <p:nvPr/>
+        </p:nvSpPr>
+        <p:spPr>
+          <a:xfrm>
+            <a:off x="10607040" y="1589130"/>
+            <a:ext cx="1371600" cy="228600"/>
+          </a:xfrm>
+          <a:prstGeom prst="rect">
+            <a:avLst/>
+          </a:prstGeom>
+          <a:noFill/>
+        </p:spPr>
+        <p:txBody>
+          <a:bodyPr wrap="none">
+            <a:spAutoFit/>
+          </a:bodyPr>
+          <a:lstStyle/>
+          <a:p>
+            <a:pPr>
+              <a:defRPr sz="700">
+                <a:solidFill>
+                  <a:srgbClr val="4C72B0"/>
+                </a:solidFill>
+              </a:defRPr>
+            </a:pPr>
+            <a:r>
+              <a:t>OR 3.91 [0.73–20.87] P=0.110</a:t>
+            </a:r>
+          </a:p>
+        </p:txBody>
+      </p:sp>
+      <p:sp>
+        <p:nvSpPr>
+          <p:cNvPr id="18" name="TextBox 17"/>
+          <p:cNvSpPr txBox="1"/>
+          <p:nvPr/>
+        </p:nvSpPr>
+        <p:spPr>
+          <a:xfrm>
+            <a:off x="274320" y="1802330"/>
+            <a:ext cx="3200400" cy="274320"/>
+          </a:xfrm>
+          <a:prstGeom prst="rect">
+            <a:avLst/>
+          </a:prstGeom>
+          <a:noFill/>
+        </p:spPr>
+        <p:txBody>
+          <a:bodyPr wrap="square">
+            <a:spAutoFit/>
+          </a:bodyPr>
+          <a:lstStyle/>
+          <a:p>
+            <a:pPr algn="r">
+              <a:defRPr sz="800"/>
+            </a:pPr>
+            <a:r>
+              <a:t>Full minus HDP</a:t>
+            </a:r>
+          </a:p>
+        </p:txBody>
+      </p:sp>
+      <p:sp>
+        <p:nvSpPr>
+          <p:cNvPr id="19" name="Rectangle 18"/>
+          <p:cNvSpPr/>
+          <p:nvPr/>
+        </p:nvSpPr>
+        <p:spPr>
+          <a:xfrm>
+            <a:off x="3767164" y="1920440"/>
+            <a:ext cx="3138097" cy="38100"/>
+          </a:xfrm>
+          <a:prstGeom prst="rect">
+            <a:avLst/>
+          </a:prstGeom>
+          <a:solidFill>
+            <a:srgbClr val="4C72B0"/>
+          </a:solidFill>
+          <a:ln>
+            <a:noFill/>
+          </a:ln>
+        </p:spPr>
+        <p:style>
+          <a:lnRef idx="1">
+            <a:schemeClr val="accent1"/>
+          </a:lnRef>
+          <a:fillRef idx="3">
+            <a:schemeClr val="accent1"/>
+          </a:fillRef>
+          <a:effectRef idx="2">
+            <a:schemeClr val="accent1"/>
+          </a:effectRef>
+          <a:fontRef idx="minor">
+            <a:schemeClr val="lt1"/>
+          </a:fontRef>
+        </p:style>
+        <p:txBody>
+          <a:bodyPr rtlCol="0" anchor="ctr"/>
+          <a:lstStyle/>
+          <a:p>
+            <a:pPr algn="ctr"/>
+          </a:p>
+        </p:txBody>
+      </p:sp>
+      <p:sp>
+        <p:nvSpPr>
+          <p:cNvPr id="20" name="Diamond 19"/>
+          <p:cNvSpPr/>
+          <p:nvPr/>
+        </p:nvSpPr>
+        <p:spPr>
+          <a:xfrm>
+            <a:off x="4199249" y="1884626"/>
+            <a:ext cx="109728" cy="109728"/>
+          </a:xfrm>
+          <a:prstGeom prst="diamond">
+            <a:avLst/>
+          </a:prstGeom>
+          <a:solidFill>
+            <a:srgbClr val="4C72B0"/>
+          </a:solidFill>
+          <a:ln>
+            <a:solidFill>
+              <a:srgbClr val="4C72B0"/>
+            </a:solidFill>
+          </a:ln>
+        </p:spPr>
+        <p:style>
+          <a:lnRef idx="1">
+            <a:schemeClr val="accent1"/>
+          </a:lnRef>
+          <a:fillRef idx="3">
+            <a:schemeClr val="accent1"/>
+          </a:fillRef>
+          <a:effectRef idx="2">
+            <a:schemeClr val="accent1"/>
+          </a:effectRef>
+          <a:fontRef idx="minor">
+            <a:schemeClr val="lt1"/>
+          </a:fontRef>
+        </p:style>
+        <p:txBody>
+          <a:bodyPr rtlCol="0" anchor="ctr"/>
+          <a:lstStyle/>
+          <a:p>
+            <a:pPr algn="ctr"/>
+          </a:p>
+        </p:txBody>
+      </p:sp>
+      <p:sp>
+        <p:nvSpPr>
+          <p:cNvPr id="21" name="TextBox 20"/>
+          <p:cNvSpPr txBox="1"/>
+          <p:nvPr/>
+        </p:nvSpPr>
+        <p:spPr>
+          <a:xfrm>
+            <a:off x="10607040" y="1829762"/>
+            <a:ext cx="1371600" cy="228600"/>
+          </a:xfrm>
+          <a:prstGeom prst="rect">
+            <a:avLst/>
+          </a:prstGeom>
+          <a:noFill/>
+        </p:spPr>
+        <p:txBody>
+          <a:bodyPr wrap="none">
+            <a:spAutoFit/>
+          </a:bodyPr>
+          <a:lstStyle/>
+          <a:p>
+            <a:pPr>
+              <a:defRPr sz="700">
+                <a:solidFill>
+                  <a:srgbClr val="4C72B0"/>
+                </a:solidFill>
+              </a:defRPr>
+            </a:pPr>
+            <a:r>
+              <a:t>OR 3.36 [0.62–18.27] P=0.161</a:t>
+            </a:r>
+          </a:p>
+        </p:txBody>
+      </p:sp>
+      <p:sp>
+        <p:nvSpPr>
+          <p:cNvPr id="22" name="TextBox 21"/>
+          <p:cNvSpPr txBox="1"/>
+          <p:nvPr/>
+        </p:nvSpPr>
+        <p:spPr>
+          <a:xfrm>
+            <a:off x="274320" y="2042962"/>
+            <a:ext cx="3200400" cy="274320"/>
+          </a:xfrm>
+          <a:prstGeom prst="rect">
+            <a:avLst/>
+          </a:prstGeom>
+          <a:noFill/>
+        </p:spPr>
+        <p:txBody>
+          <a:bodyPr wrap="square">
+            <a:spAutoFit/>
+          </a:bodyPr>
+          <a:lstStyle/>
+          <a:p>
+            <a:pPr algn="r">
+              <a:defRPr sz="800"/>
+            </a:pPr>
+            <a:r>
+              <a:t>Full minus Prior CS</a:t>
+            </a:r>
+          </a:p>
+        </p:txBody>
+      </p:sp>
+      <p:sp>
+        <p:nvSpPr>
+          <p:cNvPr id="23" name="Rectangle 22"/>
+          <p:cNvSpPr/>
+          <p:nvPr/>
+        </p:nvSpPr>
+        <p:spPr>
+          <a:xfrm>
+            <a:off x="3801489" y="2161072"/>
+            <a:ext cx="2798862" cy="38100"/>
+          </a:xfrm>
+          <a:prstGeom prst="rect">
+            <a:avLst/>
+          </a:prstGeom>
+          <a:solidFill>
+            <a:srgbClr val="4C72B0"/>
+          </a:solidFill>
+          <a:ln>
+            <a:noFill/>
+          </a:ln>
+        </p:spPr>
+        <p:style>
+          <a:lnRef idx="1">
+            <a:schemeClr val="accent1"/>
+          </a:lnRef>
+          <a:fillRef idx="3">
+            <a:schemeClr val="accent1"/>
+          </a:fillRef>
+          <a:effectRef idx="2">
+            <a:schemeClr val="accent1"/>
+          </a:effectRef>
+          <a:fontRef idx="minor">
+            <a:schemeClr val="lt1"/>
+          </a:fontRef>
+        </p:style>
+        <p:txBody>
+          <a:bodyPr rtlCol="0" anchor="ctr"/>
+          <a:lstStyle/>
+          <a:p>
+            <a:pPr algn="ctr"/>
+          </a:p>
+        </p:txBody>
+      </p:sp>
+      <p:sp>
+        <p:nvSpPr>
+          <p:cNvPr id="24" name="Diamond 23"/>
+          <p:cNvSpPr/>
+          <p:nvPr/>
+        </p:nvSpPr>
+        <p:spPr>
+          <a:xfrm>
+            <a:off x="4253452" y="2125258"/>
+            <a:ext cx="109728" cy="109728"/>
+          </a:xfrm>
+          <a:prstGeom prst="diamond">
+            <a:avLst/>
+          </a:prstGeom>
+          <a:solidFill>
+            <a:srgbClr val="4C72B0"/>
+          </a:solidFill>
+          <a:ln>
+            <a:solidFill>
+              <a:srgbClr val="4C72B0"/>
+            </a:solidFill>
+          </a:ln>
+        </p:spPr>
+        <p:style>
+          <a:lnRef idx="1">
+            <a:schemeClr val="accent1"/>
+          </a:lnRef>
+          <a:fillRef idx="3">
+            <a:schemeClr val="accent1"/>
+          </a:fillRef>
+          <a:effectRef idx="2">
+            <a:schemeClr val="accent1"/>
+          </a:effectRef>
+          <a:fontRef idx="minor">
+            <a:schemeClr val="lt1"/>
+          </a:fontRef>
+        </p:style>
+        <p:txBody>
+          <a:bodyPr rtlCol="0" anchor="ctr"/>
+          <a:lstStyle/>
+          <a:p>
+            <a:pPr algn="ctr"/>
+          </a:p>
+        </p:txBody>
+      </p:sp>
+      <p:sp>
+        <p:nvSpPr>
+          <p:cNvPr id="25" name="TextBox 24"/>
+          <p:cNvSpPr txBox="1"/>
+          <p:nvPr/>
+        </p:nvSpPr>
+        <p:spPr>
+          <a:xfrm>
+            <a:off x="10607040" y="2070394"/>
+            <a:ext cx="1371600" cy="228600"/>
+          </a:xfrm>
+          <a:prstGeom prst="rect">
+            <a:avLst/>
+          </a:prstGeom>
+          <a:noFill/>
+        </p:spPr>
+        <p:txBody>
+          <a:bodyPr wrap="none">
+            <a:spAutoFit/>
+          </a:bodyPr>
+          <a:lstStyle/>
+          <a:p>
+            <a:pPr>
+              <a:defRPr sz="700">
+                <a:solidFill>
+                  <a:srgbClr val="4C72B0"/>
+                </a:solidFill>
+              </a:defRPr>
+            </a:pPr>
+            <a:r>
+              <a:t>OR 3.66 [0.81–16.55] P=0.092</a:t>
+            </a:r>
+          </a:p>
+        </p:txBody>
+      </p:sp>
+      <p:sp>
+        <p:nvSpPr>
+          <p:cNvPr id="26" name="TextBox 25"/>
+          <p:cNvSpPr txBox="1"/>
+          <p:nvPr/>
+        </p:nvSpPr>
+        <p:spPr>
+          <a:xfrm>
+            <a:off x="274320" y="2283593"/>
+            <a:ext cx="3200400" cy="274320"/>
+          </a:xfrm>
+          <a:prstGeom prst="rect">
+            <a:avLst/>
+          </a:prstGeom>
+          <a:noFill/>
+        </p:spPr>
+        <p:txBody>
+          <a:bodyPr wrap="square">
+            <a:spAutoFit/>
+          </a:bodyPr>
+          <a:lstStyle/>
+          <a:p>
+            <a:pPr algn="r">
+              <a:defRPr sz="800"/>
+            </a:pPr>
+            <a:r>
+              <a:t>Full minus Emergency CS</a:t>
+            </a:r>
+          </a:p>
+        </p:txBody>
+      </p:sp>
+      <p:sp>
+        <p:nvSpPr>
+          <p:cNvPr id="27" name="Rectangle 26"/>
+          <p:cNvSpPr/>
+          <p:nvPr/>
+        </p:nvSpPr>
+        <p:spPr>
+          <a:xfrm>
+            <a:off x="3870598" y="2401703"/>
+            <a:ext cx="5062386" cy="38100"/>
+          </a:xfrm>
+          <a:prstGeom prst="rect">
+            <a:avLst/>
+          </a:prstGeom>
+          <a:solidFill>
+            <a:srgbClr val="C44E52"/>
+          </a:solidFill>
+          <a:ln>
+            <a:noFill/>
+          </a:ln>
+        </p:spPr>
+        <p:style>
+          <a:lnRef idx="1">
+            <a:schemeClr val="accent1"/>
+          </a:lnRef>
+          <a:fillRef idx="3">
+            <a:schemeClr val="accent1"/>
+          </a:fillRef>
+          <a:effectRef idx="2">
+            <a:schemeClr val="accent1"/>
+          </a:effectRef>
+          <a:fontRef idx="minor">
+            <a:schemeClr val="lt1"/>
+          </a:fontRef>
+        </p:style>
+        <p:txBody>
+          <a:bodyPr rtlCol="0" anchor="ctr"/>
+          <a:lstStyle/>
+          <a:p>
+            <a:pPr algn="ctr"/>
+          </a:p>
+        </p:txBody>
+      </p:sp>
+      <p:sp>
+        <p:nvSpPr>
+          <p:cNvPr id="28" name="Diamond 27"/>
+          <p:cNvSpPr/>
+          <p:nvPr/>
+        </p:nvSpPr>
+        <p:spPr>
+          <a:xfrm>
+            <a:off x="4662759" y="2365889"/>
             <a:ext cx="109728" cy="109728"/>
           </a:xfrm>
           <a:prstGeom prst="diamond">
@@ -7214,13 +7984,13 @@
       </p:sp>
       <p:sp>
         <p:nvSpPr>
-          <p:cNvPr id="9" name="TextBox 8"/>
+          <p:cNvPr id="29" name="TextBox 28"/>
           <p:cNvSpPr txBox="1"/>
           <p:nvPr/>
         </p:nvSpPr>
         <p:spPr>
           <a:xfrm>
-            <a:off x="10607040" y="1114552"/>
+            <a:off x="10607040" y="2311025"/>
             <a:ext cx="1371600" cy="228600"/>
           </a:xfrm>
           <a:prstGeom prst="rect">
@@ -7242,20 +8012,20 @@
               </a:defRPr>
             </a:pPr>
             <a:r>
-              <a:t>OR 3.18 [1.38–7.36] P=0.007**</a:t>
-            </a:r>
-          </a:p>
-        </p:txBody>
-      </p:sp>
-      <p:sp>
-        <p:nvSpPr>
-          <p:cNvPr id="10" name="TextBox 9"/>
+              <a:t>OR 5.96 [1.20–29.68] P=0.029*</a:t>
+            </a:r>
+          </a:p>
+        </p:txBody>
+      </p:sp>
+      <p:sp>
+        <p:nvSpPr>
+          <p:cNvPr id="30" name="TextBox 29"/>
           <p:cNvSpPr txBox="1"/>
           <p:nvPr/>
         </p:nvSpPr>
         <p:spPr>
           <a:xfrm>
-            <a:off x="274320" y="1341120"/>
+            <a:off x="274320" y="2524225"/>
             <a:ext cx="3200400" cy="274320"/>
           </a:xfrm>
           <a:prstGeom prst="rect">
@@ -7273,27 +8043,27 @@
               <a:defRPr sz="800"/>
             </a:pPr>
             <a:r>
-              <a:t>Full minus Hypotension (SBP &lt; 90)</a:t>
-            </a:r>
-          </a:p>
-        </p:txBody>
-      </p:sp>
-      <p:sp>
-        <p:nvSpPr>
-          <p:cNvPr id="11" name="Rectangle 10"/>
-          <p:cNvSpPr/>
-          <p:nvPr/>
-        </p:nvSpPr>
-        <p:spPr>
-          <a:xfrm>
-            <a:off x="4371826" y="1459230"/>
-            <a:ext cx="3712687" cy="38100"/>
-          </a:xfrm>
-          <a:prstGeom prst="rect">
-            <a:avLst/>
-          </a:prstGeom>
-          <a:solidFill>
-            <a:srgbClr val="C44E52"/>
+              <a:t>Full minus GA (per week)</a:t>
+            </a:r>
+          </a:p>
+        </p:txBody>
+      </p:sp>
+      <p:sp>
+        <p:nvSpPr>
+          <p:cNvPr id="31" name="Rectangle 30"/>
+          <p:cNvSpPr/>
+          <p:nvPr/>
+        </p:nvSpPr>
+        <p:spPr>
+          <a:xfrm>
+            <a:off x="3775511" y="2642335"/>
+            <a:ext cx="3325562" cy="38100"/>
+          </a:xfrm>
+          <a:prstGeom prst="rect">
+            <a:avLst/>
+          </a:prstGeom>
+          <a:solidFill>
+            <a:srgbClr val="4C72B0"/>
           </a:solidFill>
           <a:ln>
             <a:noFill/>
@@ -7323,13 +8093,475 @@
       </p:sp>
       <p:sp>
         <p:nvSpPr>
-          <p:cNvPr id="12" name="Diamond 11"/>
-          <p:cNvSpPr/>
-          <p:nvPr/>
-        </p:nvSpPr>
-        <p:spPr>
-          <a:xfrm>
-            <a:off x="5380886" y="1423416"/>
+          <p:cNvPr id="32" name="Diamond 31"/>
+          <p:cNvSpPr/>
+          <p:nvPr/>
+        </p:nvSpPr>
+        <p:spPr>
+          <a:xfrm>
+            <a:off x="4239937" y="2606521"/>
+            <a:ext cx="109728" cy="109728"/>
+          </a:xfrm>
+          <a:prstGeom prst="diamond">
+            <a:avLst/>
+          </a:prstGeom>
+          <a:solidFill>
+            <a:srgbClr val="4C72B0"/>
+          </a:solidFill>
+          <a:ln>
+            <a:solidFill>
+              <a:srgbClr val="4C72B0"/>
+            </a:solidFill>
+          </a:ln>
+        </p:spPr>
+        <p:style>
+          <a:lnRef idx="1">
+            <a:schemeClr val="accent1"/>
+          </a:lnRef>
+          <a:fillRef idx="3">
+            <a:schemeClr val="accent1"/>
+          </a:fillRef>
+          <a:effectRef idx="2">
+            <a:schemeClr val="accent1"/>
+          </a:effectRef>
+          <a:fontRef idx="minor">
+            <a:schemeClr val="lt1"/>
+          </a:fontRef>
+        </p:style>
+        <p:txBody>
+          <a:bodyPr rtlCol="0" anchor="ctr"/>
+          <a:lstStyle/>
+          <a:p>
+            <a:pPr algn="ctr"/>
+          </a:p>
+        </p:txBody>
+      </p:sp>
+      <p:sp>
+        <p:nvSpPr>
+          <p:cNvPr id="33" name="TextBox 32"/>
+          <p:cNvSpPr txBox="1"/>
+          <p:nvPr/>
+        </p:nvSpPr>
+        <p:spPr>
+          <a:xfrm>
+            <a:off x="10607040" y="2551657"/>
+            <a:ext cx="1371600" cy="228600"/>
+          </a:xfrm>
+          <a:prstGeom prst="rect">
+            <a:avLst/>
+          </a:prstGeom>
+          <a:noFill/>
+        </p:spPr>
+        <p:txBody>
+          <a:bodyPr wrap="none">
+            <a:spAutoFit/>
+          </a:bodyPr>
+          <a:lstStyle/>
+          <a:p>
+            <a:pPr>
+              <a:defRPr sz="700">
+                <a:solidFill>
+                  <a:srgbClr val="4C72B0"/>
+                </a:solidFill>
+              </a:defRPr>
+            </a:pPr>
+            <a:r>
+              <a:t>OR 3.58 [0.66–19.37] P=0.138</a:t>
+            </a:r>
+          </a:p>
+        </p:txBody>
+      </p:sp>
+      <p:sp>
+        <p:nvSpPr>
+          <p:cNvPr id="34" name="TextBox 33"/>
+          <p:cNvSpPr txBox="1"/>
+          <p:nvPr/>
+        </p:nvSpPr>
+        <p:spPr>
+          <a:xfrm>
+            <a:off x="274320" y="2764856"/>
+            <a:ext cx="3200400" cy="274320"/>
+          </a:xfrm>
+          <a:prstGeom prst="rect">
+            <a:avLst/>
+          </a:prstGeom>
+          <a:noFill/>
+        </p:spPr>
+        <p:txBody>
+          <a:bodyPr wrap="square">
+            <a:spAutoFit/>
+          </a:bodyPr>
+          <a:lstStyle/>
+          <a:p>
+            <a:pPr algn="r">
+              <a:defRPr sz="800"/>
+            </a:pPr>
+            <a:r>
+              <a:t>Full minus BMI (per kg/m²)</a:t>
+            </a:r>
+          </a:p>
+        </p:txBody>
+      </p:sp>
+      <p:sp>
+        <p:nvSpPr>
+          <p:cNvPr id="35" name="Rectangle 34"/>
+          <p:cNvSpPr/>
+          <p:nvPr/>
+        </p:nvSpPr>
+        <p:spPr>
+          <a:xfrm>
+            <a:off x="3766054" y="2882966"/>
+            <a:ext cx="3164158" cy="38100"/>
+          </a:xfrm>
+          <a:prstGeom prst="rect">
+            <a:avLst/>
+          </a:prstGeom>
+          <a:solidFill>
+            <a:srgbClr val="4C72B0"/>
+          </a:solidFill>
+          <a:ln>
+            <a:noFill/>
+          </a:ln>
+        </p:spPr>
+        <p:style>
+          <a:lnRef idx="1">
+            <a:schemeClr val="accent1"/>
+          </a:lnRef>
+          <a:fillRef idx="3">
+            <a:schemeClr val="accent1"/>
+          </a:fillRef>
+          <a:effectRef idx="2">
+            <a:schemeClr val="accent1"/>
+          </a:effectRef>
+          <a:fontRef idx="minor">
+            <a:schemeClr val="lt1"/>
+          </a:fontRef>
+        </p:style>
+        <p:txBody>
+          <a:bodyPr rtlCol="0" anchor="ctr"/>
+          <a:lstStyle/>
+          <a:p>
+            <a:pPr algn="ctr"/>
+          </a:p>
+        </p:txBody>
+      </p:sp>
+      <p:sp>
+        <p:nvSpPr>
+          <p:cNvPr id="36" name="Diamond 35"/>
+          <p:cNvSpPr/>
+          <p:nvPr/>
+        </p:nvSpPr>
+        <p:spPr>
+          <a:xfrm>
+            <a:off x="4198496" y="2847152"/>
+            <a:ext cx="109728" cy="109728"/>
+          </a:xfrm>
+          <a:prstGeom prst="diamond">
+            <a:avLst/>
+          </a:prstGeom>
+          <a:solidFill>
+            <a:srgbClr val="4C72B0"/>
+          </a:solidFill>
+          <a:ln>
+            <a:solidFill>
+              <a:srgbClr val="4C72B0"/>
+            </a:solidFill>
+          </a:ln>
+        </p:spPr>
+        <p:style>
+          <a:lnRef idx="1">
+            <a:schemeClr val="accent1"/>
+          </a:lnRef>
+          <a:fillRef idx="3">
+            <a:schemeClr val="accent1"/>
+          </a:fillRef>
+          <a:effectRef idx="2">
+            <a:schemeClr val="accent1"/>
+          </a:effectRef>
+          <a:fontRef idx="minor">
+            <a:schemeClr val="lt1"/>
+          </a:fontRef>
+        </p:style>
+        <p:txBody>
+          <a:bodyPr rtlCol="0" anchor="ctr"/>
+          <a:lstStyle/>
+          <a:p>
+            <a:pPr algn="ctr"/>
+          </a:p>
+        </p:txBody>
+      </p:sp>
+      <p:sp>
+        <p:nvSpPr>
+          <p:cNvPr id="37" name="TextBox 36"/>
+          <p:cNvSpPr txBox="1"/>
+          <p:nvPr/>
+        </p:nvSpPr>
+        <p:spPr>
+          <a:xfrm>
+            <a:off x="10607040" y="2792288"/>
+            <a:ext cx="1371600" cy="228600"/>
+          </a:xfrm>
+          <a:prstGeom prst="rect">
+            <a:avLst/>
+          </a:prstGeom>
+          <a:noFill/>
+        </p:spPr>
+        <p:txBody>
+          <a:bodyPr wrap="none">
+            <a:spAutoFit/>
+          </a:bodyPr>
+          <a:lstStyle/>
+          <a:p>
+            <a:pPr>
+              <a:defRPr sz="700">
+                <a:solidFill>
+                  <a:srgbClr val="4C72B0"/>
+                </a:solidFill>
+              </a:defRPr>
+            </a:pPr>
+            <a:r>
+              <a:t>OR 3.35 [0.61–18.41] P=0.164</a:t>
+            </a:r>
+          </a:p>
+        </p:txBody>
+      </p:sp>
+      <p:sp>
+        <p:nvSpPr>
+          <p:cNvPr id="38" name="TextBox 37"/>
+          <p:cNvSpPr txBox="1"/>
+          <p:nvPr/>
+        </p:nvSpPr>
+        <p:spPr>
+          <a:xfrm>
+            <a:off x="274320" y="3005488"/>
+            <a:ext cx="3200400" cy="274320"/>
+          </a:xfrm>
+          <a:prstGeom prst="rect">
+            <a:avLst/>
+          </a:prstGeom>
+          <a:noFill/>
+        </p:spPr>
+        <p:txBody>
+          <a:bodyPr wrap="square">
+            <a:spAutoFit/>
+          </a:bodyPr>
+          <a:lstStyle/>
+          <a:p>
+            <a:pPr algn="r">
+              <a:defRPr sz="800"/>
+            </a:pPr>
+            <a:r>
+              <a:t>Full minus Age (per year)</a:t>
+            </a:r>
+          </a:p>
+        </p:txBody>
+      </p:sp>
+      <p:sp>
+        <p:nvSpPr>
+          <p:cNvPr id="39" name="Rectangle 38"/>
+          <p:cNvSpPr/>
+          <p:nvPr/>
+        </p:nvSpPr>
+        <p:spPr>
+          <a:xfrm>
+            <a:off x="3771972" y="3123598"/>
+            <a:ext cx="3283437" cy="38100"/>
+          </a:xfrm>
+          <a:prstGeom prst="rect">
+            <a:avLst/>
+          </a:prstGeom>
+          <a:solidFill>
+            <a:srgbClr val="4C72B0"/>
+          </a:solidFill>
+          <a:ln>
+            <a:noFill/>
+          </a:ln>
+        </p:spPr>
+        <p:style>
+          <a:lnRef idx="1">
+            <a:schemeClr val="accent1"/>
+          </a:lnRef>
+          <a:fillRef idx="3">
+            <a:schemeClr val="accent1"/>
+          </a:fillRef>
+          <a:effectRef idx="2">
+            <a:schemeClr val="accent1"/>
+          </a:effectRef>
+          <a:fontRef idx="minor">
+            <a:schemeClr val="lt1"/>
+          </a:fontRef>
+        </p:style>
+        <p:txBody>
+          <a:bodyPr rtlCol="0" anchor="ctr"/>
+          <a:lstStyle/>
+          <a:p>
+            <a:pPr algn="ctr"/>
+          </a:p>
+        </p:txBody>
+      </p:sp>
+      <p:sp>
+        <p:nvSpPr>
+          <p:cNvPr id="40" name="Diamond 39"/>
+          <p:cNvSpPr/>
+          <p:nvPr/>
+        </p:nvSpPr>
+        <p:spPr>
+          <a:xfrm>
+            <a:off x="4226126" y="3087784"/>
+            <a:ext cx="109728" cy="109728"/>
+          </a:xfrm>
+          <a:prstGeom prst="diamond">
+            <a:avLst/>
+          </a:prstGeom>
+          <a:solidFill>
+            <a:srgbClr val="4C72B0"/>
+          </a:solidFill>
+          <a:ln>
+            <a:solidFill>
+              <a:srgbClr val="4C72B0"/>
+            </a:solidFill>
+          </a:ln>
+        </p:spPr>
+        <p:style>
+          <a:lnRef idx="1">
+            <a:schemeClr val="accent1"/>
+          </a:lnRef>
+          <a:fillRef idx="3">
+            <a:schemeClr val="accent1"/>
+          </a:fillRef>
+          <a:effectRef idx="2">
+            <a:schemeClr val="accent1"/>
+          </a:effectRef>
+          <a:fontRef idx="minor">
+            <a:schemeClr val="lt1"/>
+          </a:fontRef>
+        </p:style>
+        <p:txBody>
+          <a:bodyPr rtlCol="0" anchor="ctr"/>
+          <a:lstStyle/>
+          <a:p>
+            <a:pPr algn="ctr"/>
+          </a:p>
+        </p:txBody>
+      </p:sp>
+      <p:sp>
+        <p:nvSpPr>
+          <p:cNvPr id="41" name="TextBox 40"/>
+          <p:cNvSpPr txBox="1"/>
+          <p:nvPr/>
+        </p:nvSpPr>
+        <p:spPr>
+          <a:xfrm>
+            <a:off x="10607040" y="3032920"/>
+            <a:ext cx="1371600" cy="228600"/>
+          </a:xfrm>
+          <a:prstGeom prst="rect">
+            <a:avLst/>
+          </a:prstGeom>
+          <a:noFill/>
+        </p:spPr>
+        <p:txBody>
+          <a:bodyPr wrap="none">
+            <a:spAutoFit/>
+          </a:bodyPr>
+          <a:lstStyle/>
+          <a:p>
+            <a:pPr>
+              <a:defRPr sz="700">
+                <a:solidFill>
+                  <a:srgbClr val="4C72B0"/>
+                </a:solidFill>
+              </a:defRPr>
+            </a:pPr>
+            <a:r>
+              <a:t>OR 3.51 [0.64–19.11] P=0.147</a:t>
+            </a:r>
+          </a:p>
+        </p:txBody>
+      </p:sp>
+      <p:sp>
+        <p:nvSpPr>
+          <p:cNvPr id="42" name="TextBox 41"/>
+          <p:cNvSpPr txBox="1"/>
+          <p:nvPr/>
+        </p:nvSpPr>
+        <p:spPr>
+          <a:xfrm>
+            <a:off x="274320" y="3246120"/>
+            <a:ext cx="3200400" cy="274320"/>
+          </a:xfrm>
+          <a:prstGeom prst="rect">
+            <a:avLst/>
+          </a:prstGeom>
+          <a:noFill/>
+        </p:spPr>
+        <p:txBody>
+          <a:bodyPr wrap="square">
+            <a:spAutoFit/>
+          </a:bodyPr>
+          <a:lstStyle/>
+          <a:p>
+            <a:pPr algn="r">
+              <a:defRPr sz="800"/>
+            </a:pPr>
+            <a:r>
+              <a:t>Twin + Hypotension (SBP &lt; 90)</a:t>
+            </a:r>
+          </a:p>
+        </p:txBody>
+      </p:sp>
+      <p:sp>
+        <p:nvSpPr>
+          <p:cNvPr id="43" name="Rectangle 42"/>
+          <p:cNvSpPr/>
+          <p:nvPr/>
+        </p:nvSpPr>
+        <p:spPr>
+          <a:xfrm>
+            <a:off x="3845739" y="3364230"/>
+            <a:ext cx="2876483" cy="38100"/>
+          </a:xfrm>
+          <a:prstGeom prst="rect">
+            <a:avLst/>
+          </a:prstGeom>
+          <a:solidFill>
+            <a:srgbClr val="C44E52"/>
+          </a:solidFill>
+          <a:ln>
+            <a:noFill/>
+          </a:ln>
+        </p:spPr>
+        <p:style>
+          <a:lnRef idx="1">
+            <a:schemeClr val="accent1"/>
+          </a:lnRef>
+          <a:fillRef idx="3">
+            <a:schemeClr val="accent1"/>
+          </a:fillRef>
+          <a:effectRef idx="2">
+            <a:schemeClr val="accent1"/>
+          </a:effectRef>
+          <a:fontRef idx="minor">
+            <a:schemeClr val="lt1"/>
+          </a:fontRef>
+        </p:style>
+        <p:txBody>
+          <a:bodyPr rtlCol="0" anchor="ctr"/>
+          <a:lstStyle/>
+          <a:p>
+            <a:pPr algn="ctr"/>
+          </a:p>
+        </p:txBody>
+      </p:sp>
+      <p:sp>
+        <p:nvSpPr>
+          <p:cNvPr id="44" name="Diamond 43"/>
+          <p:cNvSpPr/>
+          <p:nvPr/>
+        </p:nvSpPr>
+        <p:spPr>
+          <a:xfrm>
+            <a:off x="4362062" y="3328416"/>
             <a:ext cx="109728" cy="109728"/>
           </a:xfrm>
           <a:prstGeom prst="diamond">
@@ -7368,13 +8600,13 @@
       </p:sp>
       <p:sp>
         <p:nvSpPr>
-          <p:cNvPr id="13" name="TextBox 12"/>
+          <p:cNvPr id="45" name="TextBox 44"/>
           <p:cNvSpPr txBox="1"/>
           <p:nvPr/>
         </p:nvSpPr>
         <p:spPr>
           <a:xfrm>
-            <a:off x="10607040" y="1368552"/>
+            <a:off x="10607040" y="3273552"/>
             <a:ext cx="1371600" cy="228600"/>
           </a:xfrm>
           <a:prstGeom prst="rect">
@@ -7396,20 +8628,20 @@
               </a:defRPr>
             </a:pPr>
             <a:r>
-              <a:t>OR 2.94 [1.18–7.32] P=0.020*</a:t>
-            </a:r>
-          </a:p>
-        </p:txBody>
-      </p:sp>
-      <p:sp>
-        <p:nvSpPr>
-          <p:cNvPr id="14" name="TextBox 13"/>
+              <a:t>OR 4.27 [1.06–17.24] P=0.041*</a:t>
+            </a:r>
+          </a:p>
+        </p:txBody>
+      </p:sp>
+      <p:sp>
+        <p:nvSpPr>
+          <p:cNvPr id="46" name="TextBox 45"/>
           <p:cNvSpPr txBox="1"/>
           <p:nvPr/>
         </p:nvSpPr>
         <p:spPr>
           <a:xfrm>
-            <a:off x="274320" y="1595120"/>
+            <a:off x="274320" y="3486751"/>
             <a:ext cx="3200400" cy="274320"/>
           </a:xfrm>
           <a:prstGeom prst="rect">
@@ -7427,21 +8659,21 @@
               <a:defRPr sz="800"/>
             </a:pPr>
             <a:r>
-              <a:t>Full minus Surgery time (per min)</a:t>
-            </a:r>
-          </a:p>
-        </p:txBody>
-      </p:sp>
-      <p:sp>
-        <p:nvSpPr>
-          <p:cNvPr id="15" name="Rectangle 14"/>
-          <p:cNvSpPr/>
-          <p:nvPr/>
-        </p:nvSpPr>
-        <p:spPr>
-          <a:xfrm>
-            <a:off x="4314432" y="1713230"/>
-            <a:ext cx="3364718" cy="38100"/>
+              <a:t>Twin + Surgery time (per min)</a:t>
+            </a:r>
+          </a:p>
+        </p:txBody>
+      </p:sp>
+      <p:sp>
+        <p:nvSpPr>
+          <p:cNvPr id="47" name="Rectangle 46"/>
+          <p:cNvSpPr/>
+          <p:nvPr/>
+        </p:nvSpPr>
+        <p:spPr>
+          <a:xfrm>
+            <a:off x="3880313" y="3604861"/>
+            <a:ext cx="3685879" cy="38100"/>
           </a:xfrm>
           <a:prstGeom prst="rect">
             <a:avLst/>
@@ -7477,13 +8709,13 @@
       </p:sp>
       <p:sp>
         <p:nvSpPr>
-          <p:cNvPr id="16" name="Diamond 15"/>
-          <p:cNvSpPr/>
-          <p:nvPr/>
-        </p:nvSpPr>
-        <p:spPr>
-          <a:xfrm>
-            <a:off x="5228000" y="1677416"/>
+          <p:cNvPr id="48" name="Diamond 47"/>
+          <p:cNvSpPr/>
+          <p:nvPr/>
+        </p:nvSpPr>
+        <p:spPr>
+          <a:xfrm>
+            <a:off x="4535740" y="3569047"/>
             <a:ext cx="109728" cy="109728"/>
           </a:xfrm>
           <a:prstGeom prst="diamond">
@@ -7522,13 +8754,13 @@
       </p:sp>
       <p:sp>
         <p:nvSpPr>
-          <p:cNvPr id="17" name="TextBox 16"/>
+          <p:cNvPr id="49" name="TextBox 48"/>
           <p:cNvSpPr txBox="1"/>
           <p:nvPr/>
         </p:nvSpPr>
         <p:spPr>
           <a:xfrm>
-            <a:off x="10607040" y="1622552"/>
+            <a:off x="10607040" y="3514183"/>
             <a:ext cx="1371600" cy="228600"/>
           </a:xfrm>
           <a:prstGeom prst="rect">
@@ -7550,20 +8782,20 @@
               </a:defRPr>
             </a:pPr>
             <a:r>
-              <a:t>OR 2.69 [1.09–6.65] P=0.032*</a:t>
-            </a:r>
-          </a:p>
-        </p:txBody>
-      </p:sp>
-      <p:sp>
-        <p:nvSpPr>
-          <p:cNvPr id="18" name="TextBox 17"/>
+              <a:t>OR 5.25 [1.25–21.99] P=0.023*</a:t>
+            </a:r>
+          </a:p>
+        </p:txBody>
+      </p:sp>
+      <p:sp>
+        <p:nvSpPr>
+          <p:cNvPr id="50" name="TextBox 49"/>
           <p:cNvSpPr txBox="1"/>
           <p:nvPr/>
         </p:nvSpPr>
         <p:spPr>
           <a:xfrm>
-            <a:off x="274320" y="1849120"/>
+            <a:off x="274320" y="3727383"/>
             <a:ext cx="3200400" cy="274320"/>
           </a:xfrm>
           <a:prstGeom prst="rect">
@@ -7581,21 +8813,21 @@
               <a:defRPr sz="800"/>
             </a:pPr>
             <a:r>
-              <a:t>Full minus Epidural anesthesia</a:t>
-            </a:r>
-          </a:p>
-        </p:txBody>
-      </p:sp>
-      <p:sp>
-        <p:nvSpPr>
-          <p:cNvPr id="19" name="Rectangle 18"/>
-          <p:cNvSpPr/>
-          <p:nvPr/>
-        </p:nvSpPr>
-        <p:spPr>
-          <a:xfrm>
-            <a:off x="4483504" y="1967230"/>
-            <a:ext cx="4178928" cy="38100"/>
+              <a:t>Twin + Epidural anesthesia</a:t>
+            </a:r>
+          </a:p>
+        </p:txBody>
+      </p:sp>
+      <p:sp>
+        <p:nvSpPr>
+          <p:cNvPr id="51" name="Rectangle 50"/>
+          <p:cNvSpPr/>
+          <p:nvPr/>
+        </p:nvSpPr>
+        <p:spPr>
+          <a:xfrm>
+            <a:off x="3839551" y="3845493"/>
+            <a:ext cx="2765802" cy="38100"/>
           </a:xfrm>
           <a:prstGeom prst="rect">
             <a:avLst/>
@@ -7631,13 +8863,13 @@
       </p:sp>
       <p:sp>
         <p:nvSpPr>
-          <p:cNvPr id="20" name="Diamond 19"/>
-          <p:cNvSpPr/>
-          <p:nvPr/>
-        </p:nvSpPr>
-        <p:spPr>
-          <a:xfrm>
-            <a:off x="5635840" y="1931416"/>
+          <p:cNvPr id="52" name="Diamond 51"/>
+          <p:cNvSpPr/>
+          <p:nvPr/>
+        </p:nvSpPr>
+        <p:spPr>
+          <a:xfrm>
+            <a:off x="4335093" y="3809679"/>
             <a:ext cx="109728" cy="109728"/>
           </a:xfrm>
           <a:prstGeom prst="diamond">
@@ -7676,13 +8908,13 @@
       </p:sp>
       <p:sp>
         <p:nvSpPr>
-          <p:cNvPr id="21" name="TextBox 20"/>
+          <p:cNvPr id="53" name="TextBox 52"/>
           <p:cNvSpPr txBox="1"/>
           <p:nvPr/>
         </p:nvSpPr>
         <p:spPr>
           <a:xfrm>
-            <a:off x="10607040" y="1876552"/>
+            <a:off x="10607040" y="3754815"/>
             <a:ext cx="1371600" cy="228600"/>
           </a:xfrm>
           <a:prstGeom prst="rect">
@@ -7704,20 +8936,20 @@
               </a:defRPr>
             </a:pPr>
             <a:r>
-              <a:t>OR 3.36 [1.37–8.28] P=0.008**</a:t>
-            </a:r>
-          </a:p>
-        </p:txBody>
-      </p:sp>
-      <p:sp>
-        <p:nvSpPr>
-          <p:cNvPr id="22" name="TextBox 21"/>
+              <a:t>OR 4.12 [1.02–16.58] P=0.046*</a:t>
+            </a:r>
+          </a:p>
+        </p:txBody>
+      </p:sp>
+      <p:sp>
+        <p:nvSpPr>
+          <p:cNvPr id="54" name="TextBox 53"/>
           <p:cNvSpPr txBox="1"/>
           <p:nvPr/>
         </p:nvSpPr>
         <p:spPr>
           <a:xfrm>
-            <a:off x="274320" y="2103120"/>
+            <a:off x="274320" y="3968014"/>
             <a:ext cx="3200400" cy="274320"/>
           </a:xfrm>
           <a:prstGeom prst="rect">
@@ -7735,21 +8967,21 @@
               <a:defRPr sz="800"/>
             </a:pPr>
             <a:r>
-              <a:t>Full minus HDP</a:t>
-            </a:r>
-          </a:p>
-        </p:txBody>
-      </p:sp>
-      <p:sp>
-        <p:nvSpPr>
-          <p:cNvPr id="23" name="Rectangle 22"/>
-          <p:cNvSpPr/>
-          <p:nvPr/>
-        </p:nvSpPr>
-        <p:spPr>
-          <a:xfrm>
-            <a:off x="4387298" y="2221230"/>
-            <a:ext cx="3812648" cy="38100"/>
+              <a:t>Twin + HDP</a:t>
+            </a:r>
+          </a:p>
+        </p:txBody>
+      </p:sp>
+      <p:sp>
+        <p:nvSpPr>
+          <p:cNvPr id="55" name="Rectangle 54"/>
+          <p:cNvSpPr/>
+          <p:nvPr/>
+        </p:nvSpPr>
+        <p:spPr>
+          <a:xfrm>
+            <a:off x="3843067" y="4086124"/>
+            <a:ext cx="2807105" cy="38100"/>
           </a:xfrm>
           <a:prstGeom prst="rect">
             <a:avLst/>
@@ -7785,13 +9017,13 @@
       </p:sp>
       <p:sp>
         <p:nvSpPr>
-          <p:cNvPr id="24" name="Diamond 23"/>
-          <p:cNvSpPr/>
-          <p:nvPr/>
-        </p:nvSpPr>
-        <p:spPr>
-          <a:xfrm>
-            <a:off x="5423325" y="2185416"/>
+          <p:cNvPr id="56" name="Diamond 55"/>
+          <p:cNvSpPr/>
+          <p:nvPr/>
+        </p:nvSpPr>
+        <p:spPr>
+          <a:xfrm>
+            <a:off x="4347736" y="4050310"/>
             <a:ext cx="109728" cy="109728"/>
           </a:xfrm>
           <a:prstGeom prst="diamond">
@@ -7830,13 +9062,13 @@
       </p:sp>
       <p:sp>
         <p:nvSpPr>
-          <p:cNvPr id="25" name="TextBox 24"/>
+          <p:cNvPr id="57" name="TextBox 56"/>
           <p:cNvSpPr txBox="1"/>
           <p:nvPr/>
         </p:nvSpPr>
         <p:spPr>
           <a:xfrm>
-            <a:off x="10607040" y="2130552"/>
+            <a:off x="10607040" y="3995446"/>
             <a:ext cx="1371600" cy="228600"/>
           </a:xfrm>
           <a:prstGeom prst="rect">
@@ -7858,20 +9090,20 @@
               </a:defRPr>
             </a:pPr>
             <a:r>
-              <a:t>OR 3.01 [1.21–7.51] P=0.018*</a:t>
-            </a:r>
-          </a:p>
-        </p:txBody>
-      </p:sp>
-      <p:sp>
-        <p:nvSpPr>
-          <p:cNvPr id="26" name="TextBox 25"/>
+              <a:t>OR 4.19 [1.04–16.83] P=0.043*</a:t>
+            </a:r>
+          </a:p>
+        </p:txBody>
+      </p:sp>
+      <p:sp>
+        <p:nvSpPr>
+          <p:cNvPr id="58" name="TextBox 57"/>
           <p:cNvSpPr txBox="1"/>
           <p:nvPr/>
         </p:nvSpPr>
         <p:spPr>
           <a:xfrm>
-            <a:off x="274320" y="2357120"/>
+            <a:off x="274320" y="4208646"/>
             <a:ext cx="3200400" cy="274320"/>
           </a:xfrm>
           <a:prstGeom prst="rect">
@@ -7889,21 +9121,21 @@
               <a:defRPr sz="800"/>
             </a:pPr>
             <a:r>
-              <a:t>Full minus Prior CS</a:t>
-            </a:r>
-          </a:p>
-        </p:txBody>
-      </p:sp>
-      <p:sp>
-        <p:nvSpPr>
-          <p:cNvPr id="27" name="Rectangle 26"/>
-          <p:cNvSpPr/>
-          <p:nvPr/>
-        </p:nvSpPr>
-        <p:spPr>
-          <a:xfrm>
-            <a:off x="4591416" y="2475230"/>
-            <a:ext cx="4341568" cy="38100"/>
+              <a:t>Twin + Prior CS</a:t>
+            </a:r>
+          </a:p>
+        </p:txBody>
+      </p:sp>
+      <p:sp>
+        <p:nvSpPr>
+          <p:cNvPr id="59" name="Rectangle 58"/>
+          <p:cNvSpPr/>
+          <p:nvPr/>
+        </p:nvSpPr>
+        <p:spPr>
+          <a:xfrm>
+            <a:off x="3857869" y="4326756"/>
+            <a:ext cx="3829539" cy="38100"/>
           </a:xfrm>
           <a:prstGeom prst="rect">
             <a:avLst/>
@@ -7939,13 +9171,13 @@
       </p:sp>
       <p:sp>
         <p:nvSpPr>
-          <p:cNvPr id="28" name="Diamond 27"/>
-          <p:cNvSpPr/>
-          <p:nvPr/>
-        </p:nvSpPr>
-        <p:spPr>
-          <a:xfrm>
-            <a:off x="5822250" y="2439416"/>
+          <p:cNvPr id="60" name="Diamond 59"/>
+          <p:cNvSpPr/>
+          <p:nvPr/>
+        </p:nvSpPr>
+        <p:spPr>
+          <a:xfrm>
+            <a:off x="4501094" y="4290942"/>
             <a:ext cx="109728" cy="109728"/>
           </a:xfrm>
           <a:prstGeom prst="diamond">
@@ -7984,13 +9216,13 @@
       </p:sp>
       <p:sp>
         <p:nvSpPr>
-          <p:cNvPr id="29" name="TextBox 28"/>
+          <p:cNvPr id="61" name="TextBox 60"/>
           <p:cNvSpPr txBox="1"/>
           <p:nvPr/>
         </p:nvSpPr>
         <p:spPr>
           <a:xfrm>
-            <a:off x="10607040" y="2384552"/>
+            <a:off x="10607040" y="4236078"/>
             <a:ext cx="1371600" cy="228600"/>
           </a:xfrm>
           <a:prstGeom prst="rect">
@@ -8012,20 +9244,20 @@
               </a:defRPr>
             </a:pPr>
             <a:r>
-              <a:t>OR 3.67 [1.54–8.73] P=0.003**</a:t>
-            </a:r>
-          </a:p>
-        </p:txBody>
-      </p:sp>
-      <p:sp>
-        <p:nvSpPr>
-          <p:cNvPr id="30" name="TextBox 29"/>
+              <a:t>OR 5.05 [1.13–22.67] P=0.034*</a:t>
+            </a:r>
+          </a:p>
+        </p:txBody>
+      </p:sp>
+      <p:sp>
+        <p:nvSpPr>
+          <p:cNvPr id="62" name="TextBox 61"/>
           <p:cNvSpPr txBox="1"/>
           <p:nvPr/>
         </p:nvSpPr>
         <p:spPr>
           <a:xfrm>
-            <a:off x="274320" y="2611120"/>
+            <a:off x="274320" y="4449277"/>
             <a:ext cx="3200400" cy="274320"/>
           </a:xfrm>
           <a:prstGeom prst="rect">
@@ -8043,27 +9275,27 @@
               <a:defRPr sz="800"/>
             </a:pPr>
             <a:r>
-              <a:t>Full minus Emergency CS</a:t>
-            </a:r>
-          </a:p>
-        </p:txBody>
-      </p:sp>
-      <p:sp>
-        <p:nvSpPr>
-          <p:cNvPr id="31" name="Rectangle 30"/>
-          <p:cNvSpPr/>
-          <p:nvPr/>
-        </p:nvSpPr>
-        <p:spPr>
-          <a:xfrm>
-            <a:off x="4449491" y="2729230"/>
-            <a:ext cx="3745205" cy="38100"/>
-          </a:xfrm>
-          <a:prstGeom prst="rect">
-            <a:avLst/>
-          </a:prstGeom>
-          <a:solidFill>
-            <a:srgbClr val="C44E52"/>
+              <a:t>Twin + Emergency CS</a:t>
+            </a:r>
+          </a:p>
+        </p:txBody>
+      </p:sp>
+      <p:sp>
+        <p:nvSpPr>
+          <p:cNvPr id="63" name="Rectangle 62"/>
+          <p:cNvSpPr/>
+          <p:nvPr/>
+        </p:nvSpPr>
+        <p:spPr>
+          <a:xfrm>
+            <a:off x="3817471" y="4567387"/>
+            <a:ext cx="2442068" cy="38100"/>
+          </a:xfrm>
+          <a:prstGeom prst="rect">
+            <a:avLst/>
+          </a:prstGeom>
+          <a:solidFill>
+            <a:srgbClr val="4C72B0"/>
           </a:solidFill>
           <a:ln>
             <a:noFill/>
@@ -8093,13 +9325,167 @@
       </p:sp>
       <p:sp>
         <p:nvSpPr>
-          <p:cNvPr id="32" name="Diamond 31"/>
-          <p:cNvSpPr/>
-          <p:nvPr/>
-        </p:nvSpPr>
-        <p:spPr>
-          <a:xfrm>
-            <a:off x="5498228" y="2693416"/>
+          <p:cNvPr id="64" name="Diamond 63"/>
+          <p:cNvSpPr/>
+          <p:nvPr/>
+        </p:nvSpPr>
+        <p:spPr>
+          <a:xfrm>
+            <a:off x="4247698" y="4531573"/>
+            <a:ext cx="109728" cy="109728"/>
+          </a:xfrm>
+          <a:prstGeom prst="diamond">
+            <a:avLst/>
+          </a:prstGeom>
+          <a:solidFill>
+            <a:srgbClr val="4C72B0"/>
+          </a:solidFill>
+          <a:ln>
+            <a:solidFill>
+              <a:srgbClr val="4C72B0"/>
+            </a:solidFill>
+          </a:ln>
+        </p:spPr>
+        <p:style>
+          <a:lnRef idx="1">
+            <a:schemeClr val="accent1"/>
+          </a:lnRef>
+          <a:fillRef idx="3">
+            <a:schemeClr val="accent1"/>
+          </a:fillRef>
+          <a:effectRef idx="2">
+            <a:schemeClr val="accent1"/>
+          </a:effectRef>
+          <a:fontRef idx="minor">
+            <a:schemeClr val="lt1"/>
+          </a:fontRef>
+        </p:style>
+        <p:txBody>
+          <a:bodyPr rtlCol="0" anchor="ctr"/>
+          <a:lstStyle/>
+          <a:p>
+            <a:pPr algn="ctr"/>
+          </a:p>
+        </p:txBody>
+      </p:sp>
+      <p:sp>
+        <p:nvSpPr>
+          <p:cNvPr id="65" name="TextBox 64"/>
+          <p:cNvSpPr txBox="1"/>
+          <p:nvPr/>
+        </p:nvSpPr>
+        <p:spPr>
+          <a:xfrm>
+            <a:off x="10607040" y="4476709"/>
+            <a:ext cx="1371600" cy="228600"/>
+          </a:xfrm>
+          <a:prstGeom prst="rect">
+            <a:avLst/>
+          </a:prstGeom>
+          <a:noFill/>
+        </p:spPr>
+        <p:txBody>
+          <a:bodyPr wrap="none">
+            <a:spAutoFit/>
+          </a:bodyPr>
+          <a:lstStyle/>
+          <a:p>
+            <a:pPr>
+              <a:defRPr sz="700">
+                <a:solidFill>
+                  <a:srgbClr val="4C72B0"/>
+                </a:solidFill>
+              </a:defRPr>
+            </a:pPr>
+            <a:r>
+              <a:t>OR 3.63 [0.90–14.64] P=0.070</a:t>
+            </a:r>
+          </a:p>
+        </p:txBody>
+      </p:sp>
+      <p:sp>
+        <p:nvSpPr>
+          <p:cNvPr id="66" name="TextBox 65"/>
+          <p:cNvSpPr txBox="1"/>
+          <p:nvPr/>
+        </p:nvSpPr>
+        <p:spPr>
+          <a:xfrm>
+            <a:off x="274320" y="4689909"/>
+            <a:ext cx="3200400" cy="274320"/>
+          </a:xfrm>
+          <a:prstGeom prst="rect">
+            <a:avLst/>
+          </a:prstGeom>
+          <a:noFill/>
+        </p:spPr>
+        <p:txBody>
+          <a:bodyPr wrap="square">
+            <a:spAutoFit/>
+          </a:bodyPr>
+          <a:lstStyle/>
+          <a:p>
+            <a:pPr algn="r">
+              <a:defRPr sz="800"/>
+            </a:pPr>
+            <a:r>
+              <a:t>Twin + GA (per week)</a:t>
+            </a:r>
+          </a:p>
+        </p:txBody>
+      </p:sp>
+      <p:sp>
+        <p:nvSpPr>
+          <p:cNvPr id="67" name="Rectangle 66"/>
+          <p:cNvSpPr/>
+          <p:nvPr/>
+        </p:nvSpPr>
+        <p:spPr>
+          <a:xfrm>
+            <a:off x="3851005" y="4808019"/>
+            <a:ext cx="3266225" cy="38100"/>
+          </a:xfrm>
+          <a:prstGeom prst="rect">
+            <a:avLst/>
+          </a:prstGeom>
+          <a:solidFill>
+            <a:srgbClr val="C44E52"/>
+          </a:solidFill>
+          <a:ln>
+            <a:noFill/>
+          </a:ln>
+        </p:spPr>
+        <p:style>
+          <a:lnRef idx="1">
+            <a:schemeClr val="accent1"/>
+          </a:lnRef>
+          <a:fillRef idx="3">
+            <a:schemeClr val="accent1"/>
+          </a:fillRef>
+          <a:effectRef idx="2">
+            <a:schemeClr val="accent1"/>
+          </a:effectRef>
+          <a:fontRef idx="minor">
+            <a:schemeClr val="lt1"/>
+          </a:fontRef>
+        </p:style>
+        <p:txBody>
+          <a:bodyPr rtlCol="0" anchor="ctr"/>
+          <a:lstStyle/>
+          <a:p>
+            <a:pPr algn="ctr"/>
+          </a:p>
+        </p:txBody>
+      </p:sp>
+      <p:sp>
+        <p:nvSpPr>
+          <p:cNvPr id="68" name="Diamond 67"/>
+          <p:cNvSpPr/>
+          <p:nvPr/>
+        </p:nvSpPr>
+        <p:spPr>
+          <a:xfrm>
+            <a:off x="4420729" y="4772205"/>
             <a:ext cx="109728" cy="109728"/>
           </a:xfrm>
           <a:prstGeom prst="diamond">
@@ -8138,13 +9524,13 @@
       </p:sp>
       <p:sp>
         <p:nvSpPr>
-          <p:cNvPr id="33" name="TextBox 32"/>
+          <p:cNvPr id="69" name="TextBox 68"/>
           <p:cNvSpPr txBox="1"/>
           <p:nvPr/>
         </p:nvSpPr>
         <p:spPr>
           <a:xfrm>
-            <a:off x="10607040" y="2638552"/>
+            <a:off x="10607040" y="4717341"/>
             <a:ext cx="1371600" cy="228600"/>
           </a:xfrm>
           <a:prstGeom prst="rect">
@@ -8166,20 +9552,20 @@
               </a:defRPr>
             </a:pPr>
             <a:r>
-              <a:t>OR 3.14 [1.31–7.51] P=0.010*</a:t>
-            </a:r>
-          </a:p>
-        </p:txBody>
-      </p:sp>
-      <p:sp>
-        <p:nvSpPr>
-          <p:cNvPr id="34" name="TextBox 33"/>
+              <a:t>OR 4.60 [1.09–19.46] P=0.038*</a:t>
+            </a:r>
+          </a:p>
+        </p:txBody>
+      </p:sp>
+      <p:sp>
+        <p:nvSpPr>
+          <p:cNvPr id="70" name="TextBox 69"/>
           <p:cNvSpPr txBox="1"/>
           <p:nvPr/>
         </p:nvSpPr>
         <p:spPr>
           <a:xfrm>
-            <a:off x="274320" y="2865120"/>
+            <a:off x="274320" y="4930541"/>
             <a:ext cx="3200400" cy="274320"/>
           </a:xfrm>
           <a:prstGeom prst="rect">
@@ -8197,21 +9583,21 @@
               <a:defRPr sz="800"/>
             </a:pPr>
             <a:r>
-              <a:t>Full minus BMI (per kg/m²)</a:t>
-            </a:r>
-          </a:p>
-        </p:txBody>
-      </p:sp>
-      <p:sp>
-        <p:nvSpPr>
-          <p:cNvPr id="35" name="Rectangle 34"/>
-          <p:cNvSpPr/>
-          <p:nvPr/>
-        </p:nvSpPr>
-        <p:spPr>
-          <a:xfrm>
-            <a:off x="4387020" y="2983230"/>
-            <a:ext cx="3781755" cy="38100"/>
+              <a:t>Twin + BMI (per kg/m²)</a:t>
+            </a:r>
+          </a:p>
+        </p:txBody>
+      </p:sp>
+      <p:sp>
+        <p:nvSpPr>
+          <p:cNvPr id="71" name="Rectangle 70"/>
+          <p:cNvSpPr/>
+          <p:nvPr/>
+        </p:nvSpPr>
+        <p:spPr>
+          <a:xfrm>
+            <a:off x="3842237" y="5048651"/>
+            <a:ext cx="2803185" cy="38100"/>
           </a:xfrm>
           <a:prstGeom prst="rect">
             <a:avLst/>
@@ -8247,13 +9633,13 @@
       </p:sp>
       <p:sp>
         <p:nvSpPr>
-          <p:cNvPr id="36" name="Diamond 35"/>
-          <p:cNvSpPr/>
-          <p:nvPr/>
-        </p:nvSpPr>
-        <p:spPr>
-          <a:xfrm>
-            <a:off x="5416721" y="2947416"/>
+          <p:cNvPr id="72" name="Diamond 71"/>
+          <p:cNvSpPr/>
+          <p:nvPr/>
+        </p:nvSpPr>
+        <p:spPr>
+          <a:xfrm>
+            <a:off x="4345476" y="5012837"/>
             <a:ext cx="109728" cy="109728"/>
           </a:xfrm>
           <a:prstGeom prst="diamond">
@@ -8292,13 +9678,13 @@
       </p:sp>
       <p:sp>
         <p:nvSpPr>
-          <p:cNvPr id="37" name="TextBox 36"/>
+          <p:cNvPr id="73" name="TextBox 72"/>
           <p:cNvSpPr txBox="1"/>
           <p:nvPr/>
         </p:nvSpPr>
         <p:spPr>
           <a:xfrm>
-            <a:off x="10607040" y="2892552"/>
+            <a:off x="10607040" y="4957973"/>
             <a:ext cx="1371600" cy="228600"/>
           </a:xfrm>
           <a:prstGeom prst="rect">
@@ -8320,20 +9706,20 @@
               </a:defRPr>
             </a:pPr>
             <a:r>
-              <a:t>OR 3.00 [1.21–7.46] P=0.018*</a:t>
-            </a:r>
-          </a:p>
-        </p:txBody>
-      </p:sp>
-      <p:sp>
-        <p:nvSpPr>
-          <p:cNvPr id="38" name="TextBox 37"/>
+              <a:t>OR 4.18 [1.04–16.81] P=0.044*</a:t>
+            </a:r>
+          </a:p>
+        </p:txBody>
+      </p:sp>
+      <p:sp>
+        <p:nvSpPr>
+          <p:cNvPr id="74" name="TextBox 73"/>
           <p:cNvSpPr txBox="1"/>
           <p:nvPr/>
         </p:nvSpPr>
         <p:spPr>
           <a:xfrm>
-            <a:off x="274320" y="3119120"/>
+            <a:off x="274320" y="5171172"/>
             <a:ext cx="3200400" cy="274320"/>
           </a:xfrm>
           <a:prstGeom prst="rect">
@@ -8351,21 +9737,21 @@
               <a:defRPr sz="800"/>
             </a:pPr>
             <a:r>
-              <a:t>Twin + Hypotension (SBP &lt; 90)</a:t>
-            </a:r>
-          </a:p>
-        </p:txBody>
-      </p:sp>
-      <p:sp>
-        <p:nvSpPr>
-          <p:cNvPr id="39" name="Rectangle 38"/>
-          <p:cNvSpPr/>
-          <p:nvPr/>
-        </p:nvSpPr>
-        <p:spPr>
-          <a:xfrm>
-            <a:off x="4404734" y="3237230"/>
-            <a:ext cx="3002977" cy="38100"/>
+              <a:t>Twin + Age (per year)</a:t>
+            </a:r>
+          </a:p>
+        </p:txBody>
+      </p:sp>
+      <p:sp>
+        <p:nvSpPr>
+          <p:cNvPr id="75" name="Rectangle 74"/>
+          <p:cNvSpPr/>
+          <p:nvPr/>
+        </p:nvSpPr>
+        <p:spPr>
+          <a:xfrm>
+            <a:off x="3839087" y="5289282"/>
+            <a:ext cx="2818349" cy="38100"/>
           </a:xfrm>
           <a:prstGeom prst="rect">
             <a:avLst/>
@@ -8401,13 +9787,13 @@
       </p:sp>
       <p:sp>
         <p:nvSpPr>
-          <p:cNvPr id="40" name="Diamond 39"/>
-          <p:cNvSpPr/>
-          <p:nvPr/>
-        </p:nvSpPr>
-        <p:spPr>
-          <a:xfrm>
-            <a:off x="5276604" y="3201416"/>
+          <p:cNvPr id="76" name="Diamond 75"/>
+          <p:cNvSpPr/>
+          <p:nvPr/>
+        </p:nvSpPr>
+        <p:spPr>
+          <a:xfrm>
+            <a:off x="4340591" y="5253468"/>
             <a:ext cx="109728" cy="109728"/>
           </a:xfrm>
           <a:prstGeom prst="diamond">
@@ -8446,13 +9832,13 @@
       </p:sp>
       <p:sp>
         <p:nvSpPr>
-          <p:cNvPr id="41" name="TextBox 40"/>
+          <p:cNvPr id="77" name="TextBox 76"/>
           <p:cNvSpPr txBox="1"/>
           <p:nvPr/>
         </p:nvSpPr>
         <p:spPr>
           <a:xfrm>
-            <a:off x="10607040" y="3146552"/>
+            <a:off x="10607040" y="5198604"/>
             <a:ext cx="1371600" cy="228600"/>
           </a:xfrm>
           <a:prstGeom prst="rect">
@@ -8474,20 +9860,20 @@
               </a:defRPr>
             </a:pPr>
             <a:r>
-              <a:t>OR 2.77 [1.24–6.20] P=0.013*</a:t>
-            </a:r>
-          </a:p>
-        </p:txBody>
-      </p:sp>
-      <p:sp>
-        <p:nvSpPr>
-          <p:cNvPr id="42" name="TextBox 41"/>
+              <a:t>OR 4.15 [1.02–16.87] P=0.047*</a:t>
+            </a:r>
+          </a:p>
+        </p:txBody>
+      </p:sp>
+      <p:sp>
+        <p:nvSpPr>
+          <p:cNvPr id="78" name="TextBox 77"/>
           <p:cNvSpPr txBox="1"/>
           <p:nvPr/>
         </p:nvSpPr>
         <p:spPr>
           <a:xfrm>
-            <a:off x="274320" y="3373120"/>
+            <a:off x="274320" y="5411804"/>
             <a:ext cx="3200400" cy="274320"/>
           </a:xfrm>
           <a:prstGeom prst="rect">
@@ -8505,21 +9891,21 @@
               <a:defRPr sz="800"/>
             </a:pPr>
             <a:r>
-              <a:t>Twin + Surgery time (per min)</a:t>
-            </a:r>
-          </a:p>
-        </p:txBody>
-      </p:sp>
-      <p:sp>
-        <p:nvSpPr>
-          <p:cNvPr id="43" name="Rectangle 42"/>
-          <p:cNvSpPr/>
-          <p:nvPr/>
-        </p:nvSpPr>
-        <p:spPr>
-          <a:xfrm>
-            <a:off x="4549653" y="3491230"/>
-            <a:ext cx="3741573" cy="38100"/>
+              <a:t>Crude (twin only)</a:t>
+            </a:r>
+          </a:p>
+        </p:txBody>
+      </p:sp>
+      <p:sp>
+        <p:nvSpPr>
+          <p:cNvPr id="79" name="Rectangle 78"/>
+          <p:cNvSpPr/>
+          <p:nvPr/>
+        </p:nvSpPr>
+        <p:spPr>
+          <a:xfrm>
+            <a:off x="3842985" y="5529914"/>
+            <a:ext cx="2805676" cy="38100"/>
           </a:xfrm>
           <a:prstGeom prst="rect">
             <a:avLst/>
@@ -8555,13 +9941,13 @@
       </p:sp>
       <p:sp>
         <p:nvSpPr>
-          <p:cNvPr id="44" name="Diamond 43"/>
-          <p:cNvSpPr/>
-          <p:nvPr/>
-        </p:nvSpPr>
-        <p:spPr>
-          <a:xfrm>
-            <a:off x="5635823" y="3455416"/>
+          <p:cNvPr id="80" name="Diamond 79"/>
+          <p:cNvSpPr/>
+          <p:nvPr/>
+        </p:nvSpPr>
+        <p:spPr>
+          <a:xfrm>
+            <a:off x="4347383" y="5494100"/>
             <a:ext cx="109728" cy="109728"/>
           </a:xfrm>
           <a:prstGeom prst="diamond">
@@ -8600,13 +9986,13 @@
       </p:sp>
       <p:sp>
         <p:nvSpPr>
-          <p:cNvPr id="45" name="TextBox 44"/>
+          <p:cNvPr id="81" name="TextBox 80"/>
           <p:cNvSpPr txBox="1"/>
           <p:nvPr/>
         </p:nvSpPr>
         <p:spPr>
           <a:xfrm>
-            <a:off x="10607040" y="3400552"/>
+            <a:off x="10607040" y="5439236"/>
             <a:ext cx="1371600" cy="228600"/>
           </a:xfrm>
           <a:prstGeom prst="rect">
@@ -8628,1246 +10014,14 @@
               </a:defRPr>
             </a:pPr>
             <a:r>
-              <a:t>OR 3.36 [1.48–7.67] P=0.004**</a:t>
-            </a:r>
-          </a:p>
-        </p:txBody>
-      </p:sp>
-      <p:sp>
-        <p:nvSpPr>
-          <p:cNvPr id="46" name="TextBox 45"/>
-          <p:cNvSpPr txBox="1"/>
-          <p:nvPr/>
-        </p:nvSpPr>
-        <p:spPr>
-          <a:xfrm>
-            <a:off x="274320" y="3627120"/>
-            <a:ext cx="3200400" cy="274320"/>
-          </a:xfrm>
-          <a:prstGeom prst="rect">
-            <a:avLst/>
-          </a:prstGeom>
-          <a:noFill/>
-        </p:spPr>
-        <p:txBody>
-          <a:bodyPr wrap="square">
-            <a:spAutoFit/>
-          </a:bodyPr>
-          <a:lstStyle/>
-          <a:p>
-            <a:pPr algn="r">
-              <a:defRPr sz="800"/>
-            </a:pPr>
-            <a:r>
-              <a:t>Twin + Epidural anesthesia</a:t>
-            </a:r>
-          </a:p>
-        </p:txBody>
-      </p:sp>
-      <p:sp>
-        <p:nvSpPr>
-          <p:cNvPr id="47" name="Rectangle 46"/>
-          <p:cNvSpPr/>
-          <p:nvPr/>
-        </p:nvSpPr>
-        <p:spPr>
-          <a:xfrm>
-            <a:off x="4376445" y="3745230"/>
-            <a:ext cx="2897988" cy="38100"/>
-          </a:xfrm>
-          <a:prstGeom prst="rect">
-            <a:avLst/>
-          </a:prstGeom>
-          <a:solidFill>
-            <a:srgbClr val="C44E52"/>
-          </a:solidFill>
-          <a:ln>
-            <a:noFill/>
-          </a:ln>
-        </p:spPr>
-        <p:style>
-          <a:lnRef idx="1">
-            <a:schemeClr val="accent1"/>
-          </a:lnRef>
-          <a:fillRef idx="3">
-            <a:schemeClr val="accent1"/>
-          </a:fillRef>
-          <a:effectRef idx="2">
-            <a:schemeClr val="accent1"/>
-          </a:effectRef>
-          <a:fontRef idx="minor">
-            <a:schemeClr val="lt1"/>
-          </a:fontRef>
-        </p:style>
-        <p:txBody>
-          <a:bodyPr rtlCol="0" anchor="ctr"/>
-          <a:lstStyle/>
-          <a:p>
-            <a:pPr algn="ctr"/>
-          </a:p>
-        </p:txBody>
-      </p:sp>
-      <p:sp>
-        <p:nvSpPr>
-          <p:cNvPr id="48" name="Diamond 47"/>
-          <p:cNvSpPr/>
-          <p:nvPr/>
-        </p:nvSpPr>
-        <p:spPr>
-          <a:xfrm>
-            <a:off x="5215170" y="3709416"/>
-            <a:ext cx="109728" cy="109728"/>
-          </a:xfrm>
-          <a:prstGeom prst="diamond">
-            <a:avLst/>
-          </a:prstGeom>
-          <a:solidFill>
-            <a:srgbClr val="C44E52"/>
-          </a:solidFill>
-          <a:ln>
-            <a:solidFill>
-              <a:srgbClr val="C44E52"/>
-            </a:solidFill>
-          </a:ln>
-        </p:spPr>
-        <p:style>
-          <a:lnRef idx="1">
-            <a:schemeClr val="accent1"/>
-          </a:lnRef>
-          <a:fillRef idx="3">
-            <a:schemeClr val="accent1"/>
-          </a:fillRef>
-          <a:effectRef idx="2">
-            <a:schemeClr val="accent1"/>
-          </a:effectRef>
-          <a:fontRef idx="minor">
-            <a:schemeClr val="lt1"/>
-          </a:fontRef>
-        </p:style>
-        <p:txBody>
-          <a:bodyPr rtlCol="0" anchor="ctr"/>
-          <a:lstStyle/>
-          <a:p>
-            <a:pPr algn="ctr"/>
-          </a:p>
-        </p:txBody>
-      </p:sp>
-      <p:sp>
-        <p:nvSpPr>
-          <p:cNvPr id="49" name="TextBox 48"/>
-          <p:cNvSpPr txBox="1"/>
-          <p:nvPr/>
-        </p:nvSpPr>
-        <p:spPr>
-          <a:xfrm>
-            <a:off x="10607040" y="3654552"/>
-            <a:ext cx="1371600" cy="228600"/>
-          </a:xfrm>
-          <a:prstGeom prst="rect">
-            <a:avLst/>
-          </a:prstGeom>
-          <a:noFill/>
-        </p:spPr>
-        <p:txBody>
-          <a:bodyPr wrap="none">
-            <a:spAutoFit/>
-          </a:bodyPr>
-          <a:lstStyle/>
-          <a:p>
-            <a:pPr>
-              <a:defRPr sz="700">
-                <a:solidFill>
-                  <a:srgbClr val="C44E52"/>
-                </a:solidFill>
-              </a:defRPr>
-            </a:pPr>
-            <a:r>
-              <a:t>OR 2.67 [1.19–5.98] P=0.017*</a:t>
-            </a:r>
-          </a:p>
-        </p:txBody>
-      </p:sp>
-      <p:sp>
-        <p:nvSpPr>
-          <p:cNvPr id="50" name="TextBox 49"/>
-          <p:cNvSpPr txBox="1"/>
-          <p:nvPr/>
-        </p:nvSpPr>
-        <p:spPr>
-          <a:xfrm>
-            <a:off x="274320" y="3881120"/>
-            <a:ext cx="3200400" cy="274320"/>
-          </a:xfrm>
-          <a:prstGeom prst="rect">
-            <a:avLst/>
-          </a:prstGeom>
-          <a:noFill/>
-        </p:spPr>
-        <p:txBody>
-          <a:bodyPr wrap="square">
-            <a:spAutoFit/>
-          </a:bodyPr>
-          <a:lstStyle/>
-          <a:p>
-            <a:pPr algn="r">
-              <a:defRPr sz="800"/>
-            </a:pPr>
-            <a:r>
-              <a:t>Twin + HDP</a:t>
-            </a:r>
-          </a:p>
-        </p:txBody>
-      </p:sp>
-      <p:sp>
-        <p:nvSpPr>
-          <p:cNvPr id="51" name="Rectangle 50"/>
-          <p:cNvSpPr/>
-          <p:nvPr/>
-        </p:nvSpPr>
-        <p:spPr>
-          <a:xfrm>
-            <a:off x="4387632" y="3999230"/>
-            <a:ext cx="2917158" cy="38100"/>
-          </a:xfrm>
-          <a:prstGeom prst="rect">
-            <a:avLst/>
-          </a:prstGeom>
-          <a:solidFill>
-            <a:srgbClr val="C44E52"/>
-          </a:solidFill>
-          <a:ln>
-            <a:noFill/>
-          </a:ln>
-        </p:spPr>
-        <p:style>
-          <a:lnRef idx="1">
-            <a:schemeClr val="accent1"/>
-          </a:lnRef>
-          <a:fillRef idx="3">
-            <a:schemeClr val="accent1"/>
-          </a:fillRef>
-          <a:effectRef idx="2">
-            <a:schemeClr val="accent1"/>
-          </a:effectRef>
-          <a:fontRef idx="minor">
-            <a:schemeClr val="lt1"/>
-          </a:fontRef>
-        </p:style>
-        <p:txBody>
-          <a:bodyPr rtlCol="0" anchor="ctr"/>
-          <a:lstStyle/>
-          <a:p>
-            <a:pPr algn="ctr"/>
-          </a:p>
-        </p:txBody>
-      </p:sp>
-      <p:sp>
-        <p:nvSpPr>
-          <p:cNvPr id="52" name="Diamond 51"/>
-          <p:cNvSpPr/>
-          <p:nvPr/>
-        </p:nvSpPr>
-        <p:spPr>
-          <a:xfrm>
-            <a:off x="5234473" y="3963416"/>
-            <a:ext cx="109728" cy="109728"/>
-          </a:xfrm>
-          <a:prstGeom prst="diamond">
-            <a:avLst/>
-          </a:prstGeom>
-          <a:solidFill>
-            <a:srgbClr val="C44E52"/>
-          </a:solidFill>
-          <a:ln>
-            <a:solidFill>
-              <a:srgbClr val="C44E52"/>
-            </a:solidFill>
-          </a:ln>
-        </p:spPr>
-        <p:style>
-          <a:lnRef idx="1">
-            <a:schemeClr val="accent1"/>
-          </a:lnRef>
-          <a:fillRef idx="3">
-            <a:schemeClr val="accent1"/>
-          </a:fillRef>
-          <a:effectRef idx="2">
-            <a:schemeClr val="accent1"/>
-          </a:effectRef>
-          <a:fontRef idx="minor">
-            <a:schemeClr val="lt1"/>
-          </a:fontRef>
-        </p:style>
-        <p:txBody>
-          <a:bodyPr rtlCol="0" anchor="ctr"/>
-          <a:lstStyle/>
-          <a:p>
-            <a:pPr algn="ctr"/>
-          </a:p>
-        </p:txBody>
-      </p:sp>
-      <p:sp>
-        <p:nvSpPr>
-          <p:cNvPr id="53" name="TextBox 52"/>
-          <p:cNvSpPr txBox="1"/>
-          <p:nvPr/>
-        </p:nvSpPr>
-        <p:spPr>
-          <a:xfrm>
-            <a:off x="10607040" y="3908552"/>
-            <a:ext cx="1371600" cy="228600"/>
-          </a:xfrm>
-          <a:prstGeom prst="rect">
-            <a:avLst/>
-          </a:prstGeom>
-          <a:noFill/>
-        </p:spPr>
-        <p:txBody>
-          <a:bodyPr wrap="none">
-            <a:spAutoFit/>
-          </a:bodyPr>
-          <a:lstStyle/>
-          <a:p>
-            <a:pPr>
-              <a:defRPr sz="700">
-                <a:solidFill>
-                  <a:srgbClr val="C44E52"/>
-                </a:solidFill>
-              </a:defRPr>
-            </a:pPr>
-            <a:r>
-              <a:t>OR 2.70 [1.21–6.03] P=0.016*</a:t>
-            </a:r>
-          </a:p>
-        </p:txBody>
-      </p:sp>
-      <p:sp>
-        <p:nvSpPr>
-          <p:cNvPr id="54" name="TextBox 53"/>
-          <p:cNvSpPr txBox="1"/>
-          <p:nvPr/>
-        </p:nvSpPr>
-        <p:spPr>
-          <a:xfrm>
-            <a:off x="274320" y="4135120"/>
-            <a:ext cx="3200400" cy="274320"/>
-          </a:xfrm>
-          <a:prstGeom prst="rect">
-            <a:avLst/>
-          </a:prstGeom>
-          <a:noFill/>
-        </p:spPr>
-        <p:txBody>
-          <a:bodyPr wrap="square">
-            <a:spAutoFit/>
-          </a:bodyPr>
-          <a:lstStyle/>
-          <a:p>
-            <a:pPr algn="r">
-              <a:defRPr sz="800"/>
-            </a:pPr>
-            <a:r>
-              <a:t>Twin + Prior CS</a:t>
-            </a:r>
-          </a:p>
-        </p:txBody>
-      </p:sp>
-      <p:sp>
-        <p:nvSpPr>
-          <p:cNvPr id="55" name="Rectangle 54"/>
-          <p:cNvSpPr/>
-          <p:nvPr/>
-        </p:nvSpPr>
-        <p:spPr>
-          <a:xfrm>
-            <a:off x="4326783" y="4253230"/>
-            <a:ext cx="2901317" cy="38100"/>
-          </a:xfrm>
-          <a:prstGeom prst="rect">
-            <a:avLst/>
-          </a:prstGeom>
-          <a:solidFill>
-            <a:srgbClr val="C44E52"/>
-          </a:solidFill>
-          <a:ln>
-            <a:noFill/>
-          </a:ln>
-        </p:spPr>
-        <p:style>
-          <a:lnRef idx="1">
-            <a:schemeClr val="accent1"/>
-          </a:lnRef>
-          <a:fillRef idx="3">
-            <a:schemeClr val="accent1"/>
-          </a:fillRef>
-          <a:effectRef idx="2">
-            <a:schemeClr val="accent1"/>
-          </a:effectRef>
-          <a:fontRef idx="minor">
-            <a:schemeClr val="lt1"/>
-          </a:fontRef>
-        </p:style>
-        <p:txBody>
-          <a:bodyPr rtlCol="0" anchor="ctr"/>
-          <a:lstStyle/>
-          <a:p>
-            <a:pPr algn="ctr"/>
-          </a:p>
-        </p:txBody>
-      </p:sp>
-      <p:sp>
-        <p:nvSpPr>
-          <p:cNvPr id="56" name="Diamond 55"/>
-          <p:cNvSpPr/>
-          <p:nvPr/>
-        </p:nvSpPr>
-        <p:spPr>
-          <a:xfrm>
-            <a:off x="5148478" y="4217416"/>
-            <a:ext cx="109728" cy="109728"/>
-          </a:xfrm>
-          <a:prstGeom prst="diamond">
-            <a:avLst/>
-          </a:prstGeom>
-          <a:solidFill>
-            <a:srgbClr val="C44E52"/>
-          </a:solidFill>
-          <a:ln>
-            <a:solidFill>
-              <a:srgbClr val="C44E52"/>
-            </a:solidFill>
-          </a:ln>
-        </p:spPr>
-        <p:style>
-          <a:lnRef idx="1">
-            <a:schemeClr val="accent1"/>
-          </a:lnRef>
-          <a:fillRef idx="3">
-            <a:schemeClr val="accent1"/>
-          </a:fillRef>
-          <a:effectRef idx="2">
-            <a:schemeClr val="accent1"/>
-          </a:effectRef>
-          <a:fontRef idx="minor">
-            <a:schemeClr val="lt1"/>
-          </a:fontRef>
-        </p:style>
-        <p:txBody>
-          <a:bodyPr rtlCol="0" anchor="ctr"/>
-          <a:lstStyle/>
-          <a:p>
-            <a:pPr algn="ctr"/>
-          </a:p>
-        </p:txBody>
-      </p:sp>
-      <p:sp>
-        <p:nvSpPr>
-          <p:cNvPr id="57" name="TextBox 56"/>
-          <p:cNvSpPr txBox="1"/>
-          <p:nvPr/>
-        </p:nvSpPr>
-        <p:spPr>
-          <a:xfrm>
-            <a:off x="10607040" y="4162552"/>
-            <a:ext cx="1371600" cy="228600"/>
-          </a:xfrm>
-          <a:prstGeom prst="rect">
-            <a:avLst/>
-          </a:prstGeom>
-          <a:noFill/>
-        </p:spPr>
-        <p:txBody>
-          <a:bodyPr wrap="none">
-            <a:spAutoFit/>
-          </a:bodyPr>
-          <a:lstStyle/>
-          <a:p>
-            <a:pPr>
-              <a:defRPr sz="700">
-                <a:solidFill>
-                  <a:srgbClr val="C44E52"/>
-                </a:solidFill>
-              </a:defRPr>
-            </a:pPr>
-            <a:r>
-              <a:t>OR 2.56 [1.11–5.91] P=0.028*</a:t>
-            </a:r>
-          </a:p>
-        </p:txBody>
-      </p:sp>
-      <p:sp>
-        <p:nvSpPr>
-          <p:cNvPr id="58" name="TextBox 57"/>
-          <p:cNvSpPr txBox="1"/>
-          <p:nvPr/>
-        </p:nvSpPr>
-        <p:spPr>
-          <a:xfrm>
-            <a:off x="274320" y="4389120"/>
-            <a:ext cx="3200400" cy="274320"/>
-          </a:xfrm>
-          <a:prstGeom prst="rect">
-            <a:avLst/>
-          </a:prstGeom>
-          <a:noFill/>
-        </p:spPr>
-        <p:txBody>
-          <a:bodyPr wrap="square">
-            <a:spAutoFit/>
-          </a:bodyPr>
-          <a:lstStyle/>
-          <a:p>
-            <a:pPr algn="r">
-              <a:defRPr sz="800"/>
-            </a:pPr>
-            <a:r>
-              <a:t>Twin + Emergency CS</a:t>
-            </a:r>
-          </a:p>
-        </p:txBody>
-      </p:sp>
-      <p:sp>
-        <p:nvSpPr>
-          <p:cNvPr id="59" name="Rectangle 58"/>
-          <p:cNvSpPr/>
-          <p:nvPr/>
-        </p:nvSpPr>
-        <p:spPr>
-          <a:xfrm>
-            <a:off x="4380427" y="4507230"/>
-            <a:ext cx="2914937" cy="38100"/>
-          </a:xfrm>
-          <a:prstGeom prst="rect">
-            <a:avLst/>
-          </a:prstGeom>
-          <a:solidFill>
-            <a:srgbClr val="C44E52"/>
-          </a:solidFill>
-          <a:ln>
-            <a:noFill/>
-          </a:ln>
-        </p:spPr>
-        <p:style>
-          <a:lnRef idx="1">
-            <a:schemeClr val="accent1"/>
-          </a:lnRef>
-          <a:fillRef idx="3">
-            <a:schemeClr val="accent1"/>
-          </a:fillRef>
-          <a:effectRef idx="2">
-            <a:schemeClr val="accent1"/>
-          </a:effectRef>
-          <a:fontRef idx="minor">
-            <a:schemeClr val="lt1"/>
-          </a:fontRef>
-        </p:style>
-        <p:txBody>
-          <a:bodyPr rtlCol="0" anchor="ctr"/>
-          <a:lstStyle/>
-          <a:p>
-            <a:pPr algn="ctr"/>
-          </a:p>
-        </p:txBody>
-      </p:sp>
-      <p:sp>
-        <p:nvSpPr>
-          <p:cNvPr id="60" name="Diamond 59"/>
-          <p:cNvSpPr/>
-          <p:nvPr/>
-        </p:nvSpPr>
-        <p:spPr>
-          <a:xfrm>
-            <a:off x="5224301" y="4471416"/>
-            <a:ext cx="109728" cy="109728"/>
-          </a:xfrm>
-          <a:prstGeom prst="diamond">
-            <a:avLst/>
-          </a:prstGeom>
-          <a:solidFill>
-            <a:srgbClr val="C44E52"/>
-          </a:solidFill>
-          <a:ln>
-            <a:solidFill>
-              <a:srgbClr val="C44E52"/>
-            </a:solidFill>
-          </a:ln>
-        </p:spPr>
-        <p:style>
-          <a:lnRef idx="1">
-            <a:schemeClr val="accent1"/>
-          </a:lnRef>
-          <a:fillRef idx="3">
-            <a:schemeClr val="accent1"/>
-          </a:fillRef>
-          <a:effectRef idx="2">
-            <a:schemeClr val="accent1"/>
-          </a:effectRef>
-          <a:fontRef idx="minor">
-            <a:schemeClr val="lt1"/>
-          </a:fontRef>
-        </p:style>
-        <p:txBody>
-          <a:bodyPr rtlCol="0" anchor="ctr"/>
-          <a:lstStyle/>
-          <a:p>
-            <a:pPr algn="ctr"/>
-          </a:p>
-        </p:txBody>
-      </p:sp>
-      <p:sp>
-        <p:nvSpPr>
-          <p:cNvPr id="61" name="TextBox 60"/>
-          <p:cNvSpPr txBox="1"/>
-          <p:nvPr/>
-        </p:nvSpPr>
-        <p:spPr>
-          <a:xfrm>
-            <a:off x="10607040" y="4416552"/>
-            <a:ext cx="1371600" cy="228600"/>
-          </a:xfrm>
-          <a:prstGeom prst="rect">
-            <a:avLst/>
-          </a:prstGeom>
-          <a:noFill/>
-        </p:spPr>
-        <p:txBody>
-          <a:bodyPr wrap="none">
-            <a:spAutoFit/>
-          </a:bodyPr>
-          <a:lstStyle/>
-          <a:p>
-            <a:pPr>
-              <a:defRPr sz="700">
-                <a:solidFill>
-                  <a:srgbClr val="C44E52"/>
-                </a:solidFill>
-              </a:defRPr>
-            </a:pPr>
-            <a:r>
-              <a:t>OR 2.68 [1.20–6.02] P=0.017*</a:t>
-            </a:r>
-          </a:p>
-        </p:txBody>
-      </p:sp>
-      <p:sp>
-        <p:nvSpPr>
-          <p:cNvPr id="62" name="TextBox 61"/>
-          <p:cNvSpPr txBox="1"/>
-          <p:nvPr/>
-        </p:nvSpPr>
-        <p:spPr>
-          <a:xfrm>
-            <a:off x="274320" y="4643120"/>
-            <a:ext cx="3200400" cy="274320"/>
-          </a:xfrm>
-          <a:prstGeom prst="rect">
-            <a:avLst/>
-          </a:prstGeom>
-          <a:noFill/>
-        </p:spPr>
-        <p:txBody>
-          <a:bodyPr wrap="square">
-            <a:spAutoFit/>
-          </a:bodyPr>
-          <a:lstStyle/>
-          <a:p>
-            <a:pPr algn="r">
-              <a:defRPr sz="800"/>
-            </a:pPr>
-            <a:r>
-              <a:t>Twin + GA (per week)</a:t>
-            </a:r>
-          </a:p>
-        </p:txBody>
-      </p:sp>
-      <p:sp>
-        <p:nvSpPr>
-          <p:cNvPr id="63" name="Rectangle 62"/>
-          <p:cNvSpPr/>
-          <p:nvPr/>
-        </p:nvSpPr>
-        <p:spPr>
-          <a:xfrm>
-            <a:off x="4394082" y="4761230"/>
-            <a:ext cx="3023628" cy="38100"/>
-          </a:xfrm>
-          <a:prstGeom prst="rect">
-            <a:avLst/>
-          </a:prstGeom>
-          <a:solidFill>
-            <a:srgbClr val="C44E52"/>
-          </a:solidFill>
-          <a:ln>
-            <a:noFill/>
-          </a:ln>
-        </p:spPr>
-        <p:style>
-          <a:lnRef idx="1">
-            <a:schemeClr val="accent1"/>
-          </a:lnRef>
-          <a:fillRef idx="3">
-            <a:schemeClr val="accent1"/>
-          </a:fillRef>
-          <a:effectRef idx="2">
-            <a:schemeClr val="accent1"/>
-          </a:effectRef>
-          <a:fontRef idx="minor">
-            <a:schemeClr val="lt1"/>
-          </a:fontRef>
-        </p:style>
-        <p:txBody>
-          <a:bodyPr rtlCol="0" anchor="ctr"/>
-          <a:lstStyle/>
-          <a:p>
-            <a:pPr algn="ctr"/>
-          </a:p>
-        </p:txBody>
-      </p:sp>
-      <p:sp>
-        <p:nvSpPr>
-          <p:cNvPr id="64" name="Diamond 63"/>
-          <p:cNvSpPr/>
-          <p:nvPr/>
-        </p:nvSpPr>
-        <p:spPr>
-          <a:xfrm>
-            <a:off x="5266843" y="4725416"/>
-            <a:ext cx="109728" cy="109728"/>
-          </a:xfrm>
-          <a:prstGeom prst="diamond">
-            <a:avLst/>
-          </a:prstGeom>
-          <a:solidFill>
-            <a:srgbClr val="C44E52"/>
-          </a:solidFill>
-          <a:ln>
-            <a:solidFill>
-              <a:srgbClr val="C44E52"/>
-            </a:solidFill>
-          </a:ln>
-        </p:spPr>
-        <p:style>
-          <a:lnRef idx="1">
-            <a:schemeClr val="accent1"/>
-          </a:lnRef>
-          <a:fillRef idx="3">
-            <a:schemeClr val="accent1"/>
-          </a:fillRef>
-          <a:effectRef idx="2">
-            <a:schemeClr val="accent1"/>
-          </a:effectRef>
-          <a:fontRef idx="minor">
-            <a:schemeClr val="lt1"/>
-          </a:fontRef>
-        </p:style>
-        <p:txBody>
-          <a:bodyPr rtlCol="0" anchor="ctr"/>
-          <a:lstStyle/>
-          <a:p>
-            <a:pPr algn="ctr"/>
-          </a:p>
-        </p:txBody>
-      </p:sp>
-      <p:sp>
-        <p:nvSpPr>
-          <p:cNvPr id="65" name="TextBox 64"/>
-          <p:cNvSpPr txBox="1"/>
-          <p:nvPr/>
-        </p:nvSpPr>
-        <p:spPr>
-          <a:xfrm>
-            <a:off x="10607040" y="4670552"/>
-            <a:ext cx="1371600" cy="228600"/>
-          </a:xfrm>
-          <a:prstGeom prst="rect">
-            <a:avLst/>
-          </a:prstGeom>
-          <a:noFill/>
-        </p:spPr>
-        <p:txBody>
-          <a:bodyPr wrap="none">
-            <a:spAutoFit/>
-          </a:bodyPr>
-          <a:lstStyle/>
-          <a:p>
-            <a:pPr>
-              <a:defRPr sz="700">
-                <a:solidFill>
-                  <a:srgbClr val="C44E52"/>
-                </a:solidFill>
-              </a:defRPr>
-            </a:pPr>
-            <a:r>
-              <a:t>OR 2.75 [1.22–6.22] P=0.015*</a:t>
-            </a:r>
-          </a:p>
-        </p:txBody>
-      </p:sp>
-      <p:sp>
-        <p:nvSpPr>
-          <p:cNvPr id="66" name="TextBox 65"/>
-          <p:cNvSpPr txBox="1"/>
-          <p:nvPr/>
-        </p:nvSpPr>
-        <p:spPr>
-          <a:xfrm>
-            <a:off x="274320" y="4897120"/>
-            <a:ext cx="3200400" cy="274320"/>
-          </a:xfrm>
-          <a:prstGeom prst="rect">
-            <a:avLst/>
-          </a:prstGeom>
-          <a:noFill/>
-        </p:spPr>
-        <p:txBody>
-          <a:bodyPr wrap="square">
-            <a:spAutoFit/>
-          </a:bodyPr>
-          <a:lstStyle/>
-          <a:p>
-            <a:pPr algn="r">
-              <a:defRPr sz="800"/>
-            </a:pPr>
-            <a:r>
-              <a:t>Twin + BMI (per kg/m²)</a:t>
-            </a:r>
-          </a:p>
-        </p:txBody>
-      </p:sp>
-      <p:sp>
-        <p:nvSpPr>
-          <p:cNvPr id="67" name="Rectangle 66"/>
-          <p:cNvSpPr/>
-          <p:nvPr/>
-        </p:nvSpPr>
-        <p:spPr>
-          <a:xfrm>
-            <a:off x="4392706" y="5015230"/>
-            <a:ext cx="2947730" cy="38100"/>
-          </a:xfrm>
-          <a:prstGeom prst="rect">
-            <a:avLst/>
-          </a:prstGeom>
-          <a:solidFill>
-            <a:srgbClr val="C44E52"/>
-          </a:solidFill>
-          <a:ln>
-            <a:noFill/>
-          </a:ln>
-        </p:spPr>
-        <p:style>
-          <a:lnRef idx="1">
-            <a:schemeClr val="accent1"/>
-          </a:lnRef>
-          <a:fillRef idx="3">
-            <a:schemeClr val="accent1"/>
-          </a:fillRef>
-          <a:effectRef idx="2">
-            <a:schemeClr val="accent1"/>
-          </a:effectRef>
-          <a:fontRef idx="minor">
-            <a:schemeClr val="lt1"/>
-          </a:fontRef>
-        </p:style>
-        <p:txBody>
-          <a:bodyPr rtlCol="0" anchor="ctr"/>
-          <a:lstStyle/>
-          <a:p>
-            <a:pPr algn="ctr"/>
-          </a:p>
-        </p:txBody>
-      </p:sp>
-      <p:sp>
-        <p:nvSpPr>
-          <p:cNvPr id="68" name="Diamond 67"/>
-          <p:cNvSpPr/>
-          <p:nvPr/>
-        </p:nvSpPr>
-        <p:spPr>
-          <a:xfrm>
-            <a:off x="5248116" y="4979416"/>
-            <a:ext cx="109728" cy="109728"/>
-          </a:xfrm>
-          <a:prstGeom prst="diamond">
-            <a:avLst/>
-          </a:prstGeom>
-          <a:solidFill>
-            <a:srgbClr val="C44E52"/>
-          </a:solidFill>
-          <a:ln>
-            <a:solidFill>
-              <a:srgbClr val="C44E52"/>
-            </a:solidFill>
-          </a:ln>
-        </p:spPr>
-        <p:style>
-          <a:lnRef idx="1">
-            <a:schemeClr val="accent1"/>
-          </a:lnRef>
-          <a:fillRef idx="3">
-            <a:schemeClr val="accent1"/>
-          </a:fillRef>
-          <a:effectRef idx="2">
-            <a:schemeClr val="accent1"/>
-          </a:effectRef>
-          <a:fontRef idx="minor">
-            <a:schemeClr val="lt1"/>
-          </a:fontRef>
-        </p:style>
-        <p:txBody>
-          <a:bodyPr rtlCol="0" anchor="ctr"/>
-          <a:lstStyle/>
-          <a:p>
-            <a:pPr algn="ctr"/>
-          </a:p>
-        </p:txBody>
-      </p:sp>
-      <p:sp>
-        <p:nvSpPr>
-          <p:cNvPr id="69" name="TextBox 68"/>
-          <p:cNvSpPr txBox="1"/>
-          <p:nvPr/>
-        </p:nvSpPr>
-        <p:spPr>
-          <a:xfrm>
-            <a:off x="10607040" y="4924552"/>
-            <a:ext cx="1371600" cy="228600"/>
-          </a:xfrm>
-          <a:prstGeom prst="rect">
-            <a:avLst/>
-          </a:prstGeom>
-          <a:noFill/>
-        </p:spPr>
-        <p:txBody>
-          <a:bodyPr wrap="none">
-            <a:spAutoFit/>
-          </a:bodyPr>
-          <a:lstStyle/>
-          <a:p>
-            <a:pPr>
-              <a:defRPr sz="700">
-                <a:solidFill>
-                  <a:srgbClr val="C44E52"/>
-                </a:solidFill>
-              </a:defRPr>
-            </a:pPr>
-            <a:r>
-              <a:t>OR 2.72 [1.22–6.09] P=0.015*</a:t>
-            </a:r>
-          </a:p>
-        </p:txBody>
-      </p:sp>
-      <p:sp>
-        <p:nvSpPr>
-          <p:cNvPr id="70" name="TextBox 69"/>
-          <p:cNvSpPr txBox="1"/>
-          <p:nvPr/>
-        </p:nvSpPr>
-        <p:spPr>
-          <a:xfrm>
-            <a:off x="274320" y="5151120"/>
-            <a:ext cx="3200400" cy="274320"/>
-          </a:xfrm>
-          <a:prstGeom prst="rect">
-            <a:avLst/>
-          </a:prstGeom>
-          <a:noFill/>
-        </p:spPr>
-        <p:txBody>
-          <a:bodyPr wrap="square">
-            <a:spAutoFit/>
-          </a:bodyPr>
-          <a:lstStyle/>
-          <a:p>
-            <a:pPr algn="r">
-              <a:defRPr sz="800"/>
-            </a:pPr>
-            <a:r>
-              <a:t>Twin + Age (per year)</a:t>
-            </a:r>
-          </a:p>
-        </p:txBody>
-      </p:sp>
-      <p:sp>
-        <p:nvSpPr>
-          <p:cNvPr id="71" name="Rectangle 70"/>
-          <p:cNvSpPr/>
-          <p:nvPr/>
-        </p:nvSpPr>
-        <p:spPr>
-          <a:xfrm>
-            <a:off x="4467809" y="5269230"/>
-            <a:ext cx="3321347" cy="38100"/>
-          </a:xfrm>
-          <a:prstGeom prst="rect">
-            <a:avLst/>
-          </a:prstGeom>
-          <a:solidFill>
-            <a:srgbClr val="C44E52"/>
-          </a:solidFill>
-          <a:ln>
-            <a:noFill/>
-          </a:ln>
-        </p:spPr>
-        <p:style>
-          <a:lnRef idx="1">
-            <a:schemeClr val="accent1"/>
-          </a:lnRef>
-          <a:fillRef idx="3">
-            <a:schemeClr val="accent1"/>
-          </a:fillRef>
-          <a:effectRef idx="2">
-            <a:schemeClr val="accent1"/>
-          </a:effectRef>
-          <a:fontRef idx="minor">
-            <a:schemeClr val="lt1"/>
-          </a:fontRef>
-        </p:style>
-        <p:txBody>
-          <a:bodyPr rtlCol="0" anchor="ctr"/>
-          <a:lstStyle/>
-          <a:p>
-            <a:pPr algn="ctr"/>
-          </a:p>
-        </p:txBody>
-      </p:sp>
-      <p:sp>
-        <p:nvSpPr>
-          <p:cNvPr id="72" name="Diamond 71"/>
-          <p:cNvSpPr/>
-          <p:nvPr/>
-        </p:nvSpPr>
-        <p:spPr>
-          <a:xfrm>
-            <a:off x="5432332" y="5233416"/>
-            <a:ext cx="109728" cy="109728"/>
-          </a:xfrm>
-          <a:prstGeom prst="diamond">
-            <a:avLst/>
-          </a:prstGeom>
-          <a:solidFill>
-            <a:srgbClr val="C44E52"/>
-          </a:solidFill>
-          <a:ln>
-            <a:solidFill>
-              <a:srgbClr val="C44E52"/>
-            </a:solidFill>
-          </a:ln>
-        </p:spPr>
-        <p:style>
-          <a:lnRef idx="1">
-            <a:schemeClr val="accent1"/>
-          </a:lnRef>
-          <a:fillRef idx="3">
-            <a:schemeClr val="accent1"/>
-          </a:fillRef>
-          <a:effectRef idx="2">
-            <a:schemeClr val="accent1"/>
-          </a:effectRef>
-          <a:fontRef idx="minor">
-            <a:schemeClr val="lt1"/>
-          </a:fontRef>
-        </p:style>
-        <p:txBody>
-          <a:bodyPr rtlCol="0" anchor="ctr"/>
-          <a:lstStyle/>
-          <a:p>
-            <a:pPr algn="ctr"/>
-          </a:p>
-        </p:txBody>
-      </p:sp>
-      <p:sp>
-        <p:nvSpPr>
-          <p:cNvPr id="73" name="TextBox 72"/>
-          <p:cNvSpPr txBox="1"/>
-          <p:nvPr/>
-        </p:nvSpPr>
-        <p:spPr>
-          <a:xfrm>
-            <a:off x="10607040" y="5178552"/>
-            <a:ext cx="1371600" cy="228600"/>
-          </a:xfrm>
-          <a:prstGeom prst="rect">
-            <a:avLst/>
-          </a:prstGeom>
-          <a:noFill/>
-        </p:spPr>
-        <p:txBody>
-          <a:bodyPr wrap="none">
-            <a:spAutoFit/>
-          </a:bodyPr>
-          <a:lstStyle/>
-          <a:p>
-            <a:pPr>
-              <a:defRPr sz="700">
-                <a:solidFill>
-                  <a:srgbClr val="C44E52"/>
-                </a:solidFill>
-              </a:defRPr>
-            </a:pPr>
-            <a:r>
-              <a:t>OR 3.03 [1.34–6.84] P=0.008**</a:t>
-            </a:r>
-          </a:p>
-        </p:txBody>
-      </p:sp>
-      <p:sp>
-        <p:nvSpPr>
-          <p:cNvPr id="74" name="TextBox 73"/>
-          <p:cNvSpPr txBox="1"/>
-          <p:nvPr/>
-        </p:nvSpPr>
-        <p:spPr>
-          <a:xfrm>
-            <a:off x="274320" y="5405120"/>
-            <a:ext cx="3200400" cy="274320"/>
-          </a:xfrm>
-          <a:prstGeom prst="rect">
-            <a:avLst/>
-          </a:prstGeom>
-          <a:noFill/>
-        </p:spPr>
-        <p:txBody>
-          <a:bodyPr wrap="square">
-            <a:spAutoFit/>
-          </a:bodyPr>
-          <a:lstStyle/>
-          <a:p>
-            <a:pPr algn="r">
-              <a:defRPr sz="800"/>
-            </a:pPr>
-            <a:r>
-              <a:t>Crude (twin only)</a:t>
-            </a:r>
-          </a:p>
-        </p:txBody>
-      </p:sp>
-      <p:sp>
-        <p:nvSpPr>
-          <p:cNvPr id="75" name="Rectangle 74"/>
-          <p:cNvSpPr/>
-          <p:nvPr/>
-        </p:nvSpPr>
-        <p:spPr>
-          <a:xfrm>
-            <a:off x="4388600" y="5523230"/>
-            <a:ext cx="2920057" cy="38100"/>
-          </a:xfrm>
-          <a:prstGeom prst="rect">
-            <a:avLst/>
-          </a:prstGeom>
-          <a:solidFill>
-            <a:srgbClr val="C44E52"/>
-          </a:solidFill>
-          <a:ln>
-            <a:noFill/>
-          </a:ln>
-        </p:spPr>
-        <p:style>
-          <a:lnRef idx="1">
-            <a:schemeClr val="accent1"/>
-          </a:lnRef>
-          <a:fillRef idx="3">
-            <a:schemeClr val="accent1"/>
-          </a:fillRef>
-          <a:effectRef idx="2">
-            <a:schemeClr val="accent1"/>
-          </a:effectRef>
-          <a:fontRef idx="minor">
-            <a:schemeClr val="lt1"/>
-          </a:fontRef>
-        </p:style>
-        <p:txBody>
-          <a:bodyPr rtlCol="0" anchor="ctr"/>
-          <a:lstStyle/>
-          <a:p>
-            <a:pPr algn="ctr"/>
-          </a:p>
-        </p:txBody>
-      </p:sp>
-      <p:sp>
-        <p:nvSpPr>
-          <p:cNvPr id="76" name="Diamond 75"/>
-          <p:cNvSpPr/>
-          <p:nvPr/>
-        </p:nvSpPr>
-        <p:spPr>
-          <a:xfrm>
-            <a:off x="5236420" y="5487416"/>
-            <a:ext cx="109728" cy="109728"/>
-          </a:xfrm>
-          <a:prstGeom prst="diamond">
-            <a:avLst/>
-          </a:prstGeom>
-          <a:solidFill>
-            <a:srgbClr val="C44E52"/>
-          </a:solidFill>
-          <a:ln>
-            <a:solidFill>
-              <a:srgbClr val="C44E52"/>
-            </a:solidFill>
-          </a:ln>
-        </p:spPr>
-        <p:style>
-          <a:lnRef idx="1">
-            <a:schemeClr val="accent1"/>
-          </a:lnRef>
-          <a:fillRef idx="3">
-            <a:schemeClr val="accent1"/>
-          </a:fillRef>
-          <a:effectRef idx="2">
-            <a:schemeClr val="accent1"/>
-          </a:effectRef>
-          <a:fontRef idx="minor">
-            <a:schemeClr val="lt1"/>
-          </a:fontRef>
-        </p:style>
-        <p:txBody>
-          <a:bodyPr rtlCol="0" anchor="ctr"/>
-          <a:lstStyle/>
-          <a:p>
-            <a:pPr algn="ctr"/>
-          </a:p>
-        </p:txBody>
-      </p:sp>
-      <p:sp>
-        <p:nvSpPr>
-          <p:cNvPr id="77" name="TextBox 76"/>
-          <p:cNvSpPr txBox="1"/>
-          <p:nvPr/>
-        </p:nvSpPr>
-        <p:spPr>
-          <a:xfrm>
-            <a:off x="10607040" y="5432552"/>
-            <a:ext cx="1371600" cy="228600"/>
-          </a:xfrm>
-          <a:prstGeom prst="rect">
-            <a:avLst/>
-          </a:prstGeom>
-          <a:noFill/>
-        </p:spPr>
-        <p:txBody>
-          <a:bodyPr wrap="none">
-            <a:spAutoFit/>
-          </a:bodyPr>
-          <a:lstStyle/>
-          <a:p>
-            <a:pPr>
-              <a:defRPr sz="700">
-                <a:solidFill>
-                  <a:srgbClr val="C44E52"/>
-                </a:solidFill>
-              </a:defRPr>
-            </a:pPr>
-            <a:r>
-              <a:t>OR 2.70 [1.21–6.04] P=0.015*</a:t>
-            </a:r>
-          </a:p>
-        </p:txBody>
-      </p:sp>
-      <p:sp>
-        <p:nvSpPr>
-          <p:cNvPr id="78" name="TextBox 77"/>
+              <a:t>OR 4.19 [1.04–16.83] P=0.043*</a:t>
+            </a:r>
+          </a:p>
+        </p:txBody>
+      </p:sp>
+      <p:sp>
+        <p:nvSpPr>
+          <p:cNvPr id="82" name="TextBox 81"/>
           <p:cNvSpPr txBox="1"/>
           <p:nvPr/>
         </p:nvSpPr>
@@ -11363,7 +11517,7 @@
                   <a:srgbClr val="000000"/>
                 </a:solidFill>
               </a:rPr>
-              <a:t>0.92</a:t>
+              <a:t>0.82</a:t>
             </a:r>
           </a:p>
         </p:txBody>
@@ -11416,7 +11570,7 @@
                   <a:srgbClr val="000000"/>
                 </a:solidFill>
               </a:rPr>
-              <a:t>0.67–1.27</a:t>
+              <a:t>0.31–2.15</a:t>
             </a:r>
           </a:p>
         </p:txBody>
@@ -11469,7 +11623,7 @@
                   <a:srgbClr val="000000"/>
                 </a:solidFill>
               </a:rPr>
-              <a:t>0.68–1.26</a:t>
+              <a:t>0.30–2.29</a:t>
             </a:r>
           </a:p>
         </p:txBody>
@@ -11673,7 +11827,7 @@
                   <a:srgbClr val="000000"/>
                 </a:solidFill>
               </a:rPr>
-              <a:t>0.82</a:t>
+              <a:t>0.92</a:t>
             </a:r>
           </a:p>
         </p:txBody>
@@ -11726,7 +11880,7 @@
                   <a:srgbClr val="000000"/>
                 </a:solidFill>
               </a:rPr>
-              <a:t>0.31–2.15</a:t>
+              <a:t>0.67–1.27</a:t>
             </a:r>
           </a:p>
         </p:txBody>
@@ -11779,7 +11933,7 @@
                   <a:srgbClr val="000000"/>
                 </a:solidFill>
               </a:rPr>
-              <a:t>0.30–2.29</a:t>
+              <a:t>0.68–1.26</a:t>
             </a:r>
           </a:p>
         </p:txBody>
@@ -11983,7 +12137,7 @@
                   <a:srgbClr val="000000"/>
                 </a:solidFill>
               </a:rPr>
-              <a:t>3.18</a:t>
+              <a:t>3.48</a:t>
             </a:r>
           </a:p>
         </p:txBody>
@@ -12036,7 +12190,7 @@
                   <a:srgbClr val="000000"/>
                 </a:solidFill>
               </a:rPr>
-              <a:t>1.38–7.36</a:t>
+              <a:t>0.81–15.06</a:t>
             </a:r>
           </a:p>
         </p:txBody>
@@ -12089,7 +12243,7 @@
                   <a:srgbClr val="000000"/>
                 </a:solidFill>
               </a:rPr>
-              <a:t>1.23–7.01</a:t>
+              <a:t>0.00–21.33</a:t>
             </a:r>
           </a:p>
         </p:txBody>
@@ -12142,7 +12296,7 @@
                   <a:srgbClr val="000000"/>
                 </a:solidFill>
               </a:rPr>
-              <a:t>100.0%</a:t>
+              <a:t>99.8%</a:t>
             </a:r>
           </a:p>
         </p:txBody>
@@ -12293,7 +12447,7 @@
                   <a:srgbClr val="000000"/>
                 </a:solidFill>
               </a:rPr>
-              <a:t>3.48</a:t>
+              <a:t>3.18</a:t>
             </a:r>
           </a:p>
         </p:txBody>
@@ -12346,7 +12500,7 @@
                   <a:srgbClr val="000000"/>
                 </a:solidFill>
               </a:rPr>
-              <a:t>0.81–15.06</a:t>
+              <a:t>1.38–7.36</a:t>
             </a:r>
           </a:p>
         </p:txBody>
@@ -12399,7 +12553,7 @@
                   <a:srgbClr val="000000"/>
                 </a:solidFill>
               </a:rPr>
-              <a:t>0.00–21.33</a:t>
+              <a:t>1.23–7.01</a:t>
             </a:r>
           </a:p>
         </p:txBody>
@@ -12452,7 +12606,7 @@
                   <a:srgbClr val="000000"/>
                 </a:solidFill>
               </a:rPr>
-              <a:t>99.8%</a:t>
+              <a:t>100.0%</a:t>
             </a:r>
           </a:p>
         </p:txBody>
@@ -12611,7 +12765,7 @@
                   <a:srgbClr val="000000"/>
                 </a:solidFill>
               </a:rPr>
-              <a:t>0.65</a:t>
+              <a:t>0.70</a:t>
             </a:r>
           </a:p>
         </p:txBody>
@@ -12664,7 +12818,7 @@
                   <a:srgbClr val="000000"/>
                 </a:solidFill>
               </a:rPr>
-              <a:t>0.40–1.06</a:t>
+              <a:t>0.22–2.26</a:t>
             </a:r>
           </a:p>
         </p:txBody>
@@ -12717,7 +12871,7 @@
                   <a:srgbClr val="000000"/>
                 </a:solidFill>
               </a:rPr>
-              <a:t>0.39–1.06</a:t>
+              <a:t>0.15–2.72</a:t>
             </a:r>
           </a:p>
         </p:txBody>
@@ -12921,7 +13075,7 @@
                   <a:srgbClr val="000000"/>
                 </a:solidFill>
               </a:rPr>
-              <a:t>0.70</a:t>
+              <a:t>0.60</a:t>
             </a:r>
           </a:p>
         </p:txBody>
@@ -12974,7 +13128,7 @@
                   <a:srgbClr val="000000"/>
                 </a:solidFill>
               </a:rPr>
-              <a:t>0.22–2.26</a:t>
+              <a:t>0.40–1.06</a:t>
             </a:r>
           </a:p>
         </p:txBody>
@@ -13027,7 +13181,7 @@
                   <a:srgbClr val="000000"/>
                 </a:solidFill>
               </a:rPr>
-              <a:t>0.15–2.72</a:t>
+              <a:t>0.36–0.98</a:t>
             </a:r>
           </a:p>
         </p:txBody>
@@ -13231,7 +13385,7 @@
                   <a:srgbClr val="000000"/>
                 </a:solidFill>
               </a:rPr>
-              <a:t>13.59</a:t>
+              <a:t>14.14</a:t>
             </a:r>
           </a:p>
         </p:txBody>
@@ -13284,7 +13438,7 @@
                   <a:srgbClr val="000000"/>
                 </a:solidFill>
               </a:rPr>
-              <a:t>1.74–106.04</a:t>
+              <a:t>0.72–277.39</a:t>
             </a:r>
           </a:p>
         </p:txBody>
@@ -13337,7 +13491,7 @@
                   <a:srgbClr val="000000"/>
                 </a:solidFill>
               </a:rPr>
-              <a:t>0.00–700136.92</a:t>
+              <a:t>Unstable</a:t>
             </a:r>
           </a:p>
         </p:txBody>
@@ -13390,7 +13544,7 @@
                   <a:srgbClr val="000000"/>
                 </a:solidFill>
               </a:rPr>
-              <a:t>99.8%</a:t>
+              <a:t>91.5%</a:t>
             </a:r>
           </a:p>
         </p:txBody>
@@ -13541,7 +13695,7 @@
                   <a:srgbClr val="000000"/>
                 </a:solidFill>
               </a:rPr>
-              <a:t>14.14</a:t>
+              <a:t>13.59</a:t>
             </a:r>
           </a:p>
         </p:txBody>
@@ -13594,7 +13748,7 @@
                   <a:srgbClr val="000000"/>
                 </a:solidFill>
               </a:rPr>
-              <a:t>0.72–277.39</a:t>
+              <a:t>1.74–106.04</a:t>
             </a:r>
           </a:p>
         </p:txBody>
@@ -13647,7 +13801,7 @@
                   <a:srgbClr val="000000"/>
                 </a:solidFill>
               </a:rPr>
-              <a:t>Unstable</a:t>
+              <a:t>0.00–700136.92</a:t>
             </a:r>
           </a:p>
         </p:txBody>
@@ -13700,7 +13854,7 @@
                   <a:srgbClr val="000000"/>
                 </a:solidFill>
               </a:rPr>
-              <a:t>91.5%</a:t>
+              <a:t>99.8%</a:t>
             </a:r>
           </a:p>
         </p:txBody>

</xml_diff>